<commit_message>
Update the developer deck: 579 reference checks and the KYC four-eyes pitfall
Ten suites in the reference-tests slide, thirteen deliberate faults, and
a new slide on the four-eyes bypass: what went wrong, the rule to
implement (every case handler excluded, recorded as it happens), and the
lesson for future four-eyes controls.

Co-Authored-By: Claude Opus 5.5 <noreply@anthropic.com>
Claude-Session: https://claude.ai/code/session_01ALCBMQrSwdEMnX9x1hQAFX
</commit_message>
<xml_diff>
--- a/outputs/recap/MIPS-vision-developpeurs.pptx
+++ b/outputs/recap/MIPS-vision-developpeurs.pptx
@@ -18,9 +18,10 @@
     <p:sldId id="266" r:id="rId12"/>
     <p:sldId id="267" r:id="rId13"/>
     <p:sldId id="268" r:id="rId14"/>
+    <p:sldId id="269" r:id="rId15"/>
   </p:sldIdLst>
   <p:notesMasterIdLst>
-    <p:notesMasterId r:id="rId15"/>
+    <p:notesMasterId r:id="rId16"/>
   </p:notesMasterIdLst>
   <p:sldSz cx="12192000" cy="6858000"/>
   <p:notesSz cx="6858000" cy="12192000"/>
@@ -119,13 +120,13 @@
   <p:extLst>
     <p:ext uri="{521415D9-36F7-43E2-AB2F-B90AF26B5E84}">
       <p14:sectionLst xmlns:p14="http://schemas.microsoft.com/office/powerpoint/2010/main">
-        <p14:section name="Cap" id="{beada207-9709-d361-e7e0-686d3d39fa49}">
+        <p14:section name="Cap" id="{e2f01589-7984-ac72-dbc7-31d09842a99a}">
           <p14:sldIdLst>
             <p14:sldId id="256"/>
             <p14:sldId id="257"/>
           </p14:sldIdLst>
         </p14:section>
-        <p14:section name="Architecture" id="{e307e348-62a0-4074-4fd2-556b6c7fbbdd}">
+        <p14:section name="Architecture" id="{10190852-a49c-09ce-98f3-17411f24427f}">
           <p14:sldIdLst>
             <p14:sldId id="258"/>
             <p14:sldId id="259"/>
@@ -133,23 +134,24 @@
             <p14:sldId id="261"/>
           </p14:sldIdLst>
         </p14:section>
-        <p14:section name="Parcours et données" id="{0769a5ba-57b9-992b-221d-4e66d1d850d2}">
+        <p14:section name="Parcours et données" id="{d38d4a7b-050e-8717-00b4-b861efbf95dd}">
           <p14:sldIdLst>
             <p14:sldId id="262"/>
             <p14:sldId id="263"/>
           </p14:sldIdLst>
         </p14:section>
-        <p14:section name="Tests et sécurité" id="{c147d14a-e46b-30b7-c232-281587177383}">
+        <p14:section name="Tests et sécurité" id="{e739e27a-27e0-b2f9-af9d-7dd8131af343}">
           <p14:sldIdLst>
             <p14:sldId id="264"/>
             <p14:sldId id="265"/>
+            <p14:sldId id="266"/>
           </p14:sldIdLst>
         </p14:section>
-        <p14:section name="Feuille de route" id="{3ecb7880-2ff9-acc9-a08a-dd43da69ce6f}">
+        <p14:section name="Feuille de route" id="{20ef6c49-3dbf-92c8-4d2d-b3f135feb0ce}">
           <p14:sldIdLst>
-            <p14:sldId id="266"/>
             <p14:sldId id="267"/>
             <p14:sldId id="268"/>
+            <p14:sldId id="269"/>
           </p14:sldIdLst>
         </p14:section>
       </p14:sectionLst>
@@ -732,7 +734,7 @@
           <a:p>
             <a:r>
               <a:rPr lang="en-US" dirty="0"/>
-              <a:t/>
+              <a:t>Correction dans la PR #10 (Kyc::hasHandled, onboarding_case_handlers). Sur une base existante, la table est remplie avec le créateur et l'analyste actuel de chaque dossier ; les réassignations passées ne peuvent pas être reconstituées.</a:t>
             </a:r>
             <a:endParaRPr lang="en-US" dirty="0"/>
           </a:p>
@@ -820,7 +822,7 @@
           <a:p>
             <a:r>
               <a:rPr lang="en-US" dirty="0"/>
-              <a:t>Les huit suites du prototype (478 vérifications, tests/ dans le dépôt) servent de base : chaque palier reprend les scénarios et les montants attendus de ses suites.</a:t>
+              <a:t/>
             </a:r>
             <a:endParaRPr lang="en-US" dirty="0"/>
           </a:p>
@@ -908,7 +910,7 @@
           <a:p>
             <a:r>
               <a:rPr lang="en-US" dirty="0"/>
-              <a:t/>
+              <a:t>Les dix suites du prototype (579 vérifications, tests/ dans le dépôt) servent de base : chaque palier reprend les scénarios et les montants attendus de ses suites.</a:t>
             </a:r>
             <a:endParaRPr lang="en-US" dirty="0"/>
           </a:p>
@@ -932,6 +934,94 @@
             <a:fld id="{F7021451-1387-4CA6-816F-3879F97B5CBC}" type="slidenum">
               <a:rPr lang="en-US"/>
               <a:t>13</a:t>
+            </a:fld>
+            <a:endParaRPr lang="en-US"/>
+          </a:p>
+        </p:txBody>
+      </p:sp>
+    </p:spTree>
+    <p:extLst>
+      <p:ext uri="{BB962C8B-B14F-4D97-AF65-F5344CB8AC3E}">
+        <p14:creationId xmlns:p14="http://schemas.microsoft.com/office/powerpoint/2010/main" val="1024086991"/>
+      </p:ext>
+    </p:extLst>
+  </p:cSld>
+  <p:clrMapOvr>
+    <a:masterClrMapping/>
+  </p:clrMapOvr>
+</p:notes>
+</file>
+
+<file path=ppt/notesSlides/notesSlide14.xml><?xml version="1.0" encoding="utf-8"?>
+<p:notes xmlns:a="http://schemas.openxmlformats.org/drawingml/2006/main" xmlns:r="http://schemas.openxmlformats.org/officeDocument/2006/relationships" xmlns:p="http://schemas.openxmlformats.org/presentationml/2006/main">
+  <p:cSld>
+    <p:spTree>
+      <p:nvGrpSpPr>
+        <p:cNvPr id="1" name=""/>
+        <p:cNvGrpSpPr/>
+        <p:nvPr/>
+      </p:nvGrpSpPr>
+      <p:grpSpPr>
+        <a:xfrm>
+          <a:off x="0" y="0"/>
+          <a:ext cx="0" cy="0"/>
+          <a:chOff x="0" y="0"/>
+          <a:chExt cx="0" cy="0"/>
+        </a:xfrm>
+      </p:grpSpPr>
+      <p:sp>
+        <p:nvSpPr>
+          <p:cNvPr id="2" name="Slide Image Placeholder 1"/>
+          <p:cNvSpPr>
+            <a:spLocks noGrp="1" noRot="1" noChangeAspect="1"/>
+          </p:cNvSpPr>
+          <p:nvPr>
+            <p:ph type="sldImg"/>
+          </p:nvPr>
+        </p:nvSpPr>
+        <p:spPr/>
+      </p:sp>
+      <p:sp>
+        <p:nvSpPr>
+          <p:cNvPr id="3" name="Notes Placeholder 2"/>
+          <p:cNvSpPr>
+            <a:spLocks noGrp="1"/>
+          </p:cNvSpPr>
+          <p:nvPr>
+            <p:ph type="body" idx="1"/>
+          </p:nvPr>
+        </p:nvSpPr>
+        <p:spPr/>
+        <p:txBody>
+          <a:bodyPr/>
+          <a:lstStyle/>
+          <a:p>
+            <a:r>
+              <a:rPr lang="en-US" dirty="0"/>
+              <a:t/>
+            </a:r>
+            <a:endParaRPr lang="en-US" dirty="0"/>
+          </a:p>
+        </p:txBody>
+      </p:sp>
+      <p:sp>
+        <p:nvSpPr>
+          <p:cNvPr id="4" name="Slide Number Placeholder 3"/>
+          <p:cNvSpPr>
+            <a:spLocks noGrp="1"/>
+          </p:cNvSpPr>
+          <p:nvPr>
+            <p:ph type="sldNum" sz="quarter" idx="10"/>
+          </p:nvPr>
+        </p:nvSpPr>
+        <p:spPr/>
+        <p:txBody>
+          <a:bodyPr/>
+          <a:lstStyle/>
+          <a:p>
+            <a:fld id="{F7021451-1387-4CA6-816F-3879F97B5CBC}" type="slidenum">
+              <a:rPr lang="en-US"/>
+              <a:t>14</a:t>
             </a:fld>
             <a:endParaRPr lang="en-US"/>
           </a:p>
@@ -1612,7 +1702,7 @@
           <a:p>
             <a:r>
               <a:rPr lang="en-US" dirty="0"/>
-              <a:t>Les tests prouvent que le code applique les règles figées, pas que ces règles sont les bonnes : unité de somme_totale, remboursements et TVA restent à confirmer par la finance. La règle « 2FA obligatoire pour admin et finance » n'est pas couverte : la configuration de test la désactive.</a:t>
+              <a:t>Les tests prouvent que le code applique les règles figées, pas que ces règles sont les bonnes : unité de somme_totale, remboursements et TVA restent à confirmer par la finance. staff_2fa_required_test.py active la règle « 2FA obligatoire pour admin et finance » le temps de la suite (désactivée ailleurs pour que les autres suites se connectent par mot de passe).</a:t>
             </a:r>
             <a:endParaRPr lang="en-US" dirty="0"/>
           </a:p>
@@ -3041,7 +3131,7 @@
                   <a:schemeClr val="tx1"/>
                 </a:solidFill>
               </a:rPr>
-              <a:t>Feuille de route proposée, par paliers</a:t>
+              <a:t>Troisième piège : un double regard qu'on pouvait contourner</a:t>
             </a:r>
             <a:endParaRPr lang="en-US" sz="3000" dirty="0"/>
           </a:p>
@@ -3049,28 +3139,249 @@
       </p:sp>
       <p:sp>
         <p:nvSpPr>
-          <p:cNvPr id="3" name="ph0"/>
+          <p:cNvPr id="3" name="Text 1"/>
+          <p:cNvSpPr txBox="1"/>
+          <p:nvPr/>
+        </p:nvSpPr>
+        <p:spPr>
+          <a:xfrm>
+            <a:off x="457200" y="1188720"/>
+            <a:ext cx="5486400" cy="411480"/>
+          </a:xfrm>
+          <a:prstGeom prst="rect">
+            <a:avLst/>
+          </a:prstGeom>
+          <a:noFill/>
+          <a:ln/>
+        </p:spPr>
+        <p:txBody>
+          <a:bodyPr wrap="square" lIns="0" tIns="0" rIns="0" bIns="0" rtlCol="0" anchor="t"/>
+          <a:lstStyle/>
+          <a:p>
+            <a:pPr algn="l" indent="0" marL="0">
+              <a:buNone/>
+            </a:pPr>
+            <a:r>
+              <a:rPr lang="en-US" sz="1800" b="1" dirty="0">
+                <a:solidFill>
+                  <a:schemeClr val="accent6"/>
+                </a:solidFill>
+                <a:latin typeface="Cambria" pitchFamily="34" charset="0"/>
+                <a:ea typeface="Cambria" pitchFamily="34" charset="-122"/>
+                <a:cs typeface="Cambria" pitchFamily="34" charset="-120"/>
+              </a:rPr>
+              <a:t>Avant</a:t>
+            </a:r>
+            <a:endParaRPr lang="en-US" sz="1800" dirty="0"/>
+          </a:p>
+        </p:txBody>
+      </p:sp>
+      <p:sp>
+        <p:nvSpPr>
+          <p:cNvPr id="4" name="Text 2"/>
+          <p:cNvSpPr txBox="1"/>
+          <p:nvPr/>
+        </p:nvSpPr>
+        <p:spPr>
+          <a:xfrm>
+            <a:off x="457200" y="1691640"/>
+            <a:ext cx="5486400" cy="2103120"/>
+          </a:xfrm>
+          <a:prstGeom prst="rect">
+            <a:avLst/>
+          </a:prstGeom>
+          <a:noFill/>
+          <a:ln/>
+        </p:spPr>
+        <p:txBody>
+          <a:bodyPr wrap="square" lIns="635" tIns="635" rIns="635" bIns="635" rtlCol="0" anchor="t"/>
+          <a:lstStyle/>
+          <a:p>
+            <a:pPr marL="342900" indent="-342900">
+              <a:spcAft>
+                <a:spcPts val="600"/>
+              </a:spcAft>
+              <a:buSzPct val="100000"/>
+              <a:buChar char="•"/>
+            </a:pPr>
+            <a:r>
+              <a:rPr lang="en-US" sz="1300" dirty="0">
+                <a:solidFill>
+                  <a:schemeClr val="tx1"/>
+                </a:solidFill>
+              </a:rPr>
+              <a:t>Le contrôle comparait l'approbateur à l'analyste du moment seulement</a:t>
+            </a:r>
+            <a:endParaRPr lang="en-US" sz="1300" dirty="0"/>
+          </a:p>
+          <a:p>
+            <a:pPr marL="342900" indent="-342900">
+              <a:spcAft>
+                <a:spcPts val="600"/>
+              </a:spcAft>
+              <a:buSzPct val="100000"/>
+              <a:buChar char="•"/>
+            </a:pPr>
+            <a:r>
+              <a:rPr lang="en-US" sz="1300" dirty="0">
+                <a:solidFill>
+                  <a:schemeClr val="tx1"/>
+                </a:solidFill>
+              </a:rPr>
+              <a:t>Un analyste ayant le rôle d'approbateur réassignait le dossier à un collègue, puis l'approuvait ou le rejetait lui-même</a:t>
+            </a:r>
+            <a:endParaRPr lang="en-US" sz="1300" dirty="0"/>
+          </a:p>
+          <a:p>
+            <a:pPr marL="342900" indent="-342900">
+              <a:spcAft>
+                <a:spcPts val="600"/>
+              </a:spcAft>
+              <a:buSzPct val="100000"/>
+              <a:buChar char="•"/>
+            </a:pPr>
+            <a:r>
+              <a:rPr lang="en-US" sz="1300" dirty="0">
+                <a:solidFill>
+                  <a:schemeClr val="tx1"/>
+                </a:solidFill>
+              </a:rPr>
+              <a:t>Trouvé par onboarding_approval_test.py, pas par la relecture du code</a:t>
+            </a:r>
+            <a:endParaRPr lang="en-US" sz="1300" dirty="0"/>
+          </a:p>
+        </p:txBody>
+      </p:sp>
+      <p:sp>
+        <p:nvSpPr>
+          <p:cNvPr id="5" name="Text 3"/>
+          <p:cNvSpPr txBox="1"/>
+          <p:nvPr/>
+        </p:nvSpPr>
+        <p:spPr>
+          <a:xfrm>
+            <a:off x="457200" y="3611880"/>
+            <a:ext cx="5486400" cy="365760"/>
+          </a:xfrm>
+          <a:prstGeom prst="rect">
+            <a:avLst/>
+          </a:prstGeom>
+          <a:noFill/>
+          <a:ln/>
+        </p:spPr>
+        <p:txBody>
+          <a:bodyPr wrap="square" lIns="0" tIns="0" rIns="0" bIns="0" rtlCol="0" anchor="t"/>
+          <a:lstStyle/>
+          <a:p>
+            <a:pPr algn="l" indent="0" marL="0">
+              <a:buNone/>
+            </a:pPr>
+            <a:r>
+              <a:rPr lang="en-US" sz="1500" b="1" dirty="0">
+                <a:solidFill>
+                  <a:schemeClr val="accent4"/>
+                </a:solidFill>
+              </a:rPr>
+              <a:t>Règle à implémenter</a:t>
+            </a:r>
+            <a:endParaRPr lang="en-US" sz="1500" dirty="0"/>
+          </a:p>
+        </p:txBody>
+      </p:sp>
+      <p:sp>
+        <p:nvSpPr>
+          <p:cNvPr id="6" name="Text 4"/>
+          <p:cNvSpPr txBox="1"/>
+          <p:nvPr/>
+        </p:nvSpPr>
+        <p:spPr>
+          <a:xfrm>
+            <a:off x="457200" y="4023360"/>
+            <a:ext cx="5486400" cy="1920240"/>
+          </a:xfrm>
+          <a:prstGeom prst="rect">
+            <a:avLst/>
+          </a:prstGeom>
+          <a:noFill/>
+          <a:ln/>
+        </p:spPr>
+        <p:txBody>
+          <a:bodyPr wrap="square" lIns="635" tIns="635" rIns="635" bIns="635" rtlCol="0" anchor="t"/>
+          <a:lstStyle/>
+          <a:p>
+            <a:pPr marL="342900" indent="-342900">
+              <a:spcAft>
+                <a:spcPts val="600"/>
+              </a:spcAft>
+              <a:buSzPct val="100000"/>
+              <a:buChar char="•"/>
+            </a:pPr>
+            <a:r>
+              <a:rPr lang="en-US" sz="1300" dirty="0">
+                <a:solidFill>
+                  <a:schemeClr val="tx1"/>
+                </a:solidFill>
+              </a:rPr>
+              <a:t>Ne peut pas trancher : le créateur du dossier, tout analyste qui en a été chargé, quiconque a changé l'attribution</a:t>
+            </a:r>
+            <a:endParaRPr lang="en-US" sz="1300" dirty="0"/>
+          </a:p>
+          <a:p>
+            <a:pPr marL="342900" indent="-342900">
+              <a:spcAft>
+                <a:spcPts val="600"/>
+              </a:spcAft>
+              <a:buSzPct val="100000"/>
+              <a:buChar char="•"/>
+            </a:pPr>
+            <a:r>
+              <a:rPr lang="en-US" sz="1300" dirty="0">
+                <a:solidFill>
+                  <a:schemeClr val="tx1"/>
+                </a:solidFill>
+              </a:rPr>
+              <a:t>Ces personnes sont enregistrées au fil de l'eau (table onboarding_case_handlers), jamais déduites de l'état courant</a:t>
+            </a:r>
+            <a:endParaRPr lang="en-US" sz="1300" dirty="0"/>
+          </a:p>
+          <a:p>
+            <a:pPr marL="342900" indent="-342900">
+              <a:spcAft>
+                <a:spcPts val="600"/>
+              </a:spcAft>
+              <a:buSzPct val="100000"/>
+              <a:buChar char="•"/>
+            </a:pPr>
+            <a:r>
+              <a:rPr lang="en-US" sz="1300" dirty="0">
+                <a:solidFill>
+                  <a:schemeClr val="tx1"/>
+                </a:solidFill>
+              </a:rPr>
+              <a:t>Même règle pour l'approbation et pour le rejet</a:t>
+            </a:r>
+            <a:endParaRPr lang="en-US" sz="1300" dirty="0"/>
+          </a:p>
+        </p:txBody>
+      </p:sp>
+      <p:sp>
+        <p:nvSpPr>
+          <p:cNvPr id="7" name="Shape 5"/>
           <p:cNvSpPr/>
           <p:nvPr/>
         </p:nvSpPr>
         <p:spPr>
           <a:xfrm>
-            <a:off x="457200" y="1463040"/>
-            <a:ext cx="1481328" cy="3566160"/>
-          </a:xfrm>
-          <a:prstGeom prst="roundRect">
-            <a:avLst>
-              <a:gd name="adj" fmla="val 4938"/>
-            </a:avLst>
-          </a:prstGeom>
-          <a:solidFill>
-            <a:schemeClr val="accent6">
-              <a:alpha val="12000"/>
-            </a:schemeClr>
-          </a:solidFill>
-          <a:ln w="9525">
+            <a:off x="6172200" y="1234440"/>
+            <a:ext cx="0" cy="4754880"/>
+          </a:xfrm>
+          <a:prstGeom prst="line">
+            <a:avLst/>
+          </a:prstGeom>
+          <a:noFill/>
+          <a:ln w="12700">
             <a:solidFill>
-              <a:schemeClr val="accent6"/>
+              <a:srgbClr val="D5DDE7"/>
             </a:solidFill>
             <a:prstDash val="solid"/>
           </a:ln>
@@ -3078,14 +3389,14 @@
       </p:sp>
       <p:sp>
         <p:nvSpPr>
-          <p:cNvPr id="4" name="Text 2"/>
+          <p:cNvPr id="8" name="Text 6"/>
           <p:cNvSpPr txBox="1"/>
           <p:nvPr/>
         </p:nvSpPr>
         <p:spPr>
           <a:xfrm>
-            <a:off x="548640" y="1554480"/>
-            <a:ext cx="1280160" cy="640080"/>
+            <a:off x="6400800" y="1188720"/>
+            <a:ext cx="5303520" cy="411480"/>
           </a:xfrm>
           <a:prstGeom prst="rect">
             <a:avLst/>
@@ -3094,164 +3405,24 @@
           <a:ln/>
         </p:spPr>
         <p:txBody>
-          <a:bodyPr wrap="square" lIns="1016" tIns="1016" rIns="1016" bIns="1016" rtlCol="0" anchor="t"/>
+          <a:bodyPr wrap="square" lIns="0" tIns="0" rIns="0" bIns="0" rtlCol="0" anchor="t"/>
           <a:lstStyle/>
           <a:p>
             <a:pPr algn="l" indent="0" marL="0">
               <a:buNone/>
             </a:pPr>
             <a:r>
-              <a:rPr lang="en-US" sz="3400" b="1" dirty="0">
-                <a:solidFill>
-                  <a:schemeClr val="accent6"/>
+              <a:rPr lang="en-US" sz="1800" b="1" dirty="0">
+                <a:solidFill>
+                  <a:schemeClr val="accent1"/>
                 </a:solidFill>
                 <a:latin typeface="Cambria" pitchFamily="34" charset="0"/>
                 <a:ea typeface="Cambria" pitchFamily="34" charset="-122"/>
                 <a:cs typeface="Cambria" pitchFamily="34" charset="-120"/>
               </a:rPr>
-              <a:t>0</a:t>
-            </a:r>
-            <a:endParaRPr lang="en-US" sz="3400" dirty="0"/>
-          </a:p>
-        </p:txBody>
-      </p:sp>
-      <p:sp>
-        <p:nvSpPr>
-          <p:cNvPr id="5" name="Text 3"/>
-          <p:cNvSpPr txBox="1"/>
-          <p:nvPr/>
-        </p:nvSpPr>
-        <p:spPr>
-          <a:xfrm>
-            <a:off x="548640" y="2240280"/>
-            <a:ext cx="1325880" cy="822960"/>
-          </a:xfrm>
-          <a:prstGeom prst="rect">
-            <a:avLst/>
-          </a:prstGeom>
-          <a:noFill/>
-          <a:ln/>
-        </p:spPr>
-        <p:txBody>
-          <a:bodyPr wrap="square" lIns="1016" tIns="1016" rIns="1016" bIns="1016" rtlCol="0" anchor="t"/>
-          <a:lstStyle/>
-          <a:p>
-            <a:pPr algn="l" indent="0" marL="0">
-              <a:buNone/>
-            </a:pPr>
-            <a:r>
-              <a:rPr lang="en-US" sz="1400" b="1" dirty="0">
-                <a:solidFill>
-                  <a:schemeClr val="tx1"/>
-                </a:solidFill>
-              </a:rPr>
-              <a:t>Décisions</a:t>
-            </a:r>
-            <a:endParaRPr lang="en-US" sz="1400" dirty="0"/>
-          </a:p>
-        </p:txBody>
-      </p:sp>
-      <p:sp>
-        <p:nvSpPr>
-          <p:cNvPr id="6" name="Text 4"/>
-          <p:cNvSpPr txBox="1"/>
-          <p:nvPr/>
-        </p:nvSpPr>
-        <p:spPr>
-          <a:xfrm>
-            <a:off x="548640" y="3063240"/>
-            <a:ext cx="1325880" cy="1874520"/>
-          </a:xfrm>
-          <a:prstGeom prst="rect">
-            <a:avLst/>
-          </a:prstGeom>
-          <a:noFill/>
-          <a:ln/>
-        </p:spPr>
-        <p:txBody>
-          <a:bodyPr wrap="square" lIns="1016" tIns="1016" rIns="1016" bIns="1016" rtlCol="0" anchor="t"/>
-          <a:lstStyle/>
-          <a:p>
-            <a:pPr algn="l" indent="0" marL="0">
-              <a:buNone/>
-            </a:pPr>
-            <a:r>
-              <a:rPr lang="en-US" sz="1200" dirty="0">
-                <a:solidFill>
-                  <a:schemeClr val="tx1"/>
-                </a:solidFill>
-              </a:rPr>
-              <a:t>Modèle A ou B · textes BoM · seuils KYC · texte des CGU</a:t>
-            </a:r>
-            <a:endParaRPr lang="en-US" sz="1200" dirty="0"/>
-          </a:p>
-        </p:txBody>
-      </p:sp>
-      <p:sp>
-        <p:nvSpPr>
-          <p:cNvPr id="7" name="ph1"/>
-          <p:cNvSpPr/>
-          <p:nvPr/>
-        </p:nvSpPr>
-        <p:spPr>
-          <a:xfrm>
-            <a:off x="2075688" y="1463040"/>
-            <a:ext cx="1481328" cy="3566160"/>
-          </a:xfrm>
-          <a:prstGeom prst="roundRect">
-            <a:avLst>
-              <a:gd name="adj" fmla="val 4938"/>
-            </a:avLst>
-          </a:prstGeom>
-          <a:solidFill>
-            <a:schemeClr val="accent2">
-              <a:alpha val="12000"/>
-            </a:schemeClr>
-          </a:solidFill>
-          <a:ln w="9525">
-            <a:solidFill>
-              <a:schemeClr val="accent2"/>
-            </a:solidFill>
-            <a:prstDash val="solid"/>
-          </a:ln>
-        </p:spPr>
-      </p:sp>
-      <p:sp>
-        <p:nvSpPr>
-          <p:cNvPr id="8" name="Text 6"/>
-          <p:cNvSpPr txBox="1"/>
-          <p:nvPr/>
-        </p:nvSpPr>
-        <p:spPr>
-          <a:xfrm>
-            <a:off x="2167128" y="1554480"/>
-            <a:ext cx="1280160" cy="640080"/>
-          </a:xfrm>
-          <a:prstGeom prst="rect">
-            <a:avLst/>
-          </a:prstGeom>
-          <a:noFill/>
-          <a:ln/>
-        </p:spPr>
-        <p:txBody>
-          <a:bodyPr wrap="square" lIns="1016" tIns="1016" rIns="1016" bIns="1016" rtlCol="0" anchor="t"/>
-          <a:lstStyle/>
-          <a:p>
-            <a:pPr algn="l" indent="0" marL="0">
-              <a:buNone/>
-            </a:pPr>
-            <a:r>
-              <a:rPr lang="en-US" sz="3400" b="1" dirty="0">
-                <a:solidFill>
-                  <a:schemeClr val="accent2"/>
-                </a:solidFill>
-                <a:latin typeface="Cambria" pitchFamily="34" charset="0"/>
-                <a:ea typeface="Cambria" pitchFamily="34" charset="-122"/>
-                <a:cs typeface="Cambria" pitchFamily="34" charset="-120"/>
-              </a:rPr>
-              <a:t>1</a:t>
-            </a:r>
-            <a:endParaRPr lang="en-US" sz="3400" dirty="0"/>
+              <a:t>Leçon pour tous les contrôles à quatre yeux</a:t>
+            </a:r>
+            <a:endParaRPr lang="en-US" sz="1800" dirty="0"/>
           </a:p>
         </p:txBody>
       </p:sp>
@@ -3263,8 +3434,8 @@
         </p:nvSpPr>
         <p:spPr>
           <a:xfrm>
-            <a:off x="2167128" y="2240280"/>
-            <a:ext cx="1325880" cy="822960"/>
+            <a:off x="6400800" y="1691640"/>
+            <a:ext cx="5303520" cy="2103120"/>
           </a:xfrm>
           <a:prstGeom prst="rect">
             <a:avLst/>
@@ -3273,21 +3444,61 @@
           <a:ln/>
         </p:spPr>
         <p:txBody>
-          <a:bodyPr wrap="square" lIns="1016" tIns="1016" rIns="1016" bIns="1016" rtlCol="0" anchor="t"/>
-          <a:lstStyle/>
-          <a:p>
-            <a:pPr algn="l" indent="0" marL="0">
-              <a:buNone/>
-            </a:pPr>
-            <a:r>
-              <a:rPr lang="en-US" sz="1400" b="1" dirty="0">
+          <a:bodyPr wrap="square" lIns="635" tIns="635" rIns="635" bIns="635" rtlCol="0" anchor="t"/>
+          <a:lstStyle/>
+          <a:p>
+            <a:pPr marL="342900" indent="-342900">
+              <a:spcAft>
+                <a:spcPts val="600"/>
+              </a:spcAft>
+              <a:buSzPct val="100000"/>
+              <a:buChar char="•"/>
+            </a:pPr>
+            <a:r>
+              <a:rPr lang="en-US" sz="1300" dirty="0">
                 <a:solidFill>
                   <a:schemeClr val="tx1"/>
                 </a:solidFill>
               </a:rPr>
-              <a:t>Socle</a:t>
-            </a:r>
-            <a:endParaRPr lang="en-US" sz="1400" dirty="0"/>
+              <a:t>Un double regard se vérifie sur l'historique des intervenants, pas sur un seul champ modifiable</a:t>
+            </a:r>
+            <a:endParaRPr lang="en-US" sz="1300" dirty="0"/>
+          </a:p>
+          <a:p>
+            <a:pPr marL="342900" indent="-342900">
+              <a:spcAft>
+                <a:spcPts val="600"/>
+              </a:spcAft>
+              <a:buSzPct val="100000"/>
+              <a:buChar char="•"/>
+            </a:pPr>
+            <a:r>
+              <a:rPr lang="en-US" sz="1300" dirty="0">
+                <a:solidFill>
+                  <a:schemeClr val="tx1"/>
+                </a:solidFill>
+              </a:rPr>
+              <a:t>Tester le contournement, pas seulement le cas nominal : réassigner, créer, puis décider</a:t>
+            </a:r>
+            <a:endParaRPr lang="en-US" sz="1300" dirty="0"/>
+          </a:p>
+          <a:p>
+            <a:pPr marL="342900" indent="-342900">
+              <a:spcAft>
+                <a:spcPts val="600"/>
+              </a:spcAft>
+              <a:buSzPct val="100000"/>
+              <a:buChar char="•"/>
+            </a:pPr>
+            <a:r>
+              <a:rPr lang="en-US" sz="1300" dirty="0">
+                <a:solidFill>
+                  <a:schemeClr val="tx1"/>
+                </a:solidFill>
+              </a:rPr>
+              <a:t>À appliquer aux futurs contrôles : facturation, rapprochement, reversements du trust</a:t>
+            </a:r>
+            <a:endParaRPr lang="en-US" sz="1300" dirty="0"/>
           </a:p>
         </p:txBody>
       </p:sp>
@@ -3299,8 +3510,8 @@
         </p:nvSpPr>
         <p:spPr>
           <a:xfrm>
-            <a:off x="2167128" y="3063240"/>
-            <a:ext cx="1325880" cy="1874520"/>
+            <a:off x="6400800" y="3611880"/>
+            <a:ext cx="5303520" cy="365760"/>
           </a:xfrm>
           <a:prstGeom prst="rect">
             <a:avLst/>
@@ -3309,757 +3520,79 @@
           <a:ln/>
         </p:spPr>
         <p:txBody>
-          <a:bodyPr wrap="square" lIns="1016" tIns="1016" rIns="1016" bIns="1016" rtlCol="0" anchor="t"/>
+          <a:bodyPr wrap="square" lIns="0" tIns="0" rIns="0" bIns="0" rtlCol="0" anchor="t"/>
           <a:lstStyle/>
           <a:p>
             <a:pPr algn="l" indent="0" marL="0">
               <a:buNone/>
             </a:pPr>
             <a:r>
-              <a:rPr lang="en-US" sz="1200" dirty="0">
+              <a:rPr lang="en-US" sz="1500" b="1" dirty="0">
+                <a:solidFill>
+                  <a:schemeClr val="accent5"/>
+                </a:solidFill>
+              </a:rPr>
+              <a:t>Conséquence d'organisation</a:t>
+            </a:r>
+            <a:endParaRPr lang="en-US" sz="1500" dirty="0"/>
+          </a:p>
+        </p:txBody>
+      </p:sp>
+      <p:sp>
+        <p:nvSpPr>
+          <p:cNvPr id="11" name="Text 9"/>
+          <p:cNvSpPr txBox="1"/>
+          <p:nvPr/>
+        </p:nvSpPr>
+        <p:spPr>
+          <a:xfrm>
+            <a:off x="6400800" y="4023360"/>
+            <a:ext cx="5303520" cy="1920240"/>
+          </a:xfrm>
+          <a:prstGeom prst="rect">
+            <a:avLst/>
+          </a:prstGeom>
+          <a:noFill/>
+          <a:ln/>
+        </p:spPr>
+        <p:txBody>
+          <a:bodyPr wrap="square" lIns="635" tIns="635" rIns="635" bIns="635" rtlCol="0" anchor="t"/>
+          <a:lstStyle/>
+          <a:p>
+            <a:pPr marL="342900" indent="-342900">
+              <a:spcAft>
+                <a:spcPts val="600"/>
+              </a:spcAft>
+              <a:buSzPct val="100000"/>
+              <a:buChar char="•"/>
+            </a:pPr>
+            <a:r>
+              <a:rPr lang="en-US" sz="1300" dirty="0">
                 <a:solidFill>
                   <a:schemeClr val="tx1"/>
                 </a:solidFill>
               </a:rPr>
-              <a:t>Auth, 2FA, rôles, audit, sessions séparées</a:t>
-            </a:r>
-            <a:endParaRPr lang="en-US" sz="1200" dirty="0"/>
-          </a:p>
-        </p:txBody>
-      </p:sp>
-      <p:sp>
-        <p:nvSpPr>
-          <p:cNvPr id="11" name="ph2"/>
-          <p:cNvSpPr/>
-          <p:nvPr/>
-        </p:nvSpPr>
-        <p:spPr>
-          <a:xfrm>
-            <a:off x="3694176" y="1463040"/>
-            <a:ext cx="1481328" cy="3566160"/>
-          </a:xfrm>
-          <a:prstGeom prst="roundRect">
-            <a:avLst>
-              <a:gd name="adj" fmla="val 4938"/>
-            </a:avLst>
-          </a:prstGeom>
-          <a:solidFill>
-            <a:schemeClr val="accent2">
-              <a:alpha val="12000"/>
-            </a:schemeClr>
-          </a:solidFill>
-          <a:ln w="9525">
-            <a:solidFill>
-              <a:schemeClr val="accent2"/>
-            </a:solidFill>
-            <a:prstDash val="solid"/>
-          </a:ln>
-        </p:spPr>
-      </p:sp>
-      <p:sp>
-        <p:nvSpPr>
-          <p:cNvPr id="12" name="Text 10"/>
-          <p:cNvSpPr txBox="1"/>
-          <p:nvPr/>
-        </p:nvSpPr>
-        <p:spPr>
-          <a:xfrm>
-            <a:off x="3785616" y="1554480"/>
-            <a:ext cx="1280160" cy="640080"/>
-          </a:xfrm>
-          <a:prstGeom prst="rect">
-            <a:avLst/>
-          </a:prstGeom>
-          <a:noFill/>
-          <a:ln/>
-        </p:spPr>
-        <p:txBody>
-          <a:bodyPr wrap="square" lIns="1016" tIns="1016" rIns="1016" bIns="1016" rtlCol="0" anchor="t"/>
-          <a:lstStyle/>
-          <a:p>
-            <a:pPr algn="l" indent="0" marL="0">
-              <a:buNone/>
-            </a:pPr>
-            <a:r>
-              <a:rPr lang="en-US" sz="3400" b="1" dirty="0">
-                <a:solidFill>
-                  <a:schemeClr val="accent2"/>
-                </a:solidFill>
-                <a:latin typeface="Cambria" pitchFamily="34" charset="0"/>
-                <a:ea typeface="Cambria" pitchFamily="34" charset="-122"/>
-                <a:cs typeface="Cambria" pitchFamily="34" charset="-120"/>
-              </a:rPr>
-              <a:t>2</a:t>
-            </a:r>
-            <a:endParaRPr lang="en-US" sz="3400" dirty="0"/>
-          </a:p>
-        </p:txBody>
-      </p:sp>
-      <p:sp>
-        <p:nvSpPr>
-          <p:cNvPr id="13" name="Text 11"/>
-          <p:cNvSpPr txBox="1"/>
-          <p:nvPr/>
-        </p:nvSpPr>
-        <p:spPr>
-          <a:xfrm>
-            <a:off x="3785616" y="2240280"/>
-            <a:ext cx="1325880" cy="822960"/>
-          </a:xfrm>
-          <a:prstGeom prst="rect">
-            <a:avLst/>
-          </a:prstGeom>
-          <a:noFill/>
-          <a:ln/>
-        </p:spPr>
-        <p:txBody>
-          <a:bodyPr wrap="square" lIns="1016" tIns="1016" rIns="1016" bIns="1016" rtlCol="0" anchor="t"/>
-          <a:lstStyle/>
-          <a:p>
-            <a:pPr algn="l" indent="0" marL="0">
-              <a:buNone/>
-            </a:pPr>
-            <a:r>
-              <a:rPr lang="en-US" sz="1400" b="1" dirty="0">
+              <a:t>Il faut au moins un approbateur qui n'instruit pas le dossier</a:t>
+            </a:r>
+            <a:endParaRPr lang="en-US" sz="1300" dirty="0"/>
+          </a:p>
+          <a:p>
+            <a:pPr marL="342900" indent="-342900">
+              <a:spcAft>
+                <a:spcPts val="600"/>
+              </a:spcAft>
+              <a:buSzPct val="100000"/>
+              <a:buChar char="•"/>
+            </a:pPr>
+            <a:r>
+              <a:rPr lang="en-US" sz="1300" dirty="0">
                 <a:solidFill>
                   <a:schemeClr val="tx1"/>
                 </a:solidFill>
               </a:rPr>
-              <a:t>Reporting et facturation</a:t>
-            </a:r>
-            <a:endParaRPr lang="en-US" sz="1400" dirty="0"/>
-          </a:p>
-        </p:txBody>
-      </p:sp>
-      <p:sp>
-        <p:nvSpPr>
-          <p:cNvPr id="14" name="Text 12"/>
-          <p:cNvSpPr txBox="1"/>
-          <p:nvPr/>
-        </p:nvSpPr>
-        <p:spPr>
-          <a:xfrm>
-            <a:off x="3785616" y="3063240"/>
-            <a:ext cx="1325880" cy="1874520"/>
-          </a:xfrm>
-          <a:prstGeom prst="rect">
-            <a:avLst/>
-          </a:prstGeom>
-          <a:noFill/>
-          <a:ln/>
-        </p:spPr>
-        <p:txBody>
-          <a:bodyPr wrap="square" lIns="1016" tIns="1016" rIns="1016" bIns="1016" rtlCol="0" anchor="t"/>
-          <a:lstStyle/>
-          <a:p>
-            <a:pPr algn="l" indent="0" marL="0">
-              <a:buNone/>
-            </a:pPr>
-            <a:r>
-              <a:rPr lang="en-US" sz="1200" dirty="0">
-                <a:solidFill>
-                  <a:schemeClr val="tx1"/>
-                </a:solidFill>
-              </a:rPr>
-              <a:t>Import, rapport, Excel, BigQuery, factures</a:t>
-            </a:r>
-            <a:endParaRPr lang="en-US" sz="1200" dirty="0"/>
-          </a:p>
-        </p:txBody>
-      </p:sp>
-      <p:sp>
-        <p:nvSpPr>
-          <p:cNvPr id="15" name="ph3"/>
-          <p:cNvSpPr/>
-          <p:nvPr/>
-        </p:nvSpPr>
-        <p:spPr>
-          <a:xfrm>
-            <a:off x="5312664" y="1463040"/>
-            <a:ext cx="1481328" cy="3566160"/>
-          </a:xfrm>
-          <a:prstGeom prst="roundRect">
-            <a:avLst>
-              <a:gd name="adj" fmla="val 4938"/>
-            </a:avLst>
-          </a:prstGeom>
-          <a:solidFill>
-            <a:schemeClr val="accent1">
-              <a:alpha val="12000"/>
-            </a:schemeClr>
-          </a:solidFill>
-          <a:ln w="9525">
-            <a:solidFill>
-              <a:schemeClr val="accent1"/>
-            </a:solidFill>
-            <a:prstDash val="solid"/>
-          </a:ln>
-        </p:spPr>
-      </p:sp>
-      <p:sp>
-        <p:nvSpPr>
-          <p:cNvPr id="16" name="Text 14"/>
-          <p:cNvSpPr txBox="1"/>
-          <p:nvPr/>
-        </p:nvSpPr>
-        <p:spPr>
-          <a:xfrm>
-            <a:off x="5404104" y="1554480"/>
-            <a:ext cx="1280160" cy="640080"/>
-          </a:xfrm>
-          <a:prstGeom prst="rect">
-            <a:avLst/>
-          </a:prstGeom>
-          <a:noFill/>
-          <a:ln/>
-        </p:spPr>
-        <p:txBody>
-          <a:bodyPr wrap="square" lIns="1016" tIns="1016" rIns="1016" bIns="1016" rtlCol="0" anchor="t"/>
-          <a:lstStyle/>
-          <a:p>
-            <a:pPr algn="l" indent="0" marL="0">
-              <a:buNone/>
-            </a:pPr>
-            <a:r>
-              <a:rPr lang="en-US" sz="3400" b="1" dirty="0">
-                <a:solidFill>
-                  <a:schemeClr val="accent1"/>
-                </a:solidFill>
-                <a:latin typeface="Cambria" pitchFamily="34" charset="0"/>
-                <a:ea typeface="Cambria" pitchFamily="34" charset="-122"/>
-                <a:cs typeface="Cambria" pitchFamily="34" charset="-120"/>
-              </a:rPr>
-              <a:t>3</a:t>
-            </a:r>
-            <a:endParaRPr lang="en-US" sz="3400" dirty="0"/>
-          </a:p>
-        </p:txBody>
-      </p:sp>
-      <p:sp>
-        <p:nvSpPr>
-          <p:cNvPr id="17" name="Text 15"/>
-          <p:cNvSpPr txBox="1"/>
-          <p:nvPr/>
-        </p:nvSpPr>
-        <p:spPr>
-          <a:xfrm>
-            <a:off x="5404104" y="2240280"/>
-            <a:ext cx="1325880" cy="822960"/>
-          </a:xfrm>
-          <a:prstGeom prst="rect">
-            <a:avLst/>
-          </a:prstGeom>
-          <a:noFill/>
-          <a:ln/>
-        </p:spPr>
-        <p:txBody>
-          <a:bodyPr wrap="square" lIns="1016" tIns="1016" rIns="1016" bIns="1016" rtlCol="0" anchor="t"/>
-          <a:lstStyle/>
-          <a:p>
-            <a:pPr algn="l" indent="0" marL="0">
-              <a:buNone/>
-            </a:pPr>
-            <a:r>
-              <a:rPr lang="en-US" sz="1400" b="1" dirty="0">
-                <a:solidFill>
-                  <a:schemeClr val="tx1"/>
-                </a:solidFill>
-              </a:rPr>
-              <a:t>Marchands et KYC</a:t>
-            </a:r>
-            <a:endParaRPr lang="en-US" sz="1400" dirty="0"/>
-          </a:p>
-        </p:txBody>
-      </p:sp>
-      <p:sp>
-        <p:nvSpPr>
-          <p:cNvPr id="18" name="Text 16"/>
-          <p:cNvSpPr txBox="1"/>
-          <p:nvPr/>
-        </p:nvSpPr>
-        <p:spPr>
-          <a:xfrm>
-            <a:off x="5404104" y="3063240"/>
-            <a:ext cx="1325880" cy="1874520"/>
-          </a:xfrm>
-          <a:prstGeom prst="rect">
-            <a:avLst/>
-          </a:prstGeom>
-          <a:noFill/>
-          <a:ln/>
-        </p:spPr>
-        <p:txBody>
-          <a:bodyPr wrap="square" lIns="1016" tIns="1016" rIns="1016" bIns="1016" rtlCol="0" anchor="t"/>
-          <a:lstStyle/>
-          <a:p>
-            <a:pPr algn="l" indent="0" marL="0">
-              <a:buNone/>
-            </a:pPr>
-            <a:r>
-              <a:rPr lang="en-US" sz="1200" dirty="0">
-                <a:solidFill>
-                  <a:schemeClr val="tx1"/>
-                </a:solidFill>
-              </a:rPr>
-              <a:t>Fiche marchand, dossier KYC, double regard, relances</a:t>
-            </a:r>
-            <a:endParaRPr lang="en-US" sz="1200" dirty="0"/>
-          </a:p>
-        </p:txBody>
-      </p:sp>
-      <p:sp>
-        <p:nvSpPr>
-          <p:cNvPr id="19" name="ph4"/>
-          <p:cNvSpPr/>
-          <p:nvPr/>
-        </p:nvSpPr>
-        <p:spPr>
-          <a:xfrm>
-            <a:off x="6931152" y="1463040"/>
-            <a:ext cx="1481328" cy="3566160"/>
-          </a:xfrm>
-          <a:prstGeom prst="roundRect">
-            <a:avLst>
-              <a:gd name="adj" fmla="val 4938"/>
-            </a:avLst>
-          </a:prstGeom>
-          <a:solidFill>
-            <a:schemeClr val="accent3">
-              <a:alpha val="12000"/>
-            </a:schemeClr>
-          </a:solidFill>
-          <a:ln w="9525">
-            <a:solidFill>
-              <a:schemeClr val="accent3"/>
-            </a:solidFill>
-            <a:prstDash val="solid"/>
-          </a:ln>
-        </p:spPr>
-      </p:sp>
-      <p:sp>
-        <p:nvSpPr>
-          <p:cNvPr id="20" name="Text 18"/>
-          <p:cNvSpPr txBox="1"/>
-          <p:nvPr/>
-        </p:nvSpPr>
-        <p:spPr>
-          <a:xfrm>
-            <a:off x="7022592" y="1554480"/>
-            <a:ext cx="1280160" cy="640080"/>
-          </a:xfrm>
-          <a:prstGeom prst="rect">
-            <a:avLst/>
-          </a:prstGeom>
-          <a:noFill/>
-          <a:ln/>
-        </p:spPr>
-        <p:txBody>
-          <a:bodyPr wrap="square" lIns="1016" tIns="1016" rIns="1016" bIns="1016" rtlCol="0" anchor="t"/>
-          <a:lstStyle/>
-          <a:p>
-            <a:pPr algn="l" indent="0" marL="0">
-              <a:buNone/>
-            </a:pPr>
-            <a:r>
-              <a:rPr lang="en-US" sz="3400" b="1" dirty="0">
-                <a:solidFill>
-                  <a:schemeClr val="accent3"/>
-                </a:solidFill>
-                <a:latin typeface="Cambria" pitchFamily="34" charset="0"/>
-                <a:ea typeface="Cambria" pitchFamily="34" charset="-122"/>
-                <a:cs typeface="Cambria" pitchFamily="34" charset="-120"/>
-              </a:rPr>
-              <a:t>4</a:t>
-            </a:r>
-            <a:endParaRPr lang="en-US" sz="3400" dirty="0"/>
-          </a:p>
-        </p:txBody>
-      </p:sp>
-      <p:sp>
-        <p:nvSpPr>
-          <p:cNvPr id="21" name="Text 19"/>
-          <p:cNvSpPr txBox="1"/>
-          <p:nvPr/>
-        </p:nvSpPr>
-        <p:spPr>
-          <a:xfrm>
-            <a:off x="7022592" y="2240280"/>
-            <a:ext cx="1325880" cy="822960"/>
-          </a:xfrm>
-          <a:prstGeom prst="rect">
-            <a:avLst/>
-          </a:prstGeom>
-          <a:noFill/>
-          <a:ln/>
-        </p:spPr>
-        <p:txBody>
-          <a:bodyPr wrap="square" lIns="1016" tIns="1016" rIns="1016" bIns="1016" rtlCol="0" anchor="t"/>
-          <a:lstStyle/>
-          <a:p>
-            <a:pPr algn="l" indent="0" marL="0">
-              <a:buNone/>
-            </a:pPr>
-            <a:r>
-              <a:rPr lang="en-US" sz="1400" b="1" dirty="0">
-                <a:solidFill>
-                  <a:schemeClr val="tx1"/>
-                </a:solidFill>
-              </a:rPr>
-              <a:t>Portail marchand</a:t>
-            </a:r>
-            <a:endParaRPr lang="en-US" sz="1400" dirty="0"/>
-          </a:p>
-        </p:txBody>
-      </p:sp>
-      <p:sp>
-        <p:nvSpPr>
-          <p:cNvPr id="22" name="Text 20"/>
-          <p:cNvSpPr txBox="1"/>
-          <p:nvPr/>
-        </p:nvSpPr>
-        <p:spPr>
-          <a:xfrm>
-            <a:off x="7022592" y="3063240"/>
-            <a:ext cx="1325880" cy="1874520"/>
-          </a:xfrm>
-          <a:prstGeom prst="rect">
-            <a:avLst/>
-          </a:prstGeom>
-          <a:noFill/>
-          <a:ln/>
-        </p:spPr>
-        <p:txBody>
-          <a:bodyPr wrap="square" lIns="1016" tIns="1016" rIns="1016" bIns="1016" rtlCol="0" anchor="t"/>
-          <a:lstStyle/>
-          <a:p>
-            <a:pPr algn="l" indent="0" marL="0">
-              <a:buNone/>
-            </a:pPr>
-            <a:r>
-              <a:rPr lang="en-US" sz="1200" dirty="0">
-                <a:solidFill>
-                  <a:schemeClr val="tx1"/>
-                </a:solidFill>
-              </a:rPr>
-              <a:t>Compte, CGU, préqualification, pièces, antivirus</a:t>
-            </a:r>
-            <a:endParaRPr lang="en-US" sz="1200" dirty="0"/>
-          </a:p>
-        </p:txBody>
-      </p:sp>
-      <p:sp>
-        <p:nvSpPr>
-          <p:cNvPr id="23" name="ph5"/>
-          <p:cNvSpPr/>
-          <p:nvPr/>
-        </p:nvSpPr>
-        <p:spPr>
-          <a:xfrm>
-            <a:off x="8549640" y="1463040"/>
-            <a:ext cx="1481328" cy="3566160"/>
-          </a:xfrm>
-          <a:prstGeom prst="roundRect">
-            <a:avLst>
-              <a:gd name="adj" fmla="val 4938"/>
-            </a:avLst>
-          </a:prstGeom>
-          <a:solidFill>
-            <a:schemeClr val="accent1">
-              <a:alpha val="12000"/>
-            </a:schemeClr>
-          </a:solidFill>
-          <a:ln w="9525">
-            <a:solidFill>
-              <a:schemeClr val="accent1"/>
-            </a:solidFill>
-            <a:prstDash val="solid"/>
-          </a:ln>
-        </p:spPr>
-      </p:sp>
-      <p:sp>
-        <p:nvSpPr>
-          <p:cNvPr id="24" name="Text 22"/>
-          <p:cNvSpPr txBox="1"/>
-          <p:nvPr/>
-        </p:nvSpPr>
-        <p:spPr>
-          <a:xfrm>
-            <a:off x="8641080" y="1554480"/>
-            <a:ext cx="1280160" cy="640080"/>
-          </a:xfrm>
-          <a:prstGeom prst="rect">
-            <a:avLst/>
-          </a:prstGeom>
-          <a:noFill/>
-          <a:ln/>
-        </p:spPr>
-        <p:txBody>
-          <a:bodyPr wrap="square" lIns="1016" tIns="1016" rIns="1016" bIns="1016" rtlCol="0" anchor="t"/>
-          <a:lstStyle/>
-          <a:p>
-            <a:pPr algn="l" indent="0" marL="0">
-              <a:buNone/>
-            </a:pPr>
-            <a:r>
-              <a:rPr lang="en-US" sz="3400" b="1" dirty="0">
-                <a:solidFill>
-                  <a:schemeClr val="accent1"/>
-                </a:solidFill>
-                <a:latin typeface="Cambria" pitchFamily="34" charset="0"/>
-                <a:ea typeface="Cambria" pitchFamily="34" charset="-122"/>
-                <a:cs typeface="Cambria" pitchFamily="34" charset="-120"/>
-              </a:rPr>
-              <a:t>5</a:t>
-            </a:r>
-            <a:endParaRPr lang="en-US" sz="3400" dirty="0"/>
-          </a:p>
-        </p:txBody>
-      </p:sp>
-      <p:sp>
-        <p:nvSpPr>
-          <p:cNvPr id="25" name="Text 23"/>
-          <p:cNvSpPr txBox="1"/>
-          <p:nvPr/>
-        </p:nvSpPr>
-        <p:spPr>
-          <a:xfrm>
-            <a:off x="8641080" y="2240280"/>
-            <a:ext cx="1325880" cy="822960"/>
-          </a:xfrm>
-          <a:prstGeom prst="rect">
-            <a:avLst/>
-          </a:prstGeom>
-          <a:noFill/>
-          <a:ln/>
-        </p:spPr>
-        <p:txBody>
-          <a:bodyPr wrap="square" lIns="1016" tIns="1016" rIns="1016" bIns="1016" rtlCol="0" anchor="t"/>
-          <a:lstStyle/>
-          <a:p>
-            <a:pPr algn="l" indent="0" marL="0">
-              <a:buNone/>
-            </a:pPr>
-            <a:r>
-              <a:rPr lang="en-US" sz="1400" b="1" dirty="0">
-                <a:solidFill>
-                  <a:schemeClr val="tx1"/>
-                </a:solidFill>
-              </a:rPr>
-              <a:t>Rapprochement MCB</a:t>
-            </a:r>
-            <a:endParaRPr lang="en-US" sz="1400" dirty="0"/>
-          </a:p>
-        </p:txBody>
-      </p:sp>
-      <p:sp>
-        <p:nvSpPr>
-          <p:cNvPr id="26" name="Text 24"/>
-          <p:cNvSpPr txBox="1"/>
-          <p:nvPr/>
-        </p:nvSpPr>
-        <p:spPr>
-          <a:xfrm>
-            <a:off x="8641080" y="3063240"/>
-            <a:ext cx="1325880" cy="1874520"/>
-          </a:xfrm>
-          <a:prstGeom prst="rect">
-            <a:avLst/>
-          </a:prstGeom>
-          <a:noFill/>
-          <a:ln/>
-        </p:spPr>
-        <p:txBody>
-          <a:bodyPr wrap="square" lIns="1016" tIns="1016" rIns="1016" bIns="1016" rtlCol="0" anchor="t"/>
-          <a:lstStyle/>
-          <a:p>
-            <a:pPr algn="l" indent="0" marL="0">
-              <a:buNone/>
-            </a:pPr>
-            <a:r>
-              <a:rPr lang="en-US" sz="1200" dirty="0">
-                <a:solidFill>
-                  <a:schemeClr val="tx1"/>
-                </a:solidFill>
-              </a:rPr>
-              <a:t>Validé sur un mois déjà réconcilié</a:t>
-            </a:r>
-            <a:endParaRPr lang="en-US" sz="1200" dirty="0"/>
-          </a:p>
-        </p:txBody>
-      </p:sp>
-      <p:sp>
-        <p:nvSpPr>
-          <p:cNvPr id="27" name="ph6"/>
-          <p:cNvSpPr/>
-          <p:nvPr/>
-        </p:nvSpPr>
-        <p:spPr>
-          <a:xfrm>
-            <a:off x="10168128" y="1463040"/>
-            <a:ext cx="1481328" cy="3566160"/>
-          </a:xfrm>
-          <a:prstGeom prst="roundRect">
-            <a:avLst>
-              <a:gd name="adj" fmla="val 4938"/>
-            </a:avLst>
-          </a:prstGeom>
-          <a:solidFill>
-            <a:schemeClr val="accent5">
-              <a:alpha val="12000"/>
-            </a:schemeClr>
-          </a:solidFill>
-          <a:ln w="9525">
-            <a:solidFill>
-              <a:schemeClr val="accent5"/>
-            </a:solidFill>
-            <a:prstDash val="solid"/>
-          </a:ln>
-        </p:spPr>
-      </p:sp>
-      <p:sp>
-        <p:nvSpPr>
-          <p:cNvPr id="28" name="Text 26"/>
-          <p:cNvSpPr txBox="1"/>
-          <p:nvPr/>
-        </p:nvSpPr>
-        <p:spPr>
-          <a:xfrm>
-            <a:off x="10259568" y="1554480"/>
-            <a:ext cx="1280160" cy="640080"/>
-          </a:xfrm>
-          <a:prstGeom prst="rect">
-            <a:avLst/>
-          </a:prstGeom>
-          <a:noFill/>
-          <a:ln/>
-        </p:spPr>
-        <p:txBody>
-          <a:bodyPr wrap="square" lIns="1016" tIns="1016" rIns="1016" bIns="1016" rtlCol="0" anchor="t"/>
-          <a:lstStyle/>
-          <a:p>
-            <a:pPr algn="l" indent="0" marL="0">
-              <a:buNone/>
-            </a:pPr>
-            <a:r>
-              <a:rPr lang="en-US" sz="3400" b="1" dirty="0">
-                <a:solidFill>
-                  <a:schemeClr val="accent5"/>
-                </a:solidFill>
-                <a:latin typeface="Cambria" pitchFamily="34" charset="0"/>
-                <a:ea typeface="Cambria" pitchFamily="34" charset="-122"/>
-                <a:cs typeface="Cambria" pitchFamily="34" charset="-120"/>
-              </a:rPr>
-              <a:t>6</a:t>
-            </a:r>
-            <a:endParaRPr lang="en-US" sz="3400" dirty="0"/>
-          </a:p>
-        </p:txBody>
-      </p:sp>
-      <p:sp>
-        <p:nvSpPr>
-          <p:cNvPr id="29" name="Text 27"/>
-          <p:cNvSpPr txBox="1"/>
-          <p:nvPr/>
-        </p:nvSpPr>
-        <p:spPr>
-          <a:xfrm>
-            <a:off x="10259568" y="2240280"/>
-            <a:ext cx="1325880" cy="822960"/>
-          </a:xfrm>
-          <a:prstGeom prst="rect">
-            <a:avLst/>
-          </a:prstGeom>
-          <a:noFill/>
-          <a:ln/>
-        </p:spPr>
-        <p:txBody>
-          <a:bodyPr wrap="square" lIns="1016" tIns="1016" rIns="1016" bIns="1016" rtlCol="0" anchor="t"/>
-          <a:lstStyle/>
-          <a:p>
-            <a:pPr algn="l" indent="0" marL="0">
-              <a:buNone/>
-            </a:pPr>
-            <a:r>
-              <a:rPr lang="en-US" sz="1400" b="1" dirty="0">
-                <a:solidFill>
-                  <a:schemeClr val="tx1"/>
-                </a:solidFill>
-              </a:rPr>
-              <a:t>Trust (si modèle B)</a:t>
-            </a:r>
-            <a:endParaRPr lang="en-US" sz="1400" dirty="0"/>
-          </a:p>
-        </p:txBody>
-      </p:sp>
-      <p:sp>
-        <p:nvSpPr>
-          <p:cNvPr id="30" name="Text 28"/>
-          <p:cNvSpPr txBox="1"/>
-          <p:nvPr/>
-        </p:nvSpPr>
-        <p:spPr>
-          <a:xfrm>
-            <a:off x="10259568" y="3063240"/>
-            <a:ext cx="1325880" cy="1874520"/>
-          </a:xfrm>
-          <a:prstGeom prst="rect">
-            <a:avLst/>
-          </a:prstGeom>
-          <a:noFill/>
-          <a:ln/>
-        </p:spPr>
-        <p:txBody>
-          <a:bodyPr wrap="square" lIns="1016" tIns="1016" rIns="1016" bIns="1016" rtlCol="0" anchor="t"/>
-          <a:lstStyle/>
-          <a:p>
-            <a:pPr algn="l" indent="0" marL="0">
-              <a:buNone/>
-            </a:pPr>
-            <a:r>
-              <a:rPr lang="en-US" sz="1200" dirty="0">
-                <a:solidFill>
-                  <a:schemeClr val="tx1"/>
-                </a:solidFill>
-              </a:rPr>
-              <a:t>Grand livre, rapprochement quotidien, reversements</a:t>
-            </a:r>
-            <a:endParaRPr lang="en-US" sz="1200" dirty="0"/>
-          </a:p>
-        </p:txBody>
-      </p:sp>
-      <p:sp>
-        <p:nvSpPr>
-          <p:cNvPr id="31" name="Text 29"/>
-          <p:cNvSpPr txBox="1"/>
-          <p:nvPr/>
-        </p:nvSpPr>
-        <p:spPr>
-          <a:xfrm>
-            <a:off x="457200" y="5303520"/>
-            <a:ext cx="11247120" cy="548640"/>
-          </a:xfrm>
-          <a:prstGeom prst="rect">
-            <a:avLst/>
-          </a:prstGeom>
-          <a:noFill/>
-          <a:ln/>
-        </p:spPr>
-        <p:txBody>
-          <a:bodyPr wrap="square" lIns="0" tIns="0" rIns="0" bIns="0" rtlCol="0" anchor="t"/>
-          <a:lstStyle/>
-          <a:p>
-            <a:pPr algn="l" indent="0" marL="0">
-              <a:buNone/>
-            </a:pPr>
-            <a:r>
-              <a:rPr lang="en-US" sz="1400" i="1" dirty="0">
-                <a:solidFill>
-                  <a:schemeClr val="tx2"/>
-                </a:solidFill>
-              </a:rPr>
-              <a:t>Chaque palier se termine quand ses tests de recette passent sur données réelles. Pas de dates tant que le palier 0 n'est pas tranché.</a:t>
-            </a:r>
-            <a:endParaRPr lang="en-US" sz="1400" dirty="0"/>
+              <a:t>Sans lui, personne ne peut trancher le dossier : c'est voulu</a:t>
+            </a:r>
+            <a:endParaRPr lang="en-US" sz="1300" dirty="0"/>
           </a:p>
         </p:txBody>
       </p:sp>
@@ -4165,7 +3698,7 @@
                   <a:schemeClr val="tx1"/>
                 </a:solidFill>
               </a:rPr>
-              <a:t>Définition de « terminé »</a:t>
+              <a:t>Feuille de route proposée, par paliers</a:t>
             </a:r>
             <a:endParaRPr lang="en-US" sz="3000" dirty="0"/>
           </a:p>
@@ -4173,26 +3706,28 @@
       </p:sp>
       <p:sp>
         <p:nvSpPr>
-          <p:cNvPr id="3" name="dod0"/>
+          <p:cNvPr id="3" name="ph0"/>
           <p:cNvSpPr/>
           <p:nvPr/>
         </p:nvSpPr>
         <p:spPr>
           <a:xfrm>
-            <a:off x="457200" y="1325880"/>
-            <a:ext cx="3566160" cy="2011680"/>
+            <a:off x="457200" y="1463040"/>
+            <a:ext cx="1481328" cy="3566160"/>
           </a:xfrm>
           <a:prstGeom prst="roundRect">
             <a:avLst>
-              <a:gd name="adj" fmla="val 3636"/>
+              <a:gd name="adj" fmla="val 4938"/>
             </a:avLst>
           </a:prstGeom>
           <a:solidFill>
-            <a:schemeClr val="bg2"/>
+            <a:schemeClr val="accent6">
+              <a:alpha val="12000"/>
+            </a:schemeClr>
           </a:solidFill>
           <a:ln w="9525">
             <a:solidFill>
-              <a:schemeClr val="bg2"/>
+              <a:schemeClr val="accent6"/>
             </a:solidFill>
             <a:prstDash val="solid"/>
           </a:ln>
@@ -4200,24 +3735,139 @@
       </p:sp>
       <p:sp>
         <p:nvSpPr>
-          <p:cNvPr id="4" name="dod0-dot"/>
+          <p:cNvPr id="4" name="Text 2"/>
+          <p:cNvSpPr txBox="1"/>
+          <p:nvPr/>
+        </p:nvSpPr>
+        <p:spPr>
+          <a:xfrm>
+            <a:off x="548640" y="1554480"/>
+            <a:ext cx="1280160" cy="640080"/>
+          </a:xfrm>
+          <a:prstGeom prst="rect">
+            <a:avLst/>
+          </a:prstGeom>
+          <a:noFill/>
+          <a:ln/>
+        </p:spPr>
+        <p:txBody>
+          <a:bodyPr wrap="square" lIns="1016" tIns="1016" rIns="1016" bIns="1016" rtlCol="0" anchor="t"/>
+          <a:lstStyle/>
+          <a:p>
+            <a:pPr algn="l" indent="0" marL="0">
+              <a:buNone/>
+            </a:pPr>
+            <a:r>
+              <a:rPr lang="en-US" sz="3400" b="1" dirty="0">
+                <a:solidFill>
+                  <a:schemeClr val="accent6"/>
+                </a:solidFill>
+                <a:latin typeface="Cambria" pitchFamily="34" charset="0"/>
+                <a:ea typeface="Cambria" pitchFamily="34" charset="-122"/>
+                <a:cs typeface="Cambria" pitchFamily="34" charset="-120"/>
+              </a:rPr>
+              <a:t>0</a:t>
+            </a:r>
+            <a:endParaRPr lang="en-US" sz="3400" dirty="0"/>
+          </a:p>
+        </p:txBody>
+      </p:sp>
+      <p:sp>
+        <p:nvSpPr>
+          <p:cNvPr id="5" name="Text 3"/>
+          <p:cNvSpPr txBox="1"/>
+          <p:nvPr/>
+        </p:nvSpPr>
+        <p:spPr>
+          <a:xfrm>
+            <a:off x="548640" y="2240280"/>
+            <a:ext cx="1325880" cy="822960"/>
+          </a:xfrm>
+          <a:prstGeom prst="rect">
+            <a:avLst/>
+          </a:prstGeom>
+          <a:noFill/>
+          <a:ln/>
+        </p:spPr>
+        <p:txBody>
+          <a:bodyPr wrap="square" lIns="1016" tIns="1016" rIns="1016" bIns="1016" rtlCol="0" anchor="t"/>
+          <a:lstStyle/>
+          <a:p>
+            <a:pPr algn="l" indent="0" marL="0">
+              <a:buNone/>
+            </a:pPr>
+            <a:r>
+              <a:rPr lang="en-US" sz="1400" b="1" dirty="0">
+                <a:solidFill>
+                  <a:schemeClr val="tx1"/>
+                </a:solidFill>
+              </a:rPr>
+              <a:t>Décisions</a:t>
+            </a:r>
+            <a:endParaRPr lang="en-US" sz="1400" dirty="0"/>
+          </a:p>
+        </p:txBody>
+      </p:sp>
+      <p:sp>
+        <p:nvSpPr>
+          <p:cNvPr id="6" name="Text 4"/>
+          <p:cNvSpPr txBox="1"/>
+          <p:nvPr/>
+        </p:nvSpPr>
+        <p:spPr>
+          <a:xfrm>
+            <a:off x="548640" y="3063240"/>
+            <a:ext cx="1325880" cy="1874520"/>
+          </a:xfrm>
+          <a:prstGeom prst="rect">
+            <a:avLst/>
+          </a:prstGeom>
+          <a:noFill/>
+          <a:ln/>
+        </p:spPr>
+        <p:txBody>
+          <a:bodyPr wrap="square" lIns="1016" tIns="1016" rIns="1016" bIns="1016" rtlCol="0" anchor="t"/>
+          <a:lstStyle/>
+          <a:p>
+            <a:pPr algn="l" indent="0" marL="0">
+              <a:buNone/>
+            </a:pPr>
+            <a:r>
+              <a:rPr lang="en-US" sz="1200" dirty="0">
+                <a:solidFill>
+                  <a:schemeClr val="tx1"/>
+                </a:solidFill>
+              </a:rPr>
+              <a:t>Modèle A ou B · textes BoM · seuils KYC · texte des CGU</a:t>
+            </a:r>
+            <a:endParaRPr lang="en-US" sz="1200" dirty="0"/>
+          </a:p>
+        </p:txBody>
+      </p:sp>
+      <p:sp>
+        <p:nvSpPr>
+          <p:cNvPr id="7" name="ph1"/>
           <p:cNvSpPr/>
           <p:nvPr/>
         </p:nvSpPr>
         <p:spPr>
           <a:xfrm>
-            <a:off x="658368" y="1545336"/>
-            <a:ext cx="274320" cy="274320"/>
-          </a:xfrm>
-          <a:prstGeom prst="ellipse">
-            <a:avLst/>
+            <a:off x="2075688" y="1463040"/>
+            <a:ext cx="1481328" cy="3566160"/>
+          </a:xfrm>
+          <a:prstGeom prst="roundRect">
+            <a:avLst>
+              <a:gd name="adj" fmla="val 4938"/>
+            </a:avLst>
           </a:prstGeom>
           <a:solidFill>
-            <a:schemeClr val="accent4"/>
+            <a:schemeClr val="accent2">
+              <a:alpha val="12000"/>
+            </a:schemeClr>
           </a:solidFill>
-          <a:ln w="12700">
+          <a:ln w="9525">
             <a:solidFill>
-              <a:schemeClr val="accent4"/>
+              <a:schemeClr val="accent2"/>
             </a:solidFill>
             <a:prstDash val="solid"/>
           </a:ln>
@@ -4225,14 +3875,14 @@
       </p:sp>
       <p:sp>
         <p:nvSpPr>
-          <p:cNvPr id="5" name="Text 3"/>
+          <p:cNvPr id="8" name="Text 6"/>
           <p:cNvSpPr txBox="1"/>
           <p:nvPr/>
         </p:nvSpPr>
         <p:spPr>
           <a:xfrm>
-            <a:off x="1051560" y="1435608"/>
-            <a:ext cx="2834640" cy="457200"/>
+            <a:off x="2167128" y="1554480"/>
+            <a:ext cx="1280160" cy="640080"/>
           </a:xfrm>
           <a:prstGeom prst="rect">
             <a:avLst/>
@@ -4241,34 +3891,73 @@
           <a:ln/>
         </p:spPr>
         <p:txBody>
-          <a:bodyPr wrap="square" lIns="1016" tIns="1016" rIns="1016" bIns="1016" rtlCol="0" anchor="ctr"/>
+          <a:bodyPr wrap="square" lIns="1016" tIns="1016" rIns="1016" bIns="1016" rtlCol="0" anchor="t"/>
           <a:lstStyle/>
           <a:p>
             <a:pPr algn="l" indent="0" marL="0">
               <a:buNone/>
             </a:pPr>
             <a:r>
-              <a:rPr lang="en-US" sz="1600" b="1" dirty="0">
+              <a:rPr lang="en-US" sz="3400" b="1" dirty="0">
+                <a:solidFill>
+                  <a:schemeClr val="accent2"/>
+                </a:solidFill>
+                <a:latin typeface="Cambria" pitchFamily="34" charset="0"/>
+                <a:ea typeface="Cambria" pitchFamily="34" charset="-122"/>
+                <a:cs typeface="Cambria" pitchFamily="34" charset="-120"/>
+              </a:rPr>
+              <a:t>1</a:t>
+            </a:r>
+            <a:endParaRPr lang="en-US" sz="3400" dirty="0"/>
+          </a:p>
+        </p:txBody>
+      </p:sp>
+      <p:sp>
+        <p:nvSpPr>
+          <p:cNvPr id="9" name="Text 7"/>
+          <p:cNvSpPr txBox="1"/>
+          <p:nvPr/>
+        </p:nvSpPr>
+        <p:spPr>
+          <a:xfrm>
+            <a:off x="2167128" y="2240280"/>
+            <a:ext cx="1325880" cy="822960"/>
+          </a:xfrm>
+          <a:prstGeom prst="rect">
+            <a:avLst/>
+          </a:prstGeom>
+          <a:noFill/>
+          <a:ln/>
+        </p:spPr>
+        <p:txBody>
+          <a:bodyPr wrap="square" lIns="1016" tIns="1016" rIns="1016" bIns="1016" rtlCol="0" anchor="t"/>
+          <a:lstStyle/>
+          <a:p>
+            <a:pPr algn="l" indent="0" marL="0">
+              <a:buNone/>
+            </a:pPr>
+            <a:r>
+              <a:rPr lang="en-US" sz="1400" b="1" dirty="0">
                 <a:solidFill>
                   <a:schemeClr val="tx1"/>
                 </a:solidFill>
               </a:rPr>
-              <a:t>Tests de recette</a:t>
-            </a:r>
-            <a:endParaRPr lang="en-US" sz="1600" dirty="0"/>
-          </a:p>
-        </p:txBody>
-      </p:sp>
-      <p:sp>
-        <p:nvSpPr>
-          <p:cNvPr id="6" name="Text 4"/>
+              <a:t>Socle</a:t>
+            </a:r>
+            <a:endParaRPr lang="en-US" sz="1400" dirty="0"/>
+          </a:p>
+        </p:txBody>
+      </p:sp>
+      <p:sp>
+        <p:nvSpPr>
+          <p:cNvPr id="10" name="Text 8"/>
           <p:cNvSpPr txBox="1"/>
           <p:nvPr/>
         </p:nvSpPr>
         <p:spPr>
           <a:xfrm>
-            <a:off x="640080" y="1965960"/>
-            <a:ext cx="3246120" cy="1280160"/>
+            <a:off x="2167128" y="3063240"/>
+            <a:ext cx="1325880" cy="1874520"/>
           </a:xfrm>
           <a:prstGeom prst="rect">
             <a:avLst/>
@@ -4284,39 +3973,41 @@
               <a:buNone/>
             </a:pPr>
             <a:r>
-              <a:rPr lang="en-US" sz="1300" dirty="0">
+              <a:rPr lang="en-US" sz="1200" dirty="0">
                 <a:solidFill>
                   <a:schemeClr val="tx1"/>
                 </a:solidFill>
               </a:rPr>
-              <a:t>Les tests de la spec et les scénarios des suites de référence passent, automatisés.</a:t>
-            </a:r>
-            <a:endParaRPr lang="en-US" sz="1300" dirty="0"/>
-          </a:p>
-        </p:txBody>
-      </p:sp>
-      <p:sp>
-        <p:nvSpPr>
-          <p:cNvPr id="7" name="dod1"/>
+              <a:t>Auth, 2FA, rôles, audit, sessions séparées</a:t>
+            </a:r>
+            <a:endParaRPr lang="en-US" sz="1200" dirty="0"/>
+          </a:p>
+        </p:txBody>
+      </p:sp>
+      <p:sp>
+        <p:nvSpPr>
+          <p:cNvPr id="11" name="ph2"/>
           <p:cNvSpPr/>
           <p:nvPr/>
         </p:nvSpPr>
         <p:spPr>
           <a:xfrm>
-            <a:off x="4251960" y="1325880"/>
-            <a:ext cx="3566160" cy="2011680"/>
+            <a:off x="3694176" y="1463040"/>
+            <a:ext cx="1481328" cy="3566160"/>
           </a:xfrm>
           <a:prstGeom prst="roundRect">
             <a:avLst>
-              <a:gd name="adj" fmla="val 3636"/>
+              <a:gd name="adj" fmla="val 4938"/>
             </a:avLst>
           </a:prstGeom>
           <a:solidFill>
-            <a:schemeClr val="bg2"/>
+            <a:schemeClr val="accent2">
+              <a:alpha val="12000"/>
+            </a:schemeClr>
           </a:solidFill>
           <a:ln w="9525">
             <a:solidFill>
-              <a:schemeClr val="bg2"/>
+              <a:schemeClr val="accent2"/>
             </a:solidFill>
             <a:prstDash val="solid"/>
           </a:ln>
@@ -4324,24 +4015,139 @@
       </p:sp>
       <p:sp>
         <p:nvSpPr>
-          <p:cNvPr id="8" name="dod1-dot"/>
+          <p:cNvPr id="12" name="Text 10"/>
+          <p:cNvSpPr txBox="1"/>
+          <p:nvPr/>
+        </p:nvSpPr>
+        <p:spPr>
+          <a:xfrm>
+            <a:off x="3785616" y="1554480"/>
+            <a:ext cx="1280160" cy="640080"/>
+          </a:xfrm>
+          <a:prstGeom prst="rect">
+            <a:avLst/>
+          </a:prstGeom>
+          <a:noFill/>
+          <a:ln/>
+        </p:spPr>
+        <p:txBody>
+          <a:bodyPr wrap="square" lIns="1016" tIns="1016" rIns="1016" bIns="1016" rtlCol="0" anchor="t"/>
+          <a:lstStyle/>
+          <a:p>
+            <a:pPr algn="l" indent="0" marL="0">
+              <a:buNone/>
+            </a:pPr>
+            <a:r>
+              <a:rPr lang="en-US" sz="3400" b="1" dirty="0">
+                <a:solidFill>
+                  <a:schemeClr val="accent2"/>
+                </a:solidFill>
+                <a:latin typeface="Cambria" pitchFamily="34" charset="0"/>
+                <a:ea typeface="Cambria" pitchFamily="34" charset="-122"/>
+                <a:cs typeface="Cambria" pitchFamily="34" charset="-120"/>
+              </a:rPr>
+              <a:t>2</a:t>
+            </a:r>
+            <a:endParaRPr lang="en-US" sz="3400" dirty="0"/>
+          </a:p>
+        </p:txBody>
+      </p:sp>
+      <p:sp>
+        <p:nvSpPr>
+          <p:cNvPr id="13" name="Text 11"/>
+          <p:cNvSpPr txBox="1"/>
+          <p:nvPr/>
+        </p:nvSpPr>
+        <p:spPr>
+          <a:xfrm>
+            <a:off x="3785616" y="2240280"/>
+            <a:ext cx="1325880" cy="822960"/>
+          </a:xfrm>
+          <a:prstGeom prst="rect">
+            <a:avLst/>
+          </a:prstGeom>
+          <a:noFill/>
+          <a:ln/>
+        </p:spPr>
+        <p:txBody>
+          <a:bodyPr wrap="square" lIns="1016" tIns="1016" rIns="1016" bIns="1016" rtlCol="0" anchor="t"/>
+          <a:lstStyle/>
+          <a:p>
+            <a:pPr algn="l" indent="0" marL="0">
+              <a:buNone/>
+            </a:pPr>
+            <a:r>
+              <a:rPr lang="en-US" sz="1400" b="1" dirty="0">
+                <a:solidFill>
+                  <a:schemeClr val="tx1"/>
+                </a:solidFill>
+              </a:rPr>
+              <a:t>Reporting et facturation</a:t>
+            </a:r>
+            <a:endParaRPr lang="en-US" sz="1400" dirty="0"/>
+          </a:p>
+        </p:txBody>
+      </p:sp>
+      <p:sp>
+        <p:nvSpPr>
+          <p:cNvPr id="14" name="Text 12"/>
+          <p:cNvSpPr txBox="1"/>
+          <p:nvPr/>
+        </p:nvSpPr>
+        <p:spPr>
+          <a:xfrm>
+            <a:off x="3785616" y="3063240"/>
+            <a:ext cx="1325880" cy="1874520"/>
+          </a:xfrm>
+          <a:prstGeom prst="rect">
+            <a:avLst/>
+          </a:prstGeom>
+          <a:noFill/>
+          <a:ln/>
+        </p:spPr>
+        <p:txBody>
+          <a:bodyPr wrap="square" lIns="1016" tIns="1016" rIns="1016" bIns="1016" rtlCol="0" anchor="t"/>
+          <a:lstStyle/>
+          <a:p>
+            <a:pPr algn="l" indent="0" marL="0">
+              <a:buNone/>
+            </a:pPr>
+            <a:r>
+              <a:rPr lang="en-US" sz="1200" dirty="0">
+                <a:solidFill>
+                  <a:schemeClr val="tx1"/>
+                </a:solidFill>
+              </a:rPr>
+              <a:t>Import, rapport, Excel, BigQuery, factures</a:t>
+            </a:r>
+            <a:endParaRPr lang="en-US" sz="1200" dirty="0"/>
+          </a:p>
+        </p:txBody>
+      </p:sp>
+      <p:sp>
+        <p:nvSpPr>
+          <p:cNvPr id="15" name="ph3"/>
           <p:cNvSpPr/>
           <p:nvPr/>
         </p:nvSpPr>
         <p:spPr>
           <a:xfrm>
-            <a:off x="4453128" y="1545336"/>
-            <a:ext cx="274320" cy="274320"/>
-          </a:xfrm>
-          <a:prstGeom prst="ellipse">
-            <a:avLst/>
+            <a:off x="5312664" y="1463040"/>
+            <a:ext cx="1481328" cy="3566160"/>
+          </a:xfrm>
+          <a:prstGeom prst="roundRect">
+            <a:avLst>
+              <a:gd name="adj" fmla="val 4938"/>
+            </a:avLst>
           </a:prstGeom>
           <a:solidFill>
-            <a:schemeClr val="accent4"/>
+            <a:schemeClr val="accent1">
+              <a:alpha val="12000"/>
+            </a:schemeClr>
           </a:solidFill>
-          <a:ln w="12700">
+          <a:ln w="9525">
             <a:solidFill>
-              <a:schemeClr val="accent4"/>
+              <a:schemeClr val="accent1"/>
             </a:solidFill>
             <a:prstDash val="solid"/>
           </a:ln>
@@ -4349,14 +4155,14 @@
       </p:sp>
       <p:sp>
         <p:nvSpPr>
-          <p:cNvPr id="9" name="Text 7"/>
+          <p:cNvPr id="16" name="Text 14"/>
           <p:cNvSpPr txBox="1"/>
           <p:nvPr/>
         </p:nvSpPr>
         <p:spPr>
           <a:xfrm>
-            <a:off x="4846320" y="1435608"/>
-            <a:ext cx="2834640" cy="457200"/>
+            <a:off x="5404104" y="1554480"/>
+            <a:ext cx="1280160" cy="640080"/>
           </a:xfrm>
           <a:prstGeom prst="rect">
             <a:avLst/>
@@ -4365,34 +4171,73 @@
           <a:ln/>
         </p:spPr>
         <p:txBody>
-          <a:bodyPr wrap="square" lIns="1016" tIns="1016" rIns="1016" bIns="1016" rtlCol="0" anchor="ctr"/>
+          <a:bodyPr wrap="square" lIns="1016" tIns="1016" rIns="1016" bIns="1016" rtlCol="0" anchor="t"/>
           <a:lstStyle/>
           <a:p>
             <a:pPr algn="l" indent="0" marL="0">
               <a:buNone/>
             </a:pPr>
             <a:r>
-              <a:rPr lang="en-US" sz="1600" b="1" dirty="0">
+              <a:rPr lang="en-US" sz="3400" b="1" dirty="0">
+                <a:solidFill>
+                  <a:schemeClr val="accent1"/>
+                </a:solidFill>
+                <a:latin typeface="Cambria" pitchFamily="34" charset="0"/>
+                <a:ea typeface="Cambria" pitchFamily="34" charset="-122"/>
+                <a:cs typeface="Cambria" pitchFamily="34" charset="-120"/>
+              </a:rPr>
+              <a:t>3</a:t>
+            </a:r>
+            <a:endParaRPr lang="en-US" sz="3400" dirty="0"/>
+          </a:p>
+        </p:txBody>
+      </p:sp>
+      <p:sp>
+        <p:nvSpPr>
+          <p:cNvPr id="17" name="Text 15"/>
+          <p:cNvSpPr txBox="1"/>
+          <p:nvPr/>
+        </p:nvSpPr>
+        <p:spPr>
+          <a:xfrm>
+            <a:off x="5404104" y="2240280"/>
+            <a:ext cx="1325880" cy="822960"/>
+          </a:xfrm>
+          <a:prstGeom prst="rect">
+            <a:avLst/>
+          </a:prstGeom>
+          <a:noFill/>
+          <a:ln/>
+        </p:spPr>
+        <p:txBody>
+          <a:bodyPr wrap="square" lIns="1016" tIns="1016" rIns="1016" bIns="1016" rtlCol="0" anchor="t"/>
+          <a:lstStyle/>
+          <a:p>
+            <a:pPr algn="l" indent="0" marL="0">
+              <a:buNone/>
+            </a:pPr>
+            <a:r>
+              <a:rPr lang="en-US" sz="1400" b="1" dirty="0">
                 <a:solidFill>
                   <a:schemeClr val="tx1"/>
                 </a:solidFill>
               </a:rPr>
-              <a:t>Données réelles</a:t>
-            </a:r>
-            <a:endParaRPr lang="en-US" sz="1600" dirty="0"/>
-          </a:p>
-        </p:txBody>
-      </p:sp>
-      <p:sp>
-        <p:nvSpPr>
-          <p:cNvPr id="10" name="Text 8"/>
+              <a:t>Marchands et KYC</a:t>
+            </a:r>
+            <a:endParaRPr lang="en-US" sz="1400" dirty="0"/>
+          </a:p>
+        </p:txBody>
+      </p:sp>
+      <p:sp>
+        <p:nvSpPr>
+          <p:cNvPr id="18" name="Text 16"/>
           <p:cNvSpPr txBox="1"/>
           <p:nvPr/>
         </p:nvSpPr>
         <p:spPr>
           <a:xfrm>
-            <a:off x="4434840" y="1965960"/>
-            <a:ext cx="3246120" cy="1280160"/>
+            <a:off x="5404104" y="3063240"/>
+            <a:ext cx="1325880" cy="1874520"/>
           </a:xfrm>
           <a:prstGeom prst="rect">
             <a:avLst/>
@@ -4408,39 +4253,41 @@
               <a:buNone/>
             </a:pPr>
             <a:r>
-              <a:rPr lang="en-US" sz="1300" dirty="0">
+              <a:rPr lang="en-US" sz="1200" dirty="0">
                 <a:solidFill>
                   <a:schemeClr val="tx1"/>
                 </a:solidFill>
               </a:rPr>
-              <a:t>Résultat comparé au processus actuel sur au moins un mois.</a:t>
-            </a:r>
-            <a:endParaRPr lang="en-US" sz="1300" dirty="0"/>
-          </a:p>
-        </p:txBody>
-      </p:sp>
-      <p:sp>
-        <p:nvSpPr>
-          <p:cNvPr id="11" name="dod2"/>
+              <a:t>Fiche marchand, dossier KYC, double regard, relances</a:t>
+            </a:r>
+            <a:endParaRPr lang="en-US" sz="1200" dirty="0"/>
+          </a:p>
+        </p:txBody>
+      </p:sp>
+      <p:sp>
+        <p:nvSpPr>
+          <p:cNvPr id="19" name="ph4"/>
           <p:cNvSpPr/>
           <p:nvPr/>
         </p:nvSpPr>
         <p:spPr>
           <a:xfrm>
-            <a:off x="8046720" y="1325880"/>
-            <a:ext cx="3566160" cy="2011680"/>
+            <a:off x="6931152" y="1463040"/>
+            <a:ext cx="1481328" cy="3566160"/>
           </a:xfrm>
           <a:prstGeom prst="roundRect">
             <a:avLst>
-              <a:gd name="adj" fmla="val 3636"/>
+              <a:gd name="adj" fmla="val 4938"/>
             </a:avLst>
           </a:prstGeom>
           <a:solidFill>
-            <a:schemeClr val="bg2"/>
+            <a:schemeClr val="accent3">
+              <a:alpha val="12000"/>
+            </a:schemeClr>
           </a:solidFill>
           <a:ln w="9525">
             <a:solidFill>
-              <a:schemeClr val="bg2"/>
+              <a:schemeClr val="accent3"/>
             </a:solidFill>
             <a:prstDash val="solid"/>
           </a:ln>
@@ -4448,24 +4295,139 @@
       </p:sp>
       <p:sp>
         <p:nvSpPr>
-          <p:cNvPr id="12" name="dod2-dot"/>
+          <p:cNvPr id="20" name="Text 18"/>
+          <p:cNvSpPr txBox="1"/>
+          <p:nvPr/>
+        </p:nvSpPr>
+        <p:spPr>
+          <a:xfrm>
+            <a:off x="7022592" y="1554480"/>
+            <a:ext cx="1280160" cy="640080"/>
+          </a:xfrm>
+          <a:prstGeom prst="rect">
+            <a:avLst/>
+          </a:prstGeom>
+          <a:noFill/>
+          <a:ln/>
+        </p:spPr>
+        <p:txBody>
+          <a:bodyPr wrap="square" lIns="1016" tIns="1016" rIns="1016" bIns="1016" rtlCol="0" anchor="t"/>
+          <a:lstStyle/>
+          <a:p>
+            <a:pPr algn="l" indent="0" marL="0">
+              <a:buNone/>
+            </a:pPr>
+            <a:r>
+              <a:rPr lang="en-US" sz="3400" b="1" dirty="0">
+                <a:solidFill>
+                  <a:schemeClr val="accent3"/>
+                </a:solidFill>
+                <a:latin typeface="Cambria" pitchFamily="34" charset="0"/>
+                <a:ea typeface="Cambria" pitchFamily="34" charset="-122"/>
+                <a:cs typeface="Cambria" pitchFamily="34" charset="-120"/>
+              </a:rPr>
+              <a:t>4</a:t>
+            </a:r>
+            <a:endParaRPr lang="en-US" sz="3400" dirty="0"/>
+          </a:p>
+        </p:txBody>
+      </p:sp>
+      <p:sp>
+        <p:nvSpPr>
+          <p:cNvPr id="21" name="Text 19"/>
+          <p:cNvSpPr txBox="1"/>
+          <p:nvPr/>
+        </p:nvSpPr>
+        <p:spPr>
+          <a:xfrm>
+            <a:off x="7022592" y="2240280"/>
+            <a:ext cx="1325880" cy="822960"/>
+          </a:xfrm>
+          <a:prstGeom prst="rect">
+            <a:avLst/>
+          </a:prstGeom>
+          <a:noFill/>
+          <a:ln/>
+        </p:spPr>
+        <p:txBody>
+          <a:bodyPr wrap="square" lIns="1016" tIns="1016" rIns="1016" bIns="1016" rtlCol="0" anchor="t"/>
+          <a:lstStyle/>
+          <a:p>
+            <a:pPr algn="l" indent="0" marL="0">
+              <a:buNone/>
+            </a:pPr>
+            <a:r>
+              <a:rPr lang="en-US" sz="1400" b="1" dirty="0">
+                <a:solidFill>
+                  <a:schemeClr val="tx1"/>
+                </a:solidFill>
+              </a:rPr>
+              <a:t>Portail marchand</a:t>
+            </a:r>
+            <a:endParaRPr lang="en-US" sz="1400" dirty="0"/>
+          </a:p>
+        </p:txBody>
+      </p:sp>
+      <p:sp>
+        <p:nvSpPr>
+          <p:cNvPr id="22" name="Text 20"/>
+          <p:cNvSpPr txBox="1"/>
+          <p:nvPr/>
+        </p:nvSpPr>
+        <p:spPr>
+          <a:xfrm>
+            <a:off x="7022592" y="3063240"/>
+            <a:ext cx="1325880" cy="1874520"/>
+          </a:xfrm>
+          <a:prstGeom prst="rect">
+            <a:avLst/>
+          </a:prstGeom>
+          <a:noFill/>
+          <a:ln/>
+        </p:spPr>
+        <p:txBody>
+          <a:bodyPr wrap="square" lIns="1016" tIns="1016" rIns="1016" bIns="1016" rtlCol="0" anchor="t"/>
+          <a:lstStyle/>
+          <a:p>
+            <a:pPr algn="l" indent="0" marL="0">
+              <a:buNone/>
+            </a:pPr>
+            <a:r>
+              <a:rPr lang="en-US" sz="1200" dirty="0">
+                <a:solidFill>
+                  <a:schemeClr val="tx1"/>
+                </a:solidFill>
+              </a:rPr>
+              <a:t>Compte, CGU, préqualification, pièces, antivirus</a:t>
+            </a:r>
+            <a:endParaRPr lang="en-US" sz="1200" dirty="0"/>
+          </a:p>
+        </p:txBody>
+      </p:sp>
+      <p:sp>
+        <p:nvSpPr>
+          <p:cNvPr id="23" name="ph5"/>
           <p:cNvSpPr/>
           <p:nvPr/>
         </p:nvSpPr>
         <p:spPr>
           <a:xfrm>
-            <a:off x="8247888" y="1545336"/>
-            <a:ext cx="274320" cy="274320"/>
-          </a:xfrm>
-          <a:prstGeom prst="ellipse">
-            <a:avLst/>
+            <a:off x="8549640" y="1463040"/>
+            <a:ext cx="1481328" cy="3566160"/>
+          </a:xfrm>
+          <a:prstGeom prst="roundRect">
+            <a:avLst>
+              <a:gd name="adj" fmla="val 4938"/>
+            </a:avLst>
           </a:prstGeom>
           <a:solidFill>
-            <a:schemeClr val="accent4"/>
+            <a:schemeClr val="accent1">
+              <a:alpha val="12000"/>
+            </a:schemeClr>
           </a:solidFill>
-          <a:ln w="12700">
+          <a:ln w="9525">
             <a:solidFill>
-              <a:schemeClr val="accent4"/>
+              <a:schemeClr val="accent1"/>
             </a:solidFill>
             <a:prstDash val="solid"/>
           </a:ln>
@@ -4473,14 +4435,14 @@
       </p:sp>
       <p:sp>
         <p:nvSpPr>
-          <p:cNvPr id="13" name="Text 11"/>
+          <p:cNvPr id="24" name="Text 22"/>
           <p:cNvSpPr txBox="1"/>
           <p:nvPr/>
         </p:nvSpPr>
         <p:spPr>
           <a:xfrm>
-            <a:off x="8641080" y="1435608"/>
-            <a:ext cx="2834640" cy="457200"/>
+            <a:off x="8641080" y="1554480"/>
+            <a:ext cx="1280160" cy="640080"/>
           </a:xfrm>
           <a:prstGeom prst="rect">
             <a:avLst/>
@@ -4489,34 +4451,73 @@
           <a:ln/>
         </p:spPr>
         <p:txBody>
-          <a:bodyPr wrap="square" lIns="1016" tIns="1016" rIns="1016" bIns="1016" rtlCol="0" anchor="ctr"/>
+          <a:bodyPr wrap="square" lIns="1016" tIns="1016" rIns="1016" bIns="1016" rtlCol="0" anchor="t"/>
           <a:lstStyle/>
           <a:p>
             <a:pPr algn="l" indent="0" marL="0">
               <a:buNone/>
             </a:pPr>
             <a:r>
-              <a:rPr lang="en-US" sz="1600" b="1" dirty="0">
+              <a:rPr lang="en-US" sz="3400" b="1" dirty="0">
+                <a:solidFill>
+                  <a:schemeClr val="accent1"/>
+                </a:solidFill>
+                <a:latin typeface="Cambria" pitchFamily="34" charset="0"/>
+                <a:ea typeface="Cambria" pitchFamily="34" charset="-122"/>
+                <a:cs typeface="Cambria" pitchFamily="34" charset="-120"/>
+              </a:rPr>
+              <a:t>5</a:t>
+            </a:r>
+            <a:endParaRPr lang="en-US" sz="3400" dirty="0"/>
+          </a:p>
+        </p:txBody>
+      </p:sp>
+      <p:sp>
+        <p:nvSpPr>
+          <p:cNvPr id="25" name="Text 23"/>
+          <p:cNvSpPr txBox="1"/>
+          <p:nvPr/>
+        </p:nvSpPr>
+        <p:spPr>
+          <a:xfrm>
+            <a:off x="8641080" y="2240280"/>
+            <a:ext cx="1325880" cy="822960"/>
+          </a:xfrm>
+          <a:prstGeom prst="rect">
+            <a:avLst/>
+          </a:prstGeom>
+          <a:noFill/>
+          <a:ln/>
+        </p:spPr>
+        <p:txBody>
+          <a:bodyPr wrap="square" lIns="1016" tIns="1016" rIns="1016" bIns="1016" rtlCol="0" anchor="t"/>
+          <a:lstStyle/>
+          <a:p>
+            <a:pPr algn="l" indent="0" marL="0">
+              <a:buNone/>
+            </a:pPr>
+            <a:r>
+              <a:rPr lang="en-US" sz="1400" b="1" dirty="0">
                 <a:solidFill>
                   <a:schemeClr val="tx1"/>
                 </a:solidFill>
               </a:rPr>
-              <a:t>Revue de sécurité</a:t>
-            </a:r>
-            <a:endParaRPr lang="en-US" sz="1600" dirty="0"/>
-          </a:p>
-        </p:txBody>
-      </p:sp>
-      <p:sp>
-        <p:nvSpPr>
-          <p:cNvPr id="14" name="Text 12"/>
+              <a:t>Rapprochement MCB</a:t>
+            </a:r>
+            <a:endParaRPr lang="en-US" sz="1400" dirty="0"/>
+          </a:p>
+        </p:txBody>
+      </p:sp>
+      <p:sp>
+        <p:nvSpPr>
+          <p:cNvPr id="26" name="Text 24"/>
           <p:cNvSpPr txBox="1"/>
           <p:nvPr/>
         </p:nvSpPr>
         <p:spPr>
           <a:xfrm>
-            <a:off x="8229600" y="1965960"/>
-            <a:ext cx="3246120" cy="1280160"/>
+            <a:off x="8641080" y="3063240"/>
+            <a:ext cx="1325880" cy="1874520"/>
           </a:xfrm>
           <a:prstGeom prst="rect">
             <a:avLst/>
@@ -4532,39 +4533,41 @@
               <a:buNone/>
             </a:pPr>
             <a:r>
-              <a:rPr lang="en-US" sz="1300" dirty="0">
+              <a:rPr lang="en-US" sz="1200" dirty="0">
                 <a:solidFill>
                   <a:schemeClr val="tx1"/>
                 </a:solidFill>
               </a:rPr>
-              <a:t>Accès, double regard, données sensibles, fichiers : vérifiés par un pair.</a:t>
-            </a:r>
-            <a:endParaRPr lang="en-US" sz="1300" dirty="0"/>
-          </a:p>
-        </p:txBody>
-      </p:sp>
-      <p:sp>
-        <p:nvSpPr>
-          <p:cNvPr id="15" name="dod3"/>
+              <a:t>Validé sur un mois déjà réconcilié</a:t>
+            </a:r>
+            <a:endParaRPr lang="en-US" sz="1200" dirty="0"/>
+          </a:p>
+        </p:txBody>
+      </p:sp>
+      <p:sp>
+        <p:nvSpPr>
+          <p:cNvPr id="27" name="ph6"/>
           <p:cNvSpPr/>
           <p:nvPr/>
         </p:nvSpPr>
         <p:spPr>
           <a:xfrm>
-            <a:off x="457200" y="3566160"/>
-            <a:ext cx="3566160" cy="2011680"/>
+            <a:off x="10168128" y="1463040"/>
+            <a:ext cx="1481328" cy="3566160"/>
           </a:xfrm>
           <a:prstGeom prst="roundRect">
             <a:avLst>
-              <a:gd name="adj" fmla="val 3636"/>
+              <a:gd name="adj" fmla="val 4938"/>
             </a:avLst>
           </a:prstGeom>
           <a:solidFill>
-            <a:schemeClr val="bg2"/>
+            <a:schemeClr val="accent5">
+              <a:alpha val="12000"/>
+            </a:schemeClr>
           </a:solidFill>
           <a:ln w="9525">
             <a:solidFill>
-              <a:schemeClr val="bg2"/>
+              <a:schemeClr val="accent5"/>
             </a:solidFill>
             <a:prstDash val="solid"/>
           </a:ln>
@@ -4572,39 +4575,14 @@
       </p:sp>
       <p:sp>
         <p:nvSpPr>
-          <p:cNvPr id="16" name="dod3-dot"/>
-          <p:cNvSpPr/>
-          <p:nvPr/>
-        </p:nvSpPr>
-        <p:spPr>
-          <a:xfrm>
-            <a:off x="658368" y="3785616"/>
-            <a:ext cx="274320" cy="274320"/>
-          </a:xfrm>
-          <a:prstGeom prst="ellipse">
-            <a:avLst/>
-          </a:prstGeom>
-          <a:solidFill>
-            <a:schemeClr val="accent4"/>
-          </a:solidFill>
-          <a:ln w="12700">
-            <a:solidFill>
-              <a:schemeClr val="accent4"/>
-            </a:solidFill>
-            <a:prstDash val="solid"/>
-          </a:ln>
-        </p:spPr>
-      </p:sp>
-      <p:sp>
-        <p:nvSpPr>
-          <p:cNvPr id="17" name="Text 15"/>
+          <p:cNvPr id="28" name="Text 26"/>
           <p:cNvSpPr txBox="1"/>
           <p:nvPr/>
         </p:nvSpPr>
         <p:spPr>
           <a:xfrm>
-            <a:off x="1051560" y="3675888"/>
-            <a:ext cx="2834640" cy="457200"/>
+            <a:off x="10259568" y="1554480"/>
+            <a:ext cx="1280160" cy="640080"/>
           </a:xfrm>
           <a:prstGeom prst="rect">
             <a:avLst/>
@@ -4613,34 +4591,73 @@
           <a:ln/>
         </p:spPr>
         <p:txBody>
-          <a:bodyPr wrap="square" lIns="1016" tIns="1016" rIns="1016" bIns="1016" rtlCol="0" anchor="ctr"/>
+          <a:bodyPr wrap="square" lIns="1016" tIns="1016" rIns="1016" bIns="1016" rtlCol="0" anchor="t"/>
           <a:lstStyle/>
           <a:p>
             <a:pPr algn="l" indent="0" marL="0">
               <a:buNone/>
             </a:pPr>
             <a:r>
-              <a:rPr lang="en-US" sz="1600" b="1" dirty="0">
+              <a:rPr lang="en-US" sz="3400" b="1" dirty="0">
+                <a:solidFill>
+                  <a:schemeClr val="accent5"/>
+                </a:solidFill>
+                <a:latin typeface="Cambria" pitchFamily="34" charset="0"/>
+                <a:ea typeface="Cambria" pitchFamily="34" charset="-122"/>
+                <a:cs typeface="Cambria" pitchFamily="34" charset="-120"/>
+              </a:rPr>
+              <a:t>6</a:t>
+            </a:r>
+            <a:endParaRPr lang="en-US" sz="3400" dirty="0"/>
+          </a:p>
+        </p:txBody>
+      </p:sp>
+      <p:sp>
+        <p:nvSpPr>
+          <p:cNvPr id="29" name="Text 27"/>
+          <p:cNvSpPr txBox="1"/>
+          <p:nvPr/>
+        </p:nvSpPr>
+        <p:spPr>
+          <a:xfrm>
+            <a:off x="10259568" y="2240280"/>
+            <a:ext cx="1325880" cy="822960"/>
+          </a:xfrm>
+          <a:prstGeom prst="rect">
+            <a:avLst/>
+          </a:prstGeom>
+          <a:noFill/>
+          <a:ln/>
+        </p:spPr>
+        <p:txBody>
+          <a:bodyPr wrap="square" lIns="1016" tIns="1016" rIns="1016" bIns="1016" rtlCol="0" anchor="t"/>
+          <a:lstStyle/>
+          <a:p>
+            <a:pPr algn="l" indent="0" marL="0">
+              <a:buNone/>
+            </a:pPr>
+            <a:r>
+              <a:rPr lang="en-US" sz="1400" b="1" dirty="0">
                 <a:solidFill>
                   <a:schemeClr val="tx1"/>
                 </a:solidFill>
               </a:rPr>
-              <a:t>Configuration validée</a:t>
-            </a:r>
-            <a:endParaRPr lang="en-US" sz="1600" dirty="0"/>
-          </a:p>
-        </p:txBody>
-      </p:sp>
-      <p:sp>
-        <p:nvSpPr>
-          <p:cNvPr id="18" name="Text 16"/>
+              <a:t>Trust (si modèle B)</a:t>
+            </a:r>
+            <a:endParaRPr lang="en-US" sz="1400" dirty="0"/>
+          </a:p>
+        </p:txBody>
+      </p:sp>
+      <p:sp>
+        <p:nvSpPr>
+          <p:cNvPr id="30" name="Text 28"/>
           <p:cNvSpPr txBox="1"/>
           <p:nvPr/>
         </p:nvSpPr>
         <p:spPr>
           <a:xfrm>
-            <a:off x="640080" y="4206240"/>
-            <a:ext cx="3246120" cy="1280160"/>
+            <a:off x="10259568" y="3063240"/>
+            <a:ext cx="1325880" cy="1874520"/>
           </a:xfrm>
           <a:prstGeom prst="rect">
             <a:avLst/>
@@ -4656,79 +4673,27 @@
               <a:buNone/>
             </a:pPr>
             <a:r>
-              <a:rPr lang="en-US" sz="1300" dirty="0">
+              <a:rPr lang="en-US" sz="1200" dirty="0">
                 <a:solidFill>
                   <a:schemeClr val="tx1"/>
                 </a:solidFill>
               </a:rPr>
-              <a:t>Seuils et listes signés par la conformité ou la finance.</a:t>
-            </a:r>
-            <a:endParaRPr lang="en-US" sz="1300" dirty="0"/>
-          </a:p>
-        </p:txBody>
-      </p:sp>
-      <p:sp>
-        <p:nvSpPr>
-          <p:cNvPr id="19" name="dod4"/>
-          <p:cNvSpPr/>
-          <p:nvPr/>
-        </p:nvSpPr>
-        <p:spPr>
-          <a:xfrm>
-            <a:off x="4251960" y="3566160"/>
-            <a:ext cx="3566160" cy="2011680"/>
-          </a:xfrm>
-          <a:prstGeom prst="roundRect">
-            <a:avLst>
-              <a:gd name="adj" fmla="val 3636"/>
-            </a:avLst>
-          </a:prstGeom>
-          <a:solidFill>
-            <a:schemeClr val="bg2"/>
-          </a:solidFill>
-          <a:ln w="9525">
-            <a:solidFill>
-              <a:schemeClr val="bg2"/>
-            </a:solidFill>
-            <a:prstDash val="solid"/>
-          </a:ln>
-        </p:spPr>
-      </p:sp>
-      <p:sp>
-        <p:nvSpPr>
-          <p:cNvPr id="20" name="dod4-dot"/>
-          <p:cNvSpPr/>
-          <p:nvPr/>
-        </p:nvSpPr>
-        <p:spPr>
-          <a:xfrm>
-            <a:off x="4453128" y="3785616"/>
-            <a:ext cx="274320" cy="274320"/>
-          </a:xfrm>
-          <a:prstGeom prst="ellipse">
-            <a:avLst/>
-          </a:prstGeom>
-          <a:solidFill>
-            <a:schemeClr val="accent4"/>
-          </a:solidFill>
-          <a:ln w="12700">
-            <a:solidFill>
-              <a:schemeClr val="accent4"/>
-            </a:solidFill>
-            <a:prstDash val="solid"/>
-          </a:ln>
-        </p:spPr>
-      </p:sp>
-      <p:sp>
-        <p:nvSpPr>
-          <p:cNvPr id="21" name="Text 19"/>
+              <a:t>Grand livre, rapprochement quotidien, reversements</a:t>
+            </a:r>
+            <a:endParaRPr lang="en-US" sz="1200" dirty="0"/>
+          </a:p>
+        </p:txBody>
+      </p:sp>
+      <p:sp>
+        <p:nvSpPr>
+          <p:cNvPr id="31" name="Text 29"/>
           <p:cNvSpPr txBox="1"/>
           <p:nvPr/>
         </p:nvSpPr>
         <p:spPr>
           <a:xfrm>
-            <a:off x="4846320" y="3675888"/>
-            <a:ext cx="2834640" cy="457200"/>
+            <a:off x="457200" y="5303520"/>
+            <a:ext cx="11247120" cy="548640"/>
           </a:xfrm>
           <a:prstGeom prst="rect">
             <a:avLst/>
@@ -4737,181 +4702,21 @@
           <a:ln/>
         </p:spPr>
         <p:txBody>
-          <a:bodyPr wrap="square" lIns="1016" tIns="1016" rIns="1016" bIns="1016" rtlCol="0" anchor="ctr"/>
+          <a:bodyPr wrap="square" lIns="0" tIns="0" rIns="0" bIns="0" rtlCol="0" anchor="t"/>
           <a:lstStyle/>
           <a:p>
             <a:pPr algn="l" indent="0" marL="0">
               <a:buNone/>
             </a:pPr>
             <a:r>
-              <a:rPr lang="en-US" sz="1600" b="1" dirty="0">
-                <a:solidFill>
-                  <a:schemeClr val="tx1"/>
-                </a:solidFill>
-              </a:rPr>
-              <a:t>Journal complet</a:t>
-            </a:r>
-            <a:endParaRPr lang="en-US" sz="1600" dirty="0"/>
-          </a:p>
-        </p:txBody>
-      </p:sp>
-      <p:sp>
-        <p:nvSpPr>
-          <p:cNvPr id="22" name="Text 20"/>
-          <p:cNvSpPr txBox="1"/>
-          <p:nvPr/>
-        </p:nvSpPr>
-        <p:spPr>
-          <a:xfrm>
-            <a:off x="4434840" y="4206240"/>
-            <a:ext cx="3246120" cy="1280160"/>
-          </a:xfrm>
-          <a:prstGeom prst="rect">
-            <a:avLst/>
-          </a:prstGeom>
-          <a:noFill/>
-          <a:ln/>
-        </p:spPr>
-        <p:txBody>
-          <a:bodyPr wrap="square" lIns="1016" tIns="1016" rIns="1016" bIns="1016" rtlCol="0" anchor="t"/>
-          <a:lstStyle/>
-          <a:p>
-            <a:pPr algn="l" indent="0" marL="0">
-              <a:buNone/>
-            </a:pPr>
-            <a:r>
-              <a:rPr lang="en-US" sz="1300" dirty="0">
-                <a:solidFill>
-                  <a:schemeClr val="tx1"/>
-                </a:solidFill>
-              </a:rPr>
-              <a:t>Chaque action du module apparaît dans le journal d'audit.</a:t>
-            </a:r>
-            <a:endParaRPr lang="en-US" sz="1300" dirty="0"/>
-          </a:p>
-        </p:txBody>
-      </p:sp>
-      <p:sp>
-        <p:nvSpPr>
-          <p:cNvPr id="23" name="dod5"/>
-          <p:cNvSpPr/>
-          <p:nvPr/>
-        </p:nvSpPr>
-        <p:spPr>
-          <a:xfrm>
-            <a:off x="8046720" y="3566160"/>
-            <a:ext cx="3566160" cy="2011680"/>
-          </a:xfrm>
-          <a:prstGeom prst="roundRect">
-            <a:avLst>
-              <a:gd name="adj" fmla="val 3636"/>
-            </a:avLst>
-          </a:prstGeom>
-          <a:solidFill>
-            <a:schemeClr val="bg2"/>
-          </a:solidFill>
-          <a:ln w="9525">
-            <a:solidFill>
-              <a:schemeClr val="bg2"/>
-            </a:solidFill>
-            <a:prstDash val="solid"/>
-          </a:ln>
-        </p:spPr>
-      </p:sp>
-      <p:sp>
-        <p:nvSpPr>
-          <p:cNvPr id="24" name="dod5-dot"/>
-          <p:cNvSpPr/>
-          <p:nvPr/>
-        </p:nvSpPr>
-        <p:spPr>
-          <a:xfrm>
-            <a:off x="8247888" y="3785616"/>
-            <a:ext cx="274320" cy="274320"/>
-          </a:xfrm>
-          <a:prstGeom prst="ellipse">
-            <a:avLst/>
-          </a:prstGeom>
-          <a:solidFill>
-            <a:schemeClr val="accent4"/>
-          </a:solidFill>
-          <a:ln w="12700">
-            <a:solidFill>
-              <a:schemeClr val="accent4"/>
-            </a:solidFill>
-            <a:prstDash val="solid"/>
-          </a:ln>
-        </p:spPr>
-      </p:sp>
-      <p:sp>
-        <p:nvSpPr>
-          <p:cNvPr id="25" name="Text 23"/>
-          <p:cNvSpPr txBox="1"/>
-          <p:nvPr/>
-        </p:nvSpPr>
-        <p:spPr>
-          <a:xfrm>
-            <a:off x="8641080" y="3675888"/>
-            <a:ext cx="2834640" cy="457200"/>
-          </a:xfrm>
-          <a:prstGeom prst="rect">
-            <a:avLst/>
-          </a:prstGeom>
-          <a:noFill/>
-          <a:ln/>
-        </p:spPr>
-        <p:txBody>
-          <a:bodyPr wrap="square" lIns="1016" tIns="1016" rIns="1016" bIns="1016" rtlCol="0" anchor="ctr"/>
-          <a:lstStyle/>
-          <a:p>
-            <a:pPr algn="l" indent="0" marL="0">
-              <a:buNone/>
-            </a:pPr>
-            <a:r>
-              <a:rPr lang="en-US" sz="1600" b="1" dirty="0">
-                <a:solidFill>
-                  <a:schemeClr val="tx1"/>
-                </a:solidFill>
-              </a:rPr>
-              <a:t>Documentation</a:t>
-            </a:r>
-            <a:endParaRPr lang="en-US" sz="1600" dirty="0"/>
-          </a:p>
-        </p:txBody>
-      </p:sp>
-      <p:sp>
-        <p:nvSpPr>
-          <p:cNvPr id="26" name="Text 24"/>
-          <p:cNvSpPr txBox="1"/>
-          <p:nvPr/>
-        </p:nvSpPr>
-        <p:spPr>
-          <a:xfrm>
-            <a:off x="8229600" y="4206240"/>
-            <a:ext cx="3246120" cy="1280160"/>
-          </a:xfrm>
-          <a:prstGeom prst="rect">
-            <a:avLst/>
-          </a:prstGeom>
-          <a:noFill/>
-          <a:ln/>
-        </p:spPr>
-        <p:txBody>
-          <a:bodyPr wrap="square" lIns="1016" tIns="1016" rIns="1016" bIns="1016" rtlCol="0" anchor="t"/>
-          <a:lstStyle/>
-          <a:p>
-            <a:pPr algn="l" indent="0" marL="0">
-              <a:buNone/>
-            </a:pPr>
-            <a:r>
-              <a:rPr lang="en-US" sz="1300" dirty="0">
-                <a:solidFill>
-                  <a:schemeClr val="tx1"/>
-                </a:solidFill>
-              </a:rPr>
-              <a:t>Spec à jour, paramètres décrits, procédure d'exploitation.</a:t>
-            </a:r>
-            <a:endParaRPr lang="en-US" sz="1300" dirty="0"/>
+              <a:rPr lang="en-US" sz="1400" i="1" dirty="0">
+                <a:solidFill>
+                  <a:schemeClr val="tx2"/>
+                </a:solidFill>
+              </a:rPr>
+              <a:t>Chaque palier se termine quand ses tests de recette passent sur données réelles. Pas de dates tant que le palier 0 n'est pas tranché.</a:t>
+            </a:r>
+            <a:endParaRPr lang="en-US" sz="1400" dirty="0"/>
           </a:p>
         </p:txBody>
       </p:sp>
@@ -5017,6 +4822,858 @@
                   <a:schemeClr val="tx1"/>
                 </a:solidFill>
               </a:rPr>
+              <a:t>Définition de « terminé »</a:t>
+            </a:r>
+            <a:endParaRPr lang="en-US" sz="3000" dirty="0"/>
+          </a:p>
+        </p:txBody>
+      </p:sp>
+      <p:sp>
+        <p:nvSpPr>
+          <p:cNvPr id="3" name="dod0"/>
+          <p:cNvSpPr/>
+          <p:nvPr/>
+        </p:nvSpPr>
+        <p:spPr>
+          <a:xfrm>
+            <a:off x="457200" y="1325880"/>
+            <a:ext cx="3566160" cy="2011680"/>
+          </a:xfrm>
+          <a:prstGeom prst="roundRect">
+            <a:avLst>
+              <a:gd name="adj" fmla="val 3636"/>
+            </a:avLst>
+          </a:prstGeom>
+          <a:solidFill>
+            <a:schemeClr val="bg2"/>
+          </a:solidFill>
+          <a:ln w="9525">
+            <a:solidFill>
+              <a:schemeClr val="bg2"/>
+            </a:solidFill>
+            <a:prstDash val="solid"/>
+          </a:ln>
+        </p:spPr>
+      </p:sp>
+      <p:sp>
+        <p:nvSpPr>
+          <p:cNvPr id="4" name="dod0-dot"/>
+          <p:cNvSpPr/>
+          <p:nvPr/>
+        </p:nvSpPr>
+        <p:spPr>
+          <a:xfrm>
+            <a:off x="658368" y="1545336"/>
+            <a:ext cx="274320" cy="274320"/>
+          </a:xfrm>
+          <a:prstGeom prst="ellipse">
+            <a:avLst/>
+          </a:prstGeom>
+          <a:solidFill>
+            <a:schemeClr val="accent4"/>
+          </a:solidFill>
+          <a:ln w="12700">
+            <a:solidFill>
+              <a:schemeClr val="accent4"/>
+            </a:solidFill>
+            <a:prstDash val="solid"/>
+          </a:ln>
+        </p:spPr>
+      </p:sp>
+      <p:sp>
+        <p:nvSpPr>
+          <p:cNvPr id="5" name="Text 3"/>
+          <p:cNvSpPr txBox="1"/>
+          <p:nvPr/>
+        </p:nvSpPr>
+        <p:spPr>
+          <a:xfrm>
+            <a:off x="1051560" y="1435608"/>
+            <a:ext cx="2834640" cy="457200"/>
+          </a:xfrm>
+          <a:prstGeom prst="rect">
+            <a:avLst/>
+          </a:prstGeom>
+          <a:noFill/>
+          <a:ln/>
+        </p:spPr>
+        <p:txBody>
+          <a:bodyPr wrap="square" lIns="1016" tIns="1016" rIns="1016" bIns="1016" rtlCol="0" anchor="ctr"/>
+          <a:lstStyle/>
+          <a:p>
+            <a:pPr algn="l" indent="0" marL="0">
+              <a:buNone/>
+            </a:pPr>
+            <a:r>
+              <a:rPr lang="en-US" sz="1600" b="1" dirty="0">
+                <a:solidFill>
+                  <a:schemeClr val="tx1"/>
+                </a:solidFill>
+              </a:rPr>
+              <a:t>Tests de recette</a:t>
+            </a:r>
+            <a:endParaRPr lang="en-US" sz="1600" dirty="0"/>
+          </a:p>
+        </p:txBody>
+      </p:sp>
+      <p:sp>
+        <p:nvSpPr>
+          <p:cNvPr id="6" name="Text 4"/>
+          <p:cNvSpPr txBox="1"/>
+          <p:nvPr/>
+        </p:nvSpPr>
+        <p:spPr>
+          <a:xfrm>
+            <a:off x="640080" y="1965960"/>
+            <a:ext cx="3246120" cy="1280160"/>
+          </a:xfrm>
+          <a:prstGeom prst="rect">
+            <a:avLst/>
+          </a:prstGeom>
+          <a:noFill/>
+          <a:ln/>
+        </p:spPr>
+        <p:txBody>
+          <a:bodyPr wrap="square" lIns="1016" tIns="1016" rIns="1016" bIns="1016" rtlCol="0" anchor="t"/>
+          <a:lstStyle/>
+          <a:p>
+            <a:pPr algn="l" indent="0" marL="0">
+              <a:buNone/>
+            </a:pPr>
+            <a:r>
+              <a:rPr lang="en-US" sz="1300" dirty="0">
+                <a:solidFill>
+                  <a:schemeClr val="tx1"/>
+                </a:solidFill>
+              </a:rPr>
+              <a:t>Les tests de la spec et les scénarios des suites de référence passent, automatisés.</a:t>
+            </a:r>
+            <a:endParaRPr lang="en-US" sz="1300" dirty="0"/>
+          </a:p>
+        </p:txBody>
+      </p:sp>
+      <p:sp>
+        <p:nvSpPr>
+          <p:cNvPr id="7" name="dod1"/>
+          <p:cNvSpPr/>
+          <p:nvPr/>
+        </p:nvSpPr>
+        <p:spPr>
+          <a:xfrm>
+            <a:off x="4251960" y="1325880"/>
+            <a:ext cx="3566160" cy="2011680"/>
+          </a:xfrm>
+          <a:prstGeom prst="roundRect">
+            <a:avLst>
+              <a:gd name="adj" fmla="val 3636"/>
+            </a:avLst>
+          </a:prstGeom>
+          <a:solidFill>
+            <a:schemeClr val="bg2"/>
+          </a:solidFill>
+          <a:ln w="9525">
+            <a:solidFill>
+              <a:schemeClr val="bg2"/>
+            </a:solidFill>
+            <a:prstDash val="solid"/>
+          </a:ln>
+        </p:spPr>
+      </p:sp>
+      <p:sp>
+        <p:nvSpPr>
+          <p:cNvPr id="8" name="dod1-dot"/>
+          <p:cNvSpPr/>
+          <p:nvPr/>
+        </p:nvSpPr>
+        <p:spPr>
+          <a:xfrm>
+            <a:off x="4453128" y="1545336"/>
+            <a:ext cx="274320" cy="274320"/>
+          </a:xfrm>
+          <a:prstGeom prst="ellipse">
+            <a:avLst/>
+          </a:prstGeom>
+          <a:solidFill>
+            <a:schemeClr val="accent4"/>
+          </a:solidFill>
+          <a:ln w="12700">
+            <a:solidFill>
+              <a:schemeClr val="accent4"/>
+            </a:solidFill>
+            <a:prstDash val="solid"/>
+          </a:ln>
+        </p:spPr>
+      </p:sp>
+      <p:sp>
+        <p:nvSpPr>
+          <p:cNvPr id="9" name="Text 7"/>
+          <p:cNvSpPr txBox="1"/>
+          <p:nvPr/>
+        </p:nvSpPr>
+        <p:spPr>
+          <a:xfrm>
+            <a:off x="4846320" y="1435608"/>
+            <a:ext cx="2834640" cy="457200"/>
+          </a:xfrm>
+          <a:prstGeom prst="rect">
+            <a:avLst/>
+          </a:prstGeom>
+          <a:noFill/>
+          <a:ln/>
+        </p:spPr>
+        <p:txBody>
+          <a:bodyPr wrap="square" lIns="1016" tIns="1016" rIns="1016" bIns="1016" rtlCol="0" anchor="ctr"/>
+          <a:lstStyle/>
+          <a:p>
+            <a:pPr algn="l" indent="0" marL="0">
+              <a:buNone/>
+            </a:pPr>
+            <a:r>
+              <a:rPr lang="en-US" sz="1600" b="1" dirty="0">
+                <a:solidFill>
+                  <a:schemeClr val="tx1"/>
+                </a:solidFill>
+              </a:rPr>
+              <a:t>Données réelles</a:t>
+            </a:r>
+            <a:endParaRPr lang="en-US" sz="1600" dirty="0"/>
+          </a:p>
+        </p:txBody>
+      </p:sp>
+      <p:sp>
+        <p:nvSpPr>
+          <p:cNvPr id="10" name="Text 8"/>
+          <p:cNvSpPr txBox="1"/>
+          <p:nvPr/>
+        </p:nvSpPr>
+        <p:spPr>
+          <a:xfrm>
+            <a:off x="4434840" y="1965960"/>
+            <a:ext cx="3246120" cy="1280160"/>
+          </a:xfrm>
+          <a:prstGeom prst="rect">
+            <a:avLst/>
+          </a:prstGeom>
+          <a:noFill/>
+          <a:ln/>
+        </p:spPr>
+        <p:txBody>
+          <a:bodyPr wrap="square" lIns="1016" tIns="1016" rIns="1016" bIns="1016" rtlCol="0" anchor="t"/>
+          <a:lstStyle/>
+          <a:p>
+            <a:pPr algn="l" indent="0" marL="0">
+              <a:buNone/>
+            </a:pPr>
+            <a:r>
+              <a:rPr lang="en-US" sz="1300" dirty="0">
+                <a:solidFill>
+                  <a:schemeClr val="tx1"/>
+                </a:solidFill>
+              </a:rPr>
+              <a:t>Résultat comparé au processus actuel sur au moins un mois.</a:t>
+            </a:r>
+            <a:endParaRPr lang="en-US" sz="1300" dirty="0"/>
+          </a:p>
+        </p:txBody>
+      </p:sp>
+      <p:sp>
+        <p:nvSpPr>
+          <p:cNvPr id="11" name="dod2"/>
+          <p:cNvSpPr/>
+          <p:nvPr/>
+        </p:nvSpPr>
+        <p:spPr>
+          <a:xfrm>
+            <a:off x="8046720" y="1325880"/>
+            <a:ext cx="3566160" cy="2011680"/>
+          </a:xfrm>
+          <a:prstGeom prst="roundRect">
+            <a:avLst>
+              <a:gd name="adj" fmla="val 3636"/>
+            </a:avLst>
+          </a:prstGeom>
+          <a:solidFill>
+            <a:schemeClr val="bg2"/>
+          </a:solidFill>
+          <a:ln w="9525">
+            <a:solidFill>
+              <a:schemeClr val="bg2"/>
+            </a:solidFill>
+            <a:prstDash val="solid"/>
+          </a:ln>
+        </p:spPr>
+      </p:sp>
+      <p:sp>
+        <p:nvSpPr>
+          <p:cNvPr id="12" name="dod2-dot"/>
+          <p:cNvSpPr/>
+          <p:nvPr/>
+        </p:nvSpPr>
+        <p:spPr>
+          <a:xfrm>
+            <a:off x="8247888" y="1545336"/>
+            <a:ext cx="274320" cy="274320"/>
+          </a:xfrm>
+          <a:prstGeom prst="ellipse">
+            <a:avLst/>
+          </a:prstGeom>
+          <a:solidFill>
+            <a:schemeClr val="accent4"/>
+          </a:solidFill>
+          <a:ln w="12700">
+            <a:solidFill>
+              <a:schemeClr val="accent4"/>
+            </a:solidFill>
+            <a:prstDash val="solid"/>
+          </a:ln>
+        </p:spPr>
+      </p:sp>
+      <p:sp>
+        <p:nvSpPr>
+          <p:cNvPr id="13" name="Text 11"/>
+          <p:cNvSpPr txBox="1"/>
+          <p:nvPr/>
+        </p:nvSpPr>
+        <p:spPr>
+          <a:xfrm>
+            <a:off x="8641080" y="1435608"/>
+            <a:ext cx="2834640" cy="457200"/>
+          </a:xfrm>
+          <a:prstGeom prst="rect">
+            <a:avLst/>
+          </a:prstGeom>
+          <a:noFill/>
+          <a:ln/>
+        </p:spPr>
+        <p:txBody>
+          <a:bodyPr wrap="square" lIns="1016" tIns="1016" rIns="1016" bIns="1016" rtlCol="0" anchor="ctr"/>
+          <a:lstStyle/>
+          <a:p>
+            <a:pPr algn="l" indent="0" marL="0">
+              <a:buNone/>
+            </a:pPr>
+            <a:r>
+              <a:rPr lang="en-US" sz="1600" b="1" dirty="0">
+                <a:solidFill>
+                  <a:schemeClr val="tx1"/>
+                </a:solidFill>
+              </a:rPr>
+              <a:t>Revue de sécurité</a:t>
+            </a:r>
+            <a:endParaRPr lang="en-US" sz="1600" dirty="0"/>
+          </a:p>
+        </p:txBody>
+      </p:sp>
+      <p:sp>
+        <p:nvSpPr>
+          <p:cNvPr id="14" name="Text 12"/>
+          <p:cNvSpPr txBox="1"/>
+          <p:nvPr/>
+        </p:nvSpPr>
+        <p:spPr>
+          <a:xfrm>
+            <a:off x="8229600" y="1965960"/>
+            <a:ext cx="3246120" cy="1280160"/>
+          </a:xfrm>
+          <a:prstGeom prst="rect">
+            <a:avLst/>
+          </a:prstGeom>
+          <a:noFill/>
+          <a:ln/>
+        </p:spPr>
+        <p:txBody>
+          <a:bodyPr wrap="square" lIns="1016" tIns="1016" rIns="1016" bIns="1016" rtlCol="0" anchor="t"/>
+          <a:lstStyle/>
+          <a:p>
+            <a:pPr algn="l" indent="0" marL="0">
+              <a:buNone/>
+            </a:pPr>
+            <a:r>
+              <a:rPr lang="en-US" sz="1300" dirty="0">
+                <a:solidFill>
+                  <a:schemeClr val="tx1"/>
+                </a:solidFill>
+              </a:rPr>
+              <a:t>Accès, double regard, données sensibles, fichiers : vérifiés par un pair.</a:t>
+            </a:r>
+            <a:endParaRPr lang="en-US" sz="1300" dirty="0"/>
+          </a:p>
+        </p:txBody>
+      </p:sp>
+      <p:sp>
+        <p:nvSpPr>
+          <p:cNvPr id="15" name="dod3"/>
+          <p:cNvSpPr/>
+          <p:nvPr/>
+        </p:nvSpPr>
+        <p:spPr>
+          <a:xfrm>
+            <a:off x="457200" y="3566160"/>
+            <a:ext cx="3566160" cy="2011680"/>
+          </a:xfrm>
+          <a:prstGeom prst="roundRect">
+            <a:avLst>
+              <a:gd name="adj" fmla="val 3636"/>
+            </a:avLst>
+          </a:prstGeom>
+          <a:solidFill>
+            <a:schemeClr val="bg2"/>
+          </a:solidFill>
+          <a:ln w="9525">
+            <a:solidFill>
+              <a:schemeClr val="bg2"/>
+            </a:solidFill>
+            <a:prstDash val="solid"/>
+          </a:ln>
+        </p:spPr>
+      </p:sp>
+      <p:sp>
+        <p:nvSpPr>
+          <p:cNvPr id="16" name="dod3-dot"/>
+          <p:cNvSpPr/>
+          <p:nvPr/>
+        </p:nvSpPr>
+        <p:spPr>
+          <a:xfrm>
+            <a:off x="658368" y="3785616"/>
+            <a:ext cx="274320" cy="274320"/>
+          </a:xfrm>
+          <a:prstGeom prst="ellipse">
+            <a:avLst/>
+          </a:prstGeom>
+          <a:solidFill>
+            <a:schemeClr val="accent4"/>
+          </a:solidFill>
+          <a:ln w="12700">
+            <a:solidFill>
+              <a:schemeClr val="accent4"/>
+            </a:solidFill>
+            <a:prstDash val="solid"/>
+          </a:ln>
+        </p:spPr>
+      </p:sp>
+      <p:sp>
+        <p:nvSpPr>
+          <p:cNvPr id="17" name="Text 15"/>
+          <p:cNvSpPr txBox="1"/>
+          <p:nvPr/>
+        </p:nvSpPr>
+        <p:spPr>
+          <a:xfrm>
+            <a:off x="1051560" y="3675888"/>
+            <a:ext cx="2834640" cy="457200"/>
+          </a:xfrm>
+          <a:prstGeom prst="rect">
+            <a:avLst/>
+          </a:prstGeom>
+          <a:noFill/>
+          <a:ln/>
+        </p:spPr>
+        <p:txBody>
+          <a:bodyPr wrap="square" lIns="1016" tIns="1016" rIns="1016" bIns="1016" rtlCol="0" anchor="ctr"/>
+          <a:lstStyle/>
+          <a:p>
+            <a:pPr algn="l" indent="0" marL="0">
+              <a:buNone/>
+            </a:pPr>
+            <a:r>
+              <a:rPr lang="en-US" sz="1600" b="1" dirty="0">
+                <a:solidFill>
+                  <a:schemeClr val="tx1"/>
+                </a:solidFill>
+              </a:rPr>
+              <a:t>Configuration validée</a:t>
+            </a:r>
+            <a:endParaRPr lang="en-US" sz="1600" dirty="0"/>
+          </a:p>
+        </p:txBody>
+      </p:sp>
+      <p:sp>
+        <p:nvSpPr>
+          <p:cNvPr id="18" name="Text 16"/>
+          <p:cNvSpPr txBox="1"/>
+          <p:nvPr/>
+        </p:nvSpPr>
+        <p:spPr>
+          <a:xfrm>
+            <a:off x="640080" y="4206240"/>
+            <a:ext cx="3246120" cy="1280160"/>
+          </a:xfrm>
+          <a:prstGeom prst="rect">
+            <a:avLst/>
+          </a:prstGeom>
+          <a:noFill/>
+          <a:ln/>
+        </p:spPr>
+        <p:txBody>
+          <a:bodyPr wrap="square" lIns="1016" tIns="1016" rIns="1016" bIns="1016" rtlCol="0" anchor="t"/>
+          <a:lstStyle/>
+          <a:p>
+            <a:pPr algn="l" indent="0" marL="0">
+              <a:buNone/>
+            </a:pPr>
+            <a:r>
+              <a:rPr lang="en-US" sz="1300" dirty="0">
+                <a:solidFill>
+                  <a:schemeClr val="tx1"/>
+                </a:solidFill>
+              </a:rPr>
+              <a:t>Seuils et listes signés par la conformité ou la finance.</a:t>
+            </a:r>
+            <a:endParaRPr lang="en-US" sz="1300" dirty="0"/>
+          </a:p>
+        </p:txBody>
+      </p:sp>
+      <p:sp>
+        <p:nvSpPr>
+          <p:cNvPr id="19" name="dod4"/>
+          <p:cNvSpPr/>
+          <p:nvPr/>
+        </p:nvSpPr>
+        <p:spPr>
+          <a:xfrm>
+            <a:off x="4251960" y="3566160"/>
+            <a:ext cx="3566160" cy="2011680"/>
+          </a:xfrm>
+          <a:prstGeom prst="roundRect">
+            <a:avLst>
+              <a:gd name="adj" fmla="val 3636"/>
+            </a:avLst>
+          </a:prstGeom>
+          <a:solidFill>
+            <a:schemeClr val="bg2"/>
+          </a:solidFill>
+          <a:ln w="9525">
+            <a:solidFill>
+              <a:schemeClr val="bg2"/>
+            </a:solidFill>
+            <a:prstDash val="solid"/>
+          </a:ln>
+        </p:spPr>
+      </p:sp>
+      <p:sp>
+        <p:nvSpPr>
+          <p:cNvPr id="20" name="dod4-dot"/>
+          <p:cNvSpPr/>
+          <p:nvPr/>
+        </p:nvSpPr>
+        <p:spPr>
+          <a:xfrm>
+            <a:off x="4453128" y="3785616"/>
+            <a:ext cx="274320" cy="274320"/>
+          </a:xfrm>
+          <a:prstGeom prst="ellipse">
+            <a:avLst/>
+          </a:prstGeom>
+          <a:solidFill>
+            <a:schemeClr val="accent4"/>
+          </a:solidFill>
+          <a:ln w="12700">
+            <a:solidFill>
+              <a:schemeClr val="accent4"/>
+            </a:solidFill>
+            <a:prstDash val="solid"/>
+          </a:ln>
+        </p:spPr>
+      </p:sp>
+      <p:sp>
+        <p:nvSpPr>
+          <p:cNvPr id="21" name="Text 19"/>
+          <p:cNvSpPr txBox="1"/>
+          <p:nvPr/>
+        </p:nvSpPr>
+        <p:spPr>
+          <a:xfrm>
+            <a:off x="4846320" y="3675888"/>
+            <a:ext cx="2834640" cy="457200"/>
+          </a:xfrm>
+          <a:prstGeom prst="rect">
+            <a:avLst/>
+          </a:prstGeom>
+          <a:noFill/>
+          <a:ln/>
+        </p:spPr>
+        <p:txBody>
+          <a:bodyPr wrap="square" lIns="1016" tIns="1016" rIns="1016" bIns="1016" rtlCol="0" anchor="ctr"/>
+          <a:lstStyle/>
+          <a:p>
+            <a:pPr algn="l" indent="0" marL="0">
+              <a:buNone/>
+            </a:pPr>
+            <a:r>
+              <a:rPr lang="en-US" sz="1600" b="1" dirty="0">
+                <a:solidFill>
+                  <a:schemeClr val="tx1"/>
+                </a:solidFill>
+              </a:rPr>
+              <a:t>Journal complet</a:t>
+            </a:r>
+            <a:endParaRPr lang="en-US" sz="1600" dirty="0"/>
+          </a:p>
+        </p:txBody>
+      </p:sp>
+      <p:sp>
+        <p:nvSpPr>
+          <p:cNvPr id="22" name="Text 20"/>
+          <p:cNvSpPr txBox="1"/>
+          <p:nvPr/>
+        </p:nvSpPr>
+        <p:spPr>
+          <a:xfrm>
+            <a:off x="4434840" y="4206240"/>
+            <a:ext cx="3246120" cy="1280160"/>
+          </a:xfrm>
+          <a:prstGeom prst="rect">
+            <a:avLst/>
+          </a:prstGeom>
+          <a:noFill/>
+          <a:ln/>
+        </p:spPr>
+        <p:txBody>
+          <a:bodyPr wrap="square" lIns="1016" tIns="1016" rIns="1016" bIns="1016" rtlCol="0" anchor="t"/>
+          <a:lstStyle/>
+          <a:p>
+            <a:pPr algn="l" indent="0" marL="0">
+              <a:buNone/>
+            </a:pPr>
+            <a:r>
+              <a:rPr lang="en-US" sz="1300" dirty="0">
+                <a:solidFill>
+                  <a:schemeClr val="tx1"/>
+                </a:solidFill>
+              </a:rPr>
+              <a:t>Chaque action du module apparaît dans le journal d'audit.</a:t>
+            </a:r>
+            <a:endParaRPr lang="en-US" sz="1300" dirty="0"/>
+          </a:p>
+        </p:txBody>
+      </p:sp>
+      <p:sp>
+        <p:nvSpPr>
+          <p:cNvPr id="23" name="dod5"/>
+          <p:cNvSpPr/>
+          <p:nvPr/>
+        </p:nvSpPr>
+        <p:spPr>
+          <a:xfrm>
+            <a:off x="8046720" y="3566160"/>
+            <a:ext cx="3566160" cy="2011680"/>
+          </a:xfrm>
+          <a:prstGeom prst="roundRect">
+            <a:avLst>
+              <a:gd name="adj" fmla="val 3636"/>
+            </a:avLst>
+          </a:prstGeom>
+          <a:solidFill>
+            <a:schemeClr val="bg2"/>
+          </a:solidFill>
+          <a:ln w="9525">
+            <a:solidFill>
+              <a:schemeClr val="bg2"/>
+            </a:solidFill>
+            <a:prstDash val="solid"/>
+          </a:ln>
+        </p:spPr>
+      </p:sp>
+      <p:sp>
+        <p:nvSpPr>
+          <p:cNvPr id="24" name="dod5-dot"/>
+          <p:cNvSpPr/>
+          <p:nvPr/>
+        </p:nvSpPr>
+        <p:spPr>
+          <a:xfrm>
+            <a:off x="8247888" y="3785616"/>
+            <a:ext cx="274320" cy="274320"/>
+          </a:xfrm>
+          <a:prstGeom prst="ellipse">
+            <a:avLst/>
+          </a:prstGeom>
+          <a:solidFill>
+            <a:schemeClr val="accent4"/>
+          </a:solidFill>
+          <a:ln w="12700">
+            <a:solidFill>
+              <a:schemeClr val="accent4"/>
+            </a:solidFill>
+            <a:prstDash val="solid"/>
+          </a:ln>
+        </p:spPr>
+      </p:sp>
+      <p:sp>
+        <p:nvSpPr>
+          <p:cNvPr id="25" name="Text 23"/>
+          <p:cNvSpPr txBox="1"/>
+          <p:nvPr/>
+        </p:nvSpPr>
+        <p:spPr>
+          <a:xfrm>
+            <a:off x="8641080" y="3675888"/>
+            <a:ext cx="2834640" cy="457200"/>
+          </a:xfrm>
+          <a:prstGeom prst="rect">
+            <a:avLst/>
+          </a:prstGeom>
+          <a:noFill/>
+          <a:ln/>
+        </p:spPr>
+        <p:txBody>
+          <a:bodyPr wrap="square" lIns="1016" tIns="1016" rIns="1016" bIns="1016" rtlCol="0" anchor="ctr"/>
+          <a:lstStyle/>
+          <a:p>
+            <a:pPr algn="l" indent="0" marL="0">
+              <a:buNone/>
+            </a:pPr>
+            <a:r>
+              <a:rPr lang="en-US" sz="1600" b="1" dirty="0">
+                <a:solidFill>
+                  <a:schemeClr val="tx1"/>
+                </a:solidFill>
+              </a:rPr>
+              <a:t>Documentation</a:t>
+            </a:r>
+            <a:endParaRPr lang="en-US" sz="1600" dirty="0"/>
+          </a:p>
+        </p:txBody>
+      </p:sp>
+      <p:sp>
+        <p:nvSpPr>
+          <p:cNvPr id="26" name="Text 24"/>
+          <p:cNvSpPr txBox="1"/>
+          <p:nvPr/>
+        </p:nvSpPr>
+        <p:spPr>
+          <a:xfrm>
+            <a:off x="8229600" y="4206240"/>
+            <a:ext cx="3246120" cy="1280160"/>
+          </a:xfrm>
+          <a:prstGeom prst="rect">
+            <a:avLst/>
+          </a:prstGeom>
+          <a:noFill/>
+          <a:ln/>
+        </p:spPr>
+        <p:txBody>
+          <a:bodyPr wrap="square" lIns="1016" tIns="1016" rIns="1016" bIns="1016" rtlCol="0" anchor="t"/>
+          <a:lstStyle/>
+          <a:p>
+            <a:pPr algn="l" indent="0" marL="0">
+              <a:buNone/>
+            </a:pPr>
+            <a:r>
+              <a:rPr lang="en-US" sz="1300" dirty="0">
+                <a:solidFill>
+                  <a:schemeClr val="tx1"/>
+                </a:solidFill>
+              </a:rPr>
+              <a:t>Spec à jour, paramètres décrits, procédure d'exploitation.</a:t>
+            </a:r>
+            <a:endParaRPr lang="en-US" sz="1300" dirty="0"/>
+          </a:p>
+        </p:txBody>
+      </p:sp>
+      <p:sp>
+        <p:nvSpPr>
+          <p:cNvPr id="25" name="Slide Number Placeholder 0"/>
+          <p:cNvSpPr>
+            <a:spLocks noGrp="1"/>
+          </p:cNvSpPr>
+          <p:nvPr>
+            <p:ph type="sldNum" sz="quarter" idx="4294967295"/>
+          </p:nvPr>
+        </p:nvSpPr>
+        <p:spPr>
+          <a:xfrm>
+            <a:off x="11247120" y="6400800"/>
+            <a:ext cx="457200" cy="274320"/>
+          </a:xfrm>
+          <a:prstGeom prst="rect">
+            <a:avLst/>
+          </a:prstGeom>
+          <a:extLst>
+            <a:ext uri="{C572A759-6A51-4108-AA02-DFA0A04FC94B}">
+              <ma14:wrappingTextBoxFlag xmlns:ma14="http://schemas.microsoft.com/office/mac/drawingml/2011/main" val="0"/>
+            </a:ext>
+          </a:extLst>
+        </p:spPr>
+        <p:txBody>
+          <a:bodyPr/>
+          <a:lstStyle>
+            <a:lvl1pPr>
+              <a:defRPr sz="1000">
+                <a:solidFill>
+                  <a:schemeClr val="tx2"/>
+                </a:solidFill>
+              </a:defRPr>
+            </a:lvl1pPr>
+          </a:lstStyle>
+          <a:p>
+            <a:pPr algn="r"/>
+            <a:fld id="{F7021451-1387-4CA6-816F-3879F97B5CBC}" type="slidenum">
+              <a:rPr b="0" lang="en-US"/>
+              <a:t>13</a:t>
+            </a:fld>
+            <a:endParaRPr lang="en-US"/>
+          </a:p>
+        </p:txBody>
+      </p:sp>
+    </p:spTree>
+  </p:cSld>
+  <p:clrMapOvr>
+    <a:masterClrMapping/>
+  </p:clrMapOvr>
+</p:sld>
+</file>
+
+<file path=ppt/slides/slide14.xml><?xml version="1.0" encoding="utf-8"?>
+<p:sld xmlns:a="http://schemas.openxmlformats.org/drawingml/2006/main" xmlns:r="http://schemas.openxmlformats.org/officeDocument/2006/relationships" xmlns:p="http://schemas.openxmlformats.org/presentationml/2006/main">
+  <p:cSld name="Slide 14">
+    <p:spTree>
+      <p:nvGrpSpPr>
+        <p:cNvPr id="1" name=""/>
+        <p:cNvGrpSpPr/>
+        <p:nvPr/>
+      </p:nvGrpSpPr>
+      <p:grpSpPr>
+        <a:xfrm>
+          <a:off x="0" y="0"/>
+          <a:ext cx="0" cy="0"/>
+          <a:chOff x="0" y="0"/>
+          <a:chExt cx="0" cy="0"/>
+        </a:xfrm>
+      </p:grpSpPr>
+      <p:sp>
+        <p:nvSpPr>
+          <p:cNvPr id="2" name="Text 0"/>
+          <p:cNvSpPr/>
+          <p:nvPr>
+            <p:ph idx="100" type="title" hasCustomPrompt="1"/>
+          </p:nvPr>
+        </p:nvSpPr>
+        <p:spPr>
+          <a:xfrm>
+            <a:off x="457200" y="320040"/>
+            <a:ext cx="11247120" cy="731520"/>
+          </a:xfrm>
+          <a:prstGeom prst="rect">
+            <a:avLst/>
+          </a:prstGeom>
+          <a:noFill/>
+          <a:ln/>
+        </p:spPr>
+        <p:txBody>
+          <a:bodyPr wrap="square" lIns="0" tIns="0" rIns="0" bIns="0" rtlCol="0" anchor="ctr"/>
+          <a:lstStyle/>
+          <a:p>
+            <a:pPr algn="l" indent="0" marL="0">
+              <a:buNone/>
+            </a:pPr>
+            <a:r>
+              <a:rPr lang="en-US" sz="3000" b="1" dirty="0">
+                <a:solidFill>
+                  <a:schemeClr val="tx1"/>
+                </a:solidFill>
+              </a:rPr>
               <a:t>Ce dont l'équipe dépend</a:t>
             </a:r>
             <a:endParaRPr lang="en-US" sz="3000" dirty="0"/>
@@ -6007,7 +6664,7 @@
             <a:pPr algn="r"/>
             <a:fld id="{F7021451-1387-4CA6-816F-3879F97B5CBC}" type="slidenum">
               <a:rPr b="0" lang="en-US"/>
-              <a:t>13</a:t>
+              <a:t>14</a:t>
             </a:fld>
             <a:endParaRPr lang="en-US"/>
           </a:p>
@@ -14365,7 +15022,7 @@
                   <a:schemeClr val="tx1"/>
                 </a:solidFill>
               </a:rPr>
-              <a:t>478 vérifications de référence à reprendre</a:t>
+              <a:t>579 vérifications de référence à reprendre</a:t>
             </a:r>
             <a:endParaRPr lang="en-US" sz="3000" dirty="0"/>
           </a:p>
@@ -14398,7 +15055,7 @@
                 <a:gridCol w="2651760"/>
                 <a:gridCol w="731520"/>
               </a:tblGrid>
-              <a:tr h="429768">
+              <a:tr h="374904">
                 <a:tc>
                   <a:txBody>
                     <a:bodyPr/>
@@ -14604,7 +15261,7 @@
                   </a:tcPr>
                 </a:tc>
               </a:tr>
-              <a:tr h="429768">
+              <a:tr h="374904">
                 <a:tc>
                   <a:txBody>
                     <a:bodyPr/>
@@ -14801,7 +15458,7 @@
                   </a:tcPr>
                 </a:tc>
               </a:tr>
-              <a:tr h="429768">
+              <a:tr h="374904">
                 <a:tc>
                   <a:txBody>
                     <a:bodyPr/>
@@ -14998,7 +15655,204 @@
                   </a:tcPr>
                 </a:tc>
               </a:tr>
-              <a:tr h="429768">
+              <a:tr h="374904">
+                <a:tc>
+                  <a:txBody>
+                    <a:bodyPr/>
+                    <a:lstStyle/>
+                    <a:p>
+                      <a:pPr indent="0" marL="0">
+                        <a:buNone/>
+                      </a:pPr>
+                      <a:r>
+                        <a:rPr lang="en-US" sz="1100" dirty="0">
+                          <a:solidFill>
+                            <a:schemeClr val="tx1"/>
+                          </a:solidFill>
+                          <a:latin typeface="Calibri" pitchFamily="34" charset="0"/>
+                          <a:ea typeface="Calibri" pitchFamily="34" charset="-122"/>
+                          <a:cs typeface="Calibri" pitchFamily="34" charset="-120"/>
+                        </a:rPr>
+                        <a:t>onboarding_approval_test.py</a:t>
+                      </a:r>
+                      <a:endParaRPr lang="en-US" sz="1100" dirty="0">
+                        <a:latin typeface="Calibri" charset="0"/>
+                        <a:ea typeface="Calibri" charset="0"/>
+                        <a:cs typeface="Calibri" charset="0"/>
+                      </a:endParaRPr>
+                    </a:p>
+                  </a:txBody>
+                  <a:tcPr marL="54864" marR="54864" marT="54864" marB="54864" anchor="ctr">
+                    <a:lnL w="6350" cap="flat" cmpd="sng" algn="ctr">
+                      <a:solidFill>
+                        <a:srgbClr val="D5DDE7"/>
+                      </a:solidFill>
+                      <a:prstDash val="solid"/>
+                      <a:round/>
+                      <a:headEnd type="none" w="med" len="med"/>
+                      <a:tailEnd type="none" w="med" len="med"/>
+                    </a:lnL>
+                    <a:lnR w="6350" cap="flat" cmpd="sng" algn="ctr">
+                      <a:solidFill>
+                        <a:srgbClr val="D5DDE7"/>
+                      </a:solidFill>
+                      <a:prstDash val="solid"/>
+                      <a:round/>
+                      <a:headEnd type="none" w="med" len="med"/>
+                      <a:tailEnd type="none" w="med" len="med"/>
+                    </a:lnR>
+                    <a:lnT w="6350" cap="flat" cmpd="sng" algn="ctr">
+                      <a:solidFill>
+                        <a:srgbClr val="D5DDE7"/>
+                      </a:solidFill>
+                      <a:prstDash val="solid"/>
+                      <a:round/>
+                      <a:headEnd type="none" w="med" len="med"/>
+                      <a:tailEnd type="none" w="med" len="med"/>
+                    </a:lnT>
+                    <a:lnB w="6350" cap="flat" cmpd="sng" algn="ctr">
+                      <a:solidFill>
+                        <a:srgbClr val="D5DDE7"/>
+                      </a:solidFill>
+                      <a:prstDash val="solid"/>
+                      <a:round/>
+                      <a:headEnd type="none" w="med" len="med"/>
+                      <a:tailEnd type="none" w="med" len="med"/>
+                    </a:lnB>
+                  </a:tcPr>
+                </a:tc>
+                <a:tc>
+                  <a:txBody>
+                    <a:bodyPr/>
+                    <a:lstStyle/>
+                    <a:p>
+                      <a:pPr indent="0" marL="0">
+                        <a:buNone/>
+                      </a:pPr>
+                      <a:r>
+                        <a:rPr lang="en-US" sz="1200" dirty="0">
+                          <a:solidFill>
+                            <a:schemeClr val="tx1"/>
+                          </a:solidFill>
+                          <a:latin typeface="Calibri" pitchFamily="34" charset="0"/>
+                          <a:ea typeface="Calibri" pitchFamily="34" charset="-122"/>
+                          <a:cs typeface="Calibri" pitchFamily="34" charset="-120"/>
+                        </a:rPr>
+                        <a:t>Approbation KYC, double regard</a:t>
+                      </a:r>
+                      <a:endParaRPr lang="en-US" sz="1200" dirty="0">
+                        <a:latin typeface="Calibri" charset="0"/>
+                        <a:ea typeface="Calibri" charset="0"/>
+                        <a:cs typeface="Calibri" charset="0"/>
+                      </a:endParaRPr>
+                    </a:p>
+                  </a:txBody>
+                  <a:tcPr marL="54864" marR="54864" marT="54864" marB="54864" anchor="ctr">
+                    <a:lnL w="6350" cap="flat" cmpd="sng" algn="ctr">
+                      <a:solidFill>
+                        <a:srgbClr val="D5DDE7"/>
+                      </a:solidFill>
+                      <a:prstDash val="solid"/>
+                      <a:round/>
+                      <a:headEnd type="none" w="med" len="med"/>
+                      <a:tailEnd type="none" w="med" len="med"/>
+                    </a:lnL>
+                    <a:lnR w="6350" cap="flat" cmpd="sng" algn="ctr">
+                      <a:solidFill>
+                        <a:srgbClr val="D5DDE7"/>
+                      </a:solidFill>
+                      <a:prstDash val="solid"/>
+                      <a:round/>
+                      <a:headEnd type="none" w="med" len="med"/>
+                      <a:tailEnd type="none" w="med" len="med"/>
+                    </a:lnR>
+                    <a:lnT w="6350" cap="flat" cmpd="sng" algn="ctr">
+                      <a:solidFill>
+                        <a:srgbClr val="D5DDE7"/>
+                      </a:solidFill>
+                      <a:prstDash val="solid"/>
+                      <a:round/>
+                      <a:headEnd type="none" w="med" len="med"/>
+                      <a:tailEnd type="none" w="med" len="med"/>
+                    </a:lnT>
+                    <a:lnB w="6350" cap="flat" cmpd="sng" algn="ctr">
+                      <a:solidFill>
+                        <a:srgbClr val="D5DDE7"/>
+                      </a:solidFill>
+                      <a:prstDash val="solid"/>
+                      <a:round/>
+                      <a:headEnd type="none" w="med" len="med"/>
+                      <a:tailEnd type="none" w="med" len="med"/>
+                    </a:lnB>
+                  </a:tcPr>
+                </a:tc>
+                <a:tc>
+                  <a:txBody>
+                    <a:bodyPr/>
+                    <a:lstStyle/>
+                    <a:p>
+                      <a:pPr indent="0" marL="0">
+                        <a:buNone/>
+                      </a:pPr>
+                      <a:r>
+                        <a:rPr lang="en-US" sz="1200" b="1" dirty="0">
+                          <a:solidFill>
+                            <a:schemeClr val="tx1"/>
+                          </a:solidFill>
+                          <a:latin typeface="Calibri" pitchFamily="34" charset="0"/>
+                          <a:ea typeface="Calibri" pitchFamily="34" charset="-122"/>
+                          <a:cs typeface="Calibri" pitchFamily="34" charset="-120"/>
+                        </a:rPr>
+                        <a:t>78</a:t>
+                      </a:r>
+                      <a:endParaRPr lang="en-US" sz="1200" dirty="0">
+                        <a:latin typeface="Calibri" charset="0"/>
+                        <a:ea typeface="Calibri" charset="0"/>
+                        <a:cs typeface="Calibri" charset="0"/>
+                      </a:endParaRPr>
+                    </a:p>
+                  </a:txBody>
+                  <a:tcPr marL="54864" marR="54864" marT="54864" marB="54864" anchor="ctr">
+                    <a:lnL w="6350" cap="flat" cmpd="sng" algn="ctr">
+                      <a:solidFill>
+                        <a:srgbClr val="D5DDE7"/>
+                      </a:solidFill>
+                      <a:prstDash val="solid"/>
+                      <a:round/>
+                      <a:headEnd type="none" w="med" len="med"/>
+                      <a:tailEnd type="none" w="med" len="med"/>
+                    </a:lnL>
+                    <a:lnR w="6350" cap="flat" cmpd="sng" algn="ctr">
+                      <a:solidFill>
+                        <a:srgbClr val="D5DDE7"/>
+                      </a:solidFill>
+                      <a:prstDash val="solid"/>
+                      <a:round/>
+                      <a:headEnd type="none" w="med" len="med"/>
+                      <a:tailEnd type="none" w="med" len="med"/>
+                    </a:lnR>
+                    <a:lnT w="6350" cap="flat" cmpd="sng" algn="ctr">
+                      <a:solidFill>
+                        <a:srgbClr val="D5DDE7"/>
+                      </a:solidFill>
+                      <a:prstDash val="solid"/>
+                      <a:round/>
+                      <a:headEnd type="none" w="med" len="med"/>
+                      <a:tailEnd type="none" w="med" len="med"/>
+                    </a:lnT>
+                    <a:lnB w="6350" cap="flat" cmpd="sng" algn="ctr">
+                      <a:solidFill>
+                        <a:srgbClr val="D5DDE7"/>
+                      </a:solidFill>
+                      <a:prstDash val="solid"/>
+                      <a:round/>
+                      <a:headEnd type="none" w="med" len="med"/>
+                      <a:tailEnd type="none" w="med" len="med"/>
+                    </a:lnB>
+                  </a:tcPr>
+                </a:tc>
+              </a:tr>
+              <a:tr h="374904">
                 <a:tc>
                   <a:txBody>
                     <a:bodyPr/>
@@ -15195,7 +16049,7 @@
                   </a:tcPr>
                 </a:tc>
               </a:tr>
-              <a:tr h="429768">
+              <a:tr h="374904">
                 <a:tc>
                   <a:txBody>
                     <a:bodyPr/>
@@ -15392,7 +16246,7 @@
                   </a:tcPr>
                 </a:tc>
               </a:tr>
-              <a:tr h="429768">
+              <a:tr h="374904">
                 <a:tc>
                   <a:txBody>
                     <a:bodyPr/>
@@ -15589,7 +16443,7 @@
                   </a:tcPr>
                 </a:tc>
               </a:tr>
-              <a:tr h="429768">
+              <a:tr h="374904">
                 <a:tc>
                   <a:txBody>
                     <a:bodyPr/>
@@ -15786,7 +16640,7 @@
                   </a:tcPr>
                 </a:tc>
               </a:tr>
-              <a:tr h="429768">
+              <a:tr h="374904">
                 <a:tc>
                   <a:txBody>
                     <a:bodyPr/>
@@ -15983,7 +16837,204 @@
                   </a:tcPr>
                 </a:tc>
               </a:tr>
-              <a:tr h="429768">
+              <a:tr h="374904">
+                <a:tc>
+                  <a:txBody>
+                    <a:bodyPr/>
+                    <a:lstStyle/>
+                    <a:p>
+                      <a:pPr indent="0" marL="0">
+                        <a:buNone/>
+                      </a:pPr>
+                      <a:r>
+                        <a:rPr lang="en-US" sz="1100" dirty="0">
+                          <a:solidFill>
+                            <a:schemeClr val="tx1"/>
+                          </a:solidFill>
+                          <a:latin typeface="Calibri" pitchFamily="34" charset="0"/>
+                          <a:ea typeface="Calibri" pitchFamily="34" charset="-122"/>
+                          <a:cs typeface="Calibri" pitchFamily="34" charset="-120"/>
+                        </a:rPr>
+                        <a:t>staff_2fa_required_test.py</a:t>
+                      </a:r>
+                      <a:endParaRPr lang="en-US" sz="1100" dirty="0">
+                        <a:latin typeface="Calibri" charset="0"/>
+                        <a:ea typeface="Calibri" charset="0"/>
+                        <a:cs typeface="Calibri" charset="0"/>
+                      </a:endParaRPr>
+                    </a:p>
+                  </a:txBody>
+                  <a:tcPr marL="54864" marR="54864" marT="54864" marB="54864" anchor="ctr">
+                    <a:lnL w="6350" cap="flat" cmpd="sng" algn="ctr">
+                      <a:solidFill>
+                        <a:srgbClr val="D5DDE7"/>
+                      </a:solidFill>
+                      <a:prstDash val="solid"/>
+                      <a:round/>
+                      <a:headEnd type="none" w="med" len="med"/>
+                      <a:tailEnd type="none" w="med" len="med"/>
+                    </a:lnL>
+                    <a:lnR w="6350" cap="flat" cmpd="sng" algn="ctr">
+                      <a:solidFill>
+                        <a:srgbClr val="D5DDE7"/>
+                      </a:solidFill>
+                      <a:prstDash val="solid"/>
+                      <a:round/>
+                      <a:headEnd type="none" w="med" len="med"/>
+                      <a:tailEnd type="none" w="med" len="med"/>
+                    </a:lnR>
+                    <a:lnT w="6350" cap="flat" cmpd="sng" algn="ctr">
+                      <a:solidFill>
+                        <a:srgbClr val="D5DDE7"/>
+                      </a:solidFill>
+                      <a:prstDash val="solid"/>
+                      <a:round/>
+                      <a:headEnd type="none" w="med" len="med"/>
+                      <a:tailEnd type="none" w="med" len="med"/>
+                    </a:lnT>
+                    <a:lnB w="6350" cap="flat" cmpd="sng" algn="ctr">
+                      <a:solidFill>
+                        <a:srgbClr val="D5DDE7"/>
+                      </a:solidFill>
+                      <a:prstDash val="solid"/>
+                      <a:round/>
+                      <a:headEnd type="none" w="med" len="med"/>
+                      <a:tailEnd type="none" w="med" len="med"/>
+                    </a:lnB>
+                  </a:tcPr>
+                </a:tc>
+                <a:tc>
+                  <a:txBody>
+                    <a:bodyPr/>
+                    <a:lstStyle/>
+                    <a:p>
+                      <a:pPr indent="0" marL="0">
+                        <a:buNone/>
+                      </a:pPr>
+                      <a:r>
+                        <a:rPr lang="en-US" sz="1200" dirty="0">
+                          <a:solidFill>
+                            <a:schemeClr val="tx1"/>
+                          </a:solidFill>
+                          <a:latin typeface="Calibri" pitchFamily="34" charset="0"/>
+                          <a:ea typeface="Calibri" pitchFamily="34" charset="-122"/>
+                          <a:cs typeface="Calibri" pitchFamily="34" charset="-120"/>
+                        </a:rPr>
+                        <a:t>2FA obligatoire du personnel</a:t>
+                      </a:r>
+                      <a:endParaRPr lang="en-US" sz="1200" dirty="0">
+                        <a:latin typeface="Calibri" charset="0"/>
+                        <a:ea typeface="Calibri" charset="0"/>
+                        <a:cs typeface="Calibri" charset="0"/>
+                      </a:endParaRPr>
+                    </a:p>
+                  </a:txBody>
+                  <a:tcPr marL="54864" marR="54864" marT="54864" marB="54864" anchor="ctr">
+                    <a:lnL w="6350" cap="flat" cmpd="sng" algn="ctr">
+                      <a:solidFill>
+                        <a:srgbClr val="D5DDE7"/>
+                      </a:solidFill>
+                      <a:prstDash val="solid"/>
+                      <a:round/>
+                      <a:headEnd type="none" w="med" len="med"/>
+                      <a:tailEnd type="none" w="med" len="med"/>
+                    </a:lnL>
+                    <a:lnR w="6350" cap="flat" cmpd="sng" algn="ctr">
+                      <a:solidFill>
+                        <a:srgbClr val="D5DDE7"/>
+                      </a:solidFill>
+                      <a:prstDash val="solid"/>
+                      <a:round/>
+                      <a:headEnd type="none" w="med" len="med"/>
+                      <a:tailEnd type="none" w="med" len="med"/>
+                    </a:lnR>
+                    <a:lnT w="6350" cap="flat" cmpd="sng" algn="ctr">
+                      <a:solidFill>
+                        <a:srgbClr val="D5DDE7"/>
+                      </a:solidFill>
+                      <a:prstDash val="solid"/>
+                      <a:round/>
+                      <a:headEnd type="none" w="med" len="med"/>
+                      <a:tailEnd type="none" w="med" len="med"/>
+                    </a:lnT>
+                    <a:lnB w="6350" cap="flat" cmpd="sng" algn="ctr">
+                      <a:solidFill>
+                        <a:srgbClr val="D5DDE7"/>
+                      </a:solidFill>
+                      <a:prstDash val="solid"/>
+                      <a:round/>
+                      <a:headEnd type="none" w="med" len="med"/>
+                      <a:tailEnd type="none" w="med" len="med"/>
+                    </a:lnB>
+                  </a:tcPr>
+                </a:tc>
+                <a:tc>
+                  <a:txBody>
+                    <a:bodyPr/>
+                    <a:lstStyle/>
+                    <a:p>
+                      <a:pPr indent="0" marL="0">
+                        <a:buNone/>
+                      </a:pPr>
+                      <a:r>
+                        <a:rPr lang="en-US" sz="1200" b="1" dirty="0">
+                          <a:solidFill>
+                            <a:schemeClr val="tx1"/>
+                          </a:solidFill>
+                          <a:latin typeface="Calibri" pitchFamily="34" charset="0"/>
+                          <a:ea typeface="Calibri" pitchFamily="34" charset="-122"/>
+                          <a:cs typeface="Calibri" pitchFamily="34" charset="-120"/>
+                        </a:rPr>
+                        <a:t>23</a:t>
+                      </a:r>
+                      <a:endParaRPr lang="en-US" sz="1200" dirty="0">
+                        <a:latin typeface="Calibri" charset="0"/>
+                        <a:ea typeface="Calibri" charset="0"/>
+                        <a:cs typeface="Calibri" charset="0"/>
+                      </a:endParaRPr>
+                    </a:p>
+                  </a:txBody>
+                  <a:tcPr marL="54864" marR="54864" marT="54864" marB="54864" anchor="ctr">
+                    <a:lnL w="6350" cap="flat" cmpd="sng" algn="ctr">
+                      <a:solidFill>
+                        <a:srgbClr val="D5DDE7"/>
+                      </a:solidFill>
+                      <a:prstDash val="solid"/>
+                      <a:round/>
+                      <a:headEnd type="none" w="med" len="med"/>
+                      <a:tailEnd type="none" w="med" len="med"/>
+                    </a:lnL>
+                    <a:lnR w="6350" cap="flat" cmpd="sng" algn="ctr">
+                      <a:solidFill>
+                        <a:srgbClr val="D5DDE7"/>
+                      </a:solidFill>
+                      <a:prstDash val="solid"/>
+                      <a:round/>
+                      <a:headEnd type="none" w="med" len="med"/>
+                      <a:tailEnd type="none" w="med" len="med"/>
+                    </a:lnR>
+                    <a:lnT w="6350" cap="flat" cmpd="sng" algn="ctr">
+                      <a:solidFill>
+                        <a:srgbClr val="D5DDE7"/>
+                      </a:solidFill>
+                      <a:prstDash val="solid"/>
+                      <a:round/>
+                      <a:headEnd type="none" w="med" len="med"/>
+                      <a:tailEnd type="none" w="med" len="med"/>
+                    </a:lnT>
+                    <a:lnB w="6350" cap="flat" cmpd="sng" algn="ctr">
+                      <a:solidFill>
+                        <a:srgbClr val="D5DDE7"/>
+                      </a:solidFill>
+                      <a:prstDash val="solid"/>
+                      <a:round/>
+                      <a:headEnd type="none" w="med" len="med"/>
+                      <a:tailEnd type="none" w="med" len="med"/>
+                    </a:lnB>
+                  </a:tcPr>
+                </a:tc>
+              </a:tr>
+              <a:tr h="374904">
                 <a:tc>
                   <a:txBody>
                     <a:bodyPr/>
@@ -16564,8 +17615,8 @@
         </p:nvSpPr>
         <p:spPr>
           <a:xfrm>
-            <a:off x="457200" y="5257800"/>
-            <a:ext cx="5760720" cy="640080"/>
+            <a:off x="457200" y="5532120"/>
+            <a:ext cx="5760720" cy="457200"/>
           </a:xfrm>
           <a:prstGeom prst="rect">
             <a:avLst/>
@@ -16586,7 +17637,7 @@
                   <a:schemeClr val="tx2"/>
                 </a:solidFill>
               </a:rPr>
-              <a:t>Sept erreurs volontaires dans le code ont toutes été détectées. Données uniquement fictives.</a:t>
+              <a:t>Treize erreurs volontaires dans le code ont toutes été détectées. Données uniquement fictives.</a:t>
             </a:r>
             <a:endParaRPr lang="en-US" sz="1200" dirty="0"/>
           </a:p>

</xml_diff>

<commit_message>
Developer deck: case lifecycle slide states the stricter four-eyes rule
The arrow to 'approved' still read 'approver != analyst'; it now reads
'approver never involved', and the slide notes that approving or
rejecting is refused to whoever created, handled or reassigned the case.

Co-Authored-By: Claude Opus 5.5 <noreply@anthropic.com>
Claude-Session: https://claude.ai/code/session_01ALCBMQrSwdEMnX9x1hQAFX
</commit_message>
<xml_diff>
--- a/outputs/recap/MIPS-vision-developpeurs.pptx
+++ b/outputs/recap/MIPS-vision-developpeurs.pptx
@@ -120,13 +120,13 @@
   <p:extLst>
     <p:ext uri="{521415D9-36F7-43E2-AB2F-B90AF26B5E84}">
       <p14:sectionLst xmlns:p14="http://schemas.microsoft.com/office/powerpoint/2010/main">
-        <p14:section name="Cap" id="{e2f01589-7984-ac72-dbc7-31d09842a99a}">
+        <p14:section name="Cap" id="{eb867828-742d-fa5d-4e9e-612a549a33ec}">
           <p14:sldIdLst>
             <p14:sldId id="256"/>
             <p14:sldId id="257"/>
           </p14:sldIdLst>
         </p14:section>
-        <p14:section name="Architecture" id="{10190852-a49c-09ce-98f3-17411f24427f}">
+        <p14:section name="Architecture" id="{a77d069d-a084-0acf-1372-b0eac5f728a9}">
           <p14:sldIdLst>
             <p14:sldId id="258"/>
             <p14:sldId id="259"/>
@@ -134,20 +134,20 @@
             <p14:sldId id="261"/>
           </p14:sldIdLst>
         </p14:section>
-        <p14:section name="Parcours et données" id="{d38d4a7b-050e-8717-00b4-b861efbf95dd}">
+        <p14:section name="Parcours et données" id="{810cd1b7-bf59-d236-d0d0-23fabe8d118d}">
           <p14:sldIdLst>
             <p14:sldId id="262"/>
             <p14:sldId id="263"/>
           </p14:sldIdLst>
         </p14:section>
-        <p14:section name="Tests et sécurité" id="{e739e27a-27e0-b2f9-af9d-7dd8131af343}">
+        <p14:section name="Tests et sécurité" id="{239a7c0d-3e23-e7fe-f537-4394539d2655}">
           <p14:sldIdLst>
             <p14:sldId id="264"/>
             <p14:sldId id="265"/>
             <p14:sldId id="266"/>
           </p14:sldIdLst>
         </p14:section>
-        <p14:section name="Feuille de route" id="{20ef6c49-3dbf-92c8-4d2d-b3f135feb0ce}">
+        <p14:section name="Feuille de route" id="{4710b7ad-257b-3438-fbd6-09d9c0bf231a}">
           <p14:sldIdLst>
             <p14:sldId id="267"/>
             <p14:sldId id="268"/>
@@ -14080,8 +14080,8 @@
         </p:nvSpPr>
         <p:spPr>
           <a:xfrm>
-            <a:off x="5760720" y="1554480"/>
-            <a:ext cx="1828800" cy="274320"/>
+            <a:off x="5577840" y="1554480"/>
+            <a:ext cx="2194560" cy="274320"/>
           </a:xfrm>
           <a:prstGeom prst="rect">
             <a:avLst/>
@@ -14102,7 +14102,7 @@
                   <a:schemeClr val="tx2"/>
                 </a:solidFill>
               </a:rPr>
-              <a:t>approbateur ≠ analyste</a:t>
+              <a:t>approbateur jamais intervenu</a:t>
             </a:r>
             <a:endParaRPr lang="en-US" sz="1100" dirty="0"/>
           </a:p>
@@ -14274,7 +14274,7 @@
                   <a:schemeClr val="tx1"/>
                 </a:solidFill>
               </a:rPr>
-              <a:t>Approbation refusée tant qu'un blocage existe (8 contrôles) ; on_hold peut revenir en collecte ou en revue</a:t>
+              <a:t>Approbation refusée tant qu'un blocage existe (8 contrôles) ; approbation et rejet interdits à qui a créé, instruit ou réassigné le dossier</a:t>
             </a:r>
             <a:endParaRPr lang="en-US" sz="1300" dirty="0"/>
           </a:p>

</xml_diff>

<commit_message>
Developer deck: 590 reference checks with the ClamAV antivirus suite
Adds antivirus_clamav_test.py to the reference-tests slide, fourteen
deliberate faults, and speaker notes on the test-only signature and the
clamd / freshclam setup for production.

Co-Authored-By: Claude Opus 5.5 <noreply@anthropic.com>
Claude-Session: https://claude.ai/code/session_01ALCBMQrSwdEMnX9x1hQAFX
</commit_message>
<xml_diff>
--- a/outputs/recap/MIPS-vision-developpeurs.pptx
+++ b/outputs/recap/MIPS-vision-developpeurs.pptx
@@ -120,13 +120,13 @@
   <p:extLst>
     <p:ext uri="{521415D9-36F7-43E2-AB2F-B90AF26B5E84}">
       <p14:sectionLst xmlns:p14="http://schemas.microsoft.com/office/powerpoint/2010/main">
-        <p14:section name="Cap" id="{eb867828-742d-fa5d-4e9e-612a549a33ec}">
+        <p14:section name="Cap" id="{338871d1-afc6-7acd-b732-9d1032f04271}">
           <p14:sldIdLst>
             <p14:sldId id="256"/>
             <p14:sldId id="257"/>
           </p14:sldIdLst>
         </p14:section>
-        <p14:section name="Architecture" id="{a77d069d-a084-0acf-1372-b0eac5f728a9}">
+        <p14:section name="Architecture" id="{e8e4fe59-3253-0fe4-3505-6006cb504683}">
           <p14:sldIdLst>
             <p14:sldId id="258"/>
             <p14:sldId id="259"/>
@@ -134,20 +134,20 @@
             <p14:sldId id="261"/>
           </p14:sldIdLst>
         </p14:section>
-        <p14:section name="Parcours et données" id="{810cd1b7-bf59-d236-d0d0-23fabe8d118d}">
+        <p14:section name="Parcours et données" id="{ee327ec1-aae0-c614-4d82-bbccb9eed7e8}">
           <p14:sldIdLst>
             <p14:sldId id="262"/>
             <p14:sldId id="263"/>
           </p14:sldIdLst>
         </p14:section>
-        <p14:section name="Tests et sécurité" id="{239a7c0d-3e23-e7fe-f537-4394539d2655}">
+        <p14:section name="Tests et sécurité" id="{011ddb9b-e7bc-0b12-6fe9-52ec8d5ed452}">
           <p14:sldIdLst>
             <p14:sldId id="264"/>
             <p14:sldId id="265"/>
             <p14:sldId id="266"/>
           </p14:sldIdLst>
         </p14:section>
-        <p14:section name="Feuille de route" id="{4710b7ad-257b-3438-fbd6-09d9c0bf231a}">
+        <p14:section name="Feuille de route" id="{55b0c3b7-40a8-16d6-4f33-73d422986e6f}">
           <p14:sldIdLst>
             <p14:sldId id="267"/>
             <p14:sldId id="268"/>
@@ -910,7 +910,7 @@
           <a:p>
             <a:r>
               <a:rPr lang="en-US" dirty="0"/>
-              <a:t>Les dix suites du prototype (579 vérifications, tests/ dans le dépôt) servent de base : chaque palier reprend les scénarios et les montants attendus de ses suites.</a:t>
+              <a:t>Les onze suites du prototype (590 vérifications, tests/ dans le dépôt) servent de base : chaque palier reprend les scénarios et les montants attendus de ses suites.</a:t>
             </a:r>
             <a:endParaRPr lang="en-US" dirty="0"/>
           </a:p>
@@ -1702,7 +1702,7 @@
           <a:p>
             <a:r>
               <a:rPr lang="en-US" dirty="0"/>
-              <a:t>Les tests prouvent que le code applique les règles figées, pas que ces règles sont les bonnes : unité de somme_totale, remboursements et TVA restent à confirmer par la finance. staff_2fa_required_test.py active la règle « 2FA obligatoire pour admin et finance » le temps de la suite (désactivée ailleurs pour que les autres suites se connectent par mot de passe).</a:t>
+              <a:t>Les tests prouvent que le code applique les règles figées, pas que ces règles sont les bonnes : unité de somme_totale, remboursements et TVA restent à confirmer par la finance. staff_2fa_required_test.py active la règle « 2FA obligatoire pour admin et finance » le temps de la suite (désactivée ailleurs pour que les autres suites se connectent par mot de passe). antivirus_clamav_test.py fait tourner le vrai moteur ClamAV avec une signature de test (EICAR) : les signatures officielles ne sont pas téléchargeables dans l'environnement de test. En production, utiliser le démon clamd (clamdscan --fdpass) plutôt que clamscan, qui recharge toute la base à chaque fichier, et surveiller freshclam : sans signatures, tous les dépôts sont refusés.</a:t>
             </a:r>
             <a:endParaRPr lang="en-US" dirty="0"/>
           </a:p>
@@ -15022,7 +15022,7 @@
                   <a:schemeClr val="tx1"/>
                 </a:solidFill>
               </a:rPr>
-              <a:t>579 vérifications de référence à reprendre</a:t>
+              <a:t>590 vérifications de référence à reprendre</a:t>
             </a:r>
             <a:endParaRPr lang="en-US" sz="3000" dirty="0"/>
           </a:p>
@@ -15055,7 +15055,7 @@
                 <a:gridCol w="2651760"/>
                 <a:gridCol w="731520"/>
               </a:tblGrid>
-              <a:tr h="374904">
+              <a:tr h="347472">
                 <a:tc>
                   <a:txBody>
                     <a:bodyPr/>
@@ -15261,7 +15261,7 @@
                   </a:tcPr>
                 </a:tc>
               </a:tr>
-              <a:tr h="374904">
+              <a:tr h="347472">
                 <a:tc>
                   <a:txBody>
                     <a:bodyPr/>
@@ -15458,7 +15458,7 @@
                   </a:tcPr>
                 </a:tc>
               </a:tr>
-              <a:tr h="374904">
+              <a:tr h="347472">
                 <a:tc>
                   <a:txBody>
                     <a:bodyPr/>
@@ -15655,7 +15655,7 @@
                   </a:tcPr>
                 </a:tc>
               </a:tr>
-              <a:tr h="374904">
+              <a:tr h="347472">
                 <a:tc>
                   <a:txBody>
                     <a:bodyPr/>
@@ -15852,7 +15852,7 @@
                   </a:tcPr>
                 </a:tc>
               </a:tr>
-              <a:tr h="374904">
+              <a:tr h="347472">
                 <a:tc>
                   <a:txBody>
                     <a:bodyPr/>
@@ -16049,7 +16049,7 @@
                   </a:tcPr>
                 </a:tc>
               </a:tr>
-              <a:tr h="374904">
+              <a:tr h="347472">
                 <a:tc>
                   <a:txBody>
                     <a:bodyPr/>
@@ -16246,7 +16246,7 @@
                   </a:tcPr>
                 </a:tc>
               </a:tr>
-              <a:tr h="374904">
+              <a:tr h="347472">
                 <a:tc>
                   <a:txBody>
                     <a:bodyPr/>
@@ -16443,7 +16443,7 @@
                   </a:tcPr>
                 </a:tc>
               </a:tr>
-              <a:tr h="374904">
+              <a:tr h="347472">
                 <a:tc>
                   <a:txBody>
                     <a:bodyPr/>
@@ -16640,7 +16640,7 @@
                   </a:tcPr>
                 </a:tc>
               </a:tr>
-              <a:tr h="374904">
+              <a:tr h="347472">
                 <a:tc>
                   <a:txBody>
                     <a:bodyPr/>
@@ -16837,7 +16837,204 @@
                   </a:tcPr>
                 </a:tc>
               </a:tr>
-              <a:tr h="374904">
+              <a:tr h="347472">
+                <a:tc>
+                  <a:txBody>
+                    <a:bodyPr/>
+                    <a:lstStyle/>
+                    <a:p>
+                      <a:pPr indent="0" marL="0">
+                        <a:buNone/>
+                      </a:pPr>
+                      <a:r>
+                        <a:rPr lang="en-US" sz="1100" dirty="0">
+                          <a:solidFill>
+                            <a:schemeClr val="tx1"/>
+                          </a:solidFill>
+                          <a:latin typeface="Calibri" pitchFamily="34" charset="0"/>
+                          <a:ea typeface="Calibri" pitchFamily="34" charset="-122"/>
+                          <a:cs typeface="Calibri" pitchFamily="34" charset="-120"/>
+                        </a:rPr>
+                        <a:t>antivirus_clamav_test.py</a:t>
+                      </a:r>
+                      <a:endParaRPr lang="en-US" sz="1100" dirty="0">
+                        <a:latin typeface="Calibri" charset="0"/>
+                        <a:ea typeface="Calibri" charset="0"/>
+                        <a:cs typeface="Calibri" charset="0"/>
+                      </a:endParaRPr>
+                    </a:p>
+                  </a:txBody>
+                  <a:tcPr marL="54864" marR="54864" marT="54864" marB="54864" anchor="ctr">
+                    <a:lnL w="6350" cap="flat" cmpd="sng" algn="ctr">
+                      <a:solidFill>
+                        <a:srgbClr val="D5DDE7"/>
+                      </a:solidFill>
+                      <a:prstDash val="solid"/>
+                      <a:round/>
+                      <a:headEnd type="none" w="med" len="med"/>
+                      <a:tailEnd type="none" w="med" len="med"/>
+                    </a:lnL>
+                    <a:lnR w="6350" cap="flat" cmpd="sng" algn="ctr">
+                      <a:solidFill>
+                        <a:srgbClr val="D5DDE7"/>
+                      </a:solidFill>
+                      <a:prstDash val="solid"/>
+                      <a:round/>
+                      <a:headEnd type="none" w="med" len="med"/>
+                      <a:tailEnd type="none" w="med" len="med"/>
+                    </a:lnR>
+                    <a:lnT w="6350" cap="flat" cmpd="sng" algn="ctr">
+                      <a:solidFill>
+                        <a:srgbClr val="D5DDE7"/>
+                      </a:solidFill>
+                      <a:prstDash val="solid"/>
+                      <a:round/>
+                      <a:headEnd type="none" w="med" len="med"/>
+                      <a:tailEnd type="none" w="med" len="med"/>
+                    </a:lnT>
+                    <a:lnB w="6350" cap="flat" cmpd="sng" algn="ctr">
+                      <a:solidFill>
+                        <a:srgbClr val="D5DDE7"/>
+                      </a:solidFill>
+                      <a:prstDash val="solid"/>
+                      <a:round/>
+                      <a:headEnd type="none" w="med" len="med"/>
+                      <a:tailEnd type="none" w="med" len="med"/>
+                    </a:lnB>
+                  </a:tcPr>
+                </a:tc>
+                <a:tc>
+                  <a:txBody>
+                    <a:bodyPr/>
+                    <a:lstStyle/>
+                    <a:p>
+                      <a:pPr indent="0" marL="0">
+                        <a:buNone/>
+                      </a:pPr>
+                      <a:r>
+                        <a:rPr lang="en-US" sz="1200" dirty="0">
+                          <a:solidFill>
+                            <a:schemeClr val="tx1"/>
+                          </a:solidFill>
+                          <a:latin typeface="Calibri" pitchFamily="34" charset="0"/>
+                          <a:ea typeface="Calibri" pitchFamily="34" charset="-122"/>
+                          <a:cs typeface="Calibri" pitchFamily="34" charset="-120"/>
+                        </a:rPr>
+                        <a:t>Antivirus ClamAV (clamscan, clamd)</a:t>
+                      </a:r>
+                      <a:endParaRPr lang="en-US" sz="1200" dirty="0">
+                        <a:latin typeface="Calibri" charset="0"/>
+                        <a:ea typeface="Calibri" charset="0"/>
+                        <a:cs typeface="Calibri" charset="0"/>
+                      </a:endParaRPr>
+                    </a:p>
+                  </a:txBody>
+                  <a:tcPr marL="54864" marR="54864" marT="54864" marB="54864" anchor="ctr">
+                    <a:lnL w="6350" cap="flat" cmpd="sng" algn="ctr">
+                      <a:solidFill>
+                        <a:srgbClr val="D5DDE7"/>
+                      </a:solidFill>
+                      <a:prstDash val="solid"/>
+                      <a:round/>
+                      <a:headEnd type="none" w="med" len="med"/>
+                      <a:tailEnd type="none" w="med" len="med"/>
+                    </a:lnL>
+                    <a:lnR w="6350" cap="flat" cmpd="sng" algn="ctr">
+                      <a:solidFill>
+                        <a:srgbClr val="D5DDE7"/>
+                      </a:solidFill>
+                      <a:prstDash val="solid"/>
+                      <a:round/>
+                      <a:headEnd type="none" w="med" len="med"/>
+                      <a:tailEnd type="none" w="med" len="med"/>
+                    </a:lnR>
+                    <a:lnT w="6350" cap="flat" cmpd="sng" algn="ctr">
+                      <a:solidFill>
+                        <a:srgbClr val="D5DDE7"/>
+                      </a:solidFill>
+                      <a:prstDash val="solid"/>
+                      <a:round/>
+                      <a:headEnd type="none" w="med" len="med"/>
+                      <a:tailEnd type="none" w="med" len="med"/>
+                    </a:lnT>
+                    <a:lnB w="6350" cap="flat" cmpd="sng" algn="ctr">
+                      <a:solidFill>
+                        <a:srgbClr val="D5DDE7"/>
+                      </a:solidFill>
+                      <a:prstDash val="solid"/>
+                      <a:round/>
+                      <a:headEnd type="none" w="med" len="med"/>
+                      <a:tailEnd type="none" w="med" len="med"/>
+                    </a:lnB>
+                  </a:tcPr>
+                </a:tc>
+                <a:tc>
+                  <a:txBody>
+                    <a:bodyPr/>
+                    <a:lstStyle/>
+                    <a:p>
+                      <a:pPr indent="0" marL="0">
+                        <a:buNone/>
+                      </a:pPr>
+                      <a:r>
+                        <a:rPr lang="en-US" sz="1200" b="1" dirty="0">
+                          <a:solidFill>
+                            <a:schemeClr val="tx1"/>
+                          </a:solidFill>
+                          <a:latin typeface="Calibri" pitchFamily="34" charset="0"/>
+                          <a:ea typeface="Calibri" pitchFamily="34" charset="-122"/>
+                          <a:cs typeface="Calibri" pitchFamily="34" charset="-120"/>
+                        </a:rPr>
+                        <a:t>11</a:t>
+                      </a:r>
+                      <a:endParaRPr lang="en-US" sz="1200" dirty="0">
+                        <a:latin typeface="Calibri" charset="0"/>
+                        <a:ea typeface="Calibri" charset="0"/>
+                        <a:cs typeface="Calibri" charset="0"/>
+                      </a:endParaRPr>
+                    </a:p>
+                  </a:txBody>
+                  <a:tcPr marL="54864" marR="54864" marT="54864" marB="54864" anchor="ctr">
+                    <a:lnL w="6350" cap="flat" cmpd="sng" algn="ctr">
+                      <a:solidFill>
+                        <a:srgbClr val="D5DDE7"/>
+                      </a:solidFill>
+                      <a:prstDash val="solid"/>
+                      <a:round/>
+                      <a:headEnd type="none" w="med" len="med"/>
+                      <a:tailEnd type="none" w="med" len="med"/>
+                    </a:lnL>
+                    <a:lnR w="6350" cap="flat" cmpd="sng" algn="ctr">
+                      <a:solidFill>
+                        <a:srgbClr val="D5DDE7"/>
+                      </a:solidFill>
+                      <a:prstDash val="solid"/>
+                      <a:round/>
+                      <a:headEnd type="none" w="med" len="med"/>
+                      <a:tailEnd type="none" w="med" len="med"/>
+                    </a:lnR>
+                    <a:lnT w="6350" cap="flat" cmpd="sng" algn="ctr">
+                      <a:solidFill>
+                        <a:srgbClr val="D5DDE7"/>
+                      </a:solidFill>
+                      <a:prstDash val="solid"/>
+                      <a:round/>
+                      <a:headEnd type="none" w="med" len="med"/>
+                      <a:tailEnd type="none" w="med" len="med"/>
+                    </a:lnT>
+                    <a:lnB w="6350" cap="flat" cmpd="sng" algn="ctr">
+                      <a:solidFill>
+                        <a:srgbClr val="D5DDE7"/>
+                      </a:solidFill>
+                      <a:prstDash val="solid"/>
+                      <a:round/>
+                      <a:headEnd type="none" w="med" len="med"/>
+                      <a:tailEnd type="none" w="med" len="med"/>
+                    </a:lnB>
+                  </a:tcPr>
+                </a:tc>
+              </a:tr>
+              <a:tr h="347472">
                 <a:tc>
                   <a:txBody>
                     <a:bodyPr/>
@@ -17034,7 +17231,7 @@
                   </a:tcPr>
                 </a:tc>
               </a:tr>
-              <a:tr h="374904">
+              <a:tr h="347472">
                 <a:tc>
                   <a:txBody>
                     <a:bodyPr/>
@@ -17637,7 +17834,7 @@
                   <a:schemeClr val="tx2"/>
                 </a:solidFill>
               </a:rPr>
-              <a:t>Treize erreurs volontaires dans le code ont toutes été détectées. Données uniquement fictives.</a:t>
+              <a:t>Quatorze erreurs volontaires dans le code ont toutes été détectées. Données uniquement fictives.</a:t>
             </a:r>
             <a:endParaRPr lang="en-US" sz="1200" dirty="0"/>
           </a:p>

</xml_diff>

<commit_message>
Developer deck: antivirus slide from the ClamAV trials
New slide: recommended clamd setup and exit codes, measured times with
the official signatures (clamscan about 20 s per file, clamd under
0.1 s), freshclam supervision and the Microsoft mirror, and the EICAR
test-file pitfall that explains the suite's own test signature.

Co-Authored-By: Claude Opus 5.5 <noreply@anthropic.com>
Claude-Session: https://claude.ai/code/session_01ALCBMQrSwdEMnX9x1hQAFX
</commit_message>
<xml_diff>
--- a/outputs/recap/MIPS-vision-developpeurs.pptx
+++ b/outputs/recap/MIPS-vision-developpeurs.pptx
@@ -19,9 +19,10 @@
     <p:sldId id="267" r:id="rId13"/>
     <p:sldId id="268" r:id="rId14"/>
     <p:sldId id="269" r:id="rId15"/>
+    <p:sldId id="270" r:id="rId16"/>
   </p:sldIdLst>
   <p:notesMasterIdLst>
-    <p:notesMasterId r:id="rId16"/>
+    <p:notesMasterId r:id="rId17"/>
   </p:notesMasterIdLst>
   <p:sldSz cx="12192000" cy="6858000"/>
   <p:notesSz cx="6858000" cy="12192000"/>
@@ -120,13 +121,13 @@
   <p:extLst>
     <p:ext uri="{521415D9-36F7-43E2-AB2F-B90AF26B5E84}">
       <p14:sectionLst xmlns:p14="http://schemas.microsoft.com/office/powerpoint/2010/main">
-        <p14:section name="Cap" id="{338871d1-afc6-7acd-b732-9d1032f04271}">
+        <p14:section name="Cap" id="{761e4bd1-3225-075a-a688-c2813788f264}">
           <p14:sldIdLst>
             <p14:sldId id="256"/>
             <p14:sldId id="257"/>
           </p14:sldIdLst>
         </p14:section>
-        <p14:section name="Architecture" id="{e8e4fe59-3253-0fe4-3505-6006cb504683}">
+        <p14:section name="Architecture" id="{11bc9e42-9ae5-4109-1c75-c14543a80f4f}">
           <p14:sldIdLst>
             <p14:sldId id="258"/>
             <p14:sldId id="259"/>
@@ -134,24 +135,25 @@
             <p14:sldId id="261"/>
           </p14:sldIdLst>
         </p14:section>
-        <p14:section name="Parcours et données" id="{ee327ec1-aae0-c614-4d82-bbccb9eed7e8}">
+        <p14:section name="Parcours et données" id="{f3c51bea-2802-bbce-9457-05a3fcb3e3a6}">
           <p14:sldIdLst>
             <p14:sldId id="262"/>
             <p14:sldId id="263"/>
           </p14:sldIdLst>
         </p14:section>
-        <p14:section name="Tests et sécurité" id="{011ddb9b-e7bc-0b12-6fe9-52ec8d5ed452}">
+        <p14:section name="Tests et sécurité" id="{6b64b5f6-2057-357c-1bf0-3d64fabf8ade}">
           <p14:sldIdLst>
             <p14:sldId id="264"/>
             <p14:sldId id="265"/>
             <p14:sldId id="266"/>
+            <p14:sldId id="267"/>
           </p14:sldIdLst>
         </p14:section>
-        <p14:section name="Feuille de route" id="{55b0c3b7-40a8-16d6-4f33-73d422986e6f}">
+        <p14:section name="Feuille de route" id="{f8f83038-85be-0057-7c82-018919907920}">
           <p14:sldIdLst>
-            <p14:sldId id="267"/>
             <p14:sldId id="268"/>
             <p14:sldId id="269"/>
+            <p14:sldId id="270"/>
           </p14:sldIdLst>
         </p14:section>
       </p14:sectionLst>
@@ -822,7 +824,7 @@
           <a:p>
             <a:r>
               <a:rPr lang="en-US" dirty="0"/>
-              <a:t/>
+              <a:t>S04d (dossier BoM) a été recapturée avec cette configuration et les signatures officielles : chaque pièce affiche « antivirus OK », soit « aucune signature connue détectée ». Le refus d'une pièce infectée est prouvé par antivirus_clamav_test.py, pas montré à l'écran.</a:t>
             </a:r>
             <a:endParaRPr lang="en-US" dirty="0"/>
           </a:p>
@@ -910,7 +912,7 @@
           <a:p>
             <a:r>
               <a:rPr lang="en-US" dirty="0"/>
-              <a:t>Les onze suites du prototype (590 vérifications, tests/ dans le dépôt) servent de base : chaque palier reprend les scénarios et les montants attendus de ses suites.</a:t>
+              <a:t/>
             </a:r>
             <a:endParaRPr lang="en-US" dirty="0"/>
           </a:p>
@@ -998,7 +1000,7 @@
           <a:p>
             <a:r>
               <a:rPr lang="en-US" dirty="0"/>
-              <a:t/>
+              <a:t>Les onze suites du prototype (590 vérifications, tests/ dans le dépôt) servent de base : chaque palier reprend les scénarios et les montants attendus de ses suites.</a:t>
             </a:r>
             <a:endParaRPr lang="en-US" dirty="0"/>
           </a:p>
@@ -1022,6 +1024,94 @@
             <a:fld id="{F7021451-1387-4CA6-816F-3879F97B5CBC}" type="slidenum">
               <a:rPr lang="en-US"/>
               <a:t>14</a:t>
+            </a:fld>
+            <a:endParaRPr lang="en-US"/>
+          </a:p>
+        </p:txBody>
+      </p:sp>
+    </p:spTree>
+    <p:extLst>
+      <p:ext uri="{BB962C8B-B14F-4D97-AF65-F5344CB8AC3E}">
+        <p14:creationId xmlns:p14="http://schemas.microsoft.com/office/powerpoint/2010/main" val="1024086991"/>
+      </p:ext>
+    </p:extLst>
+  </p:cSld>
+  <p:clrMapOvr>
+    <a:masterClrMapping/>
+  </p:clrMapOvr>
+</p:notes>
+</file>
+
+<file path=ppt/notesSlides/notesSlide15.xml><?xml version="1.0" encoding="utf-8"?>
+<p:notes xmlns:a="http://schemas.openxmlformats.org/drawingml/2006/main" xmlns:r="http://schemas.openxmlformats.org/officeDocument/2006/relationships" xmlns:p="http://schemas.openxmlformats.org/presentationml/2006/main">
+  <p:cSld>
+    <p:spTree>
+      <p:nvGrpSpPr>
+        <p:cNvPr id="1" name=""/>
+        <p:cNvGrpSpPr/>
+        <p:nvPr/>
+      </p:nvGrpSpPr>
+      <p:grpSpPr>
+        <a:xfrm>
+          <a:off x="0" y="0"/>
+          <a:ext cx="0" cy="0"/>
+          <a:chOff x="0" y="0"/>
+          <a:chExt cx="0" cy="0"/>
+        </a:xfrm>
+      </p:grpSpPr>
+      <p:sp>
+        <p:nvSpPr>
+          <p:cNvPr id="2" name="Slide Image Placeholder 1"/>
+          <p:cNvSpPr>
+            <a:spLocks noGrp="1" noRot="1" noChangeAspect="1"/>
+          </p:cNvSpPr>
+          <p:nvPr>
+            <p:ph type="sldImg"/>
+          </p:nvPr>
+        </p:nvSpPr>
+        <p:spPr/>
+      </p:sp>
+      <p:sp>
+        <p:nvSpPr>
+          <p:cNvPr id="3" name="Notes Placeholder 2"/>
+          <p:cNvSpPr>
+            <a:spLocks noGrp="1"/>
+          </p:cNvSpPr>
+          <p:nvPr>
+            <p:ph type="body" idx="1"/>
+          </p:nvPr>
+        </p:nvSpPr>
+        <p:spPr/>
+        <p:txBody>
+          <a:bodyPr/>
+          <a:lstStyle/>
+          <a:p>
+            <a:r>
+              <a:rPr lang="en-US" dirty="0"/>
+              <a:t/>
+            </a:r>
+            <a:endParaRPr lang="en-US" dirty="0"/>
+          </a:p>
+        </p:txBody>
+      </p:sp>
+      <p:sp>
+        <p:nvSpPr>
+          <p:cNvPr id="4" name="Slide Number Placeholder 3"/>
+          <p:cNvSpPr>
+            <a:spLocks noGrp="1"/>
+          </p:cNvSpPr>
+          <p:nvPr>
+            <p:ph type="sldNum" sz="quarter" idx="10"/>
+          </p:nvPr>
+        </p:nvSpPr>
+        <p:spPr/>
+        <p:txBody>
+          <a:bodyPr/>
+          <a:lstStyle/>
+          <a:p>
+            <a:fld id="{F7021451-1387-4CA6-816F-3879F97B5CBC}" type="slidenum">
+              <a:rPr lang="en-US"/>
+              <a:t>15</a:t>
             </a:fld>
             <a:endParaRPr lang="en-US"/>
           </a:p>
@@ -1702,7 +1792,7 @@
           <a:p>
             <a:r>
               <a:rPr lang="en-US" dirty="0"/>
-              <a:t>Les tests prouvent que le code applique les règles figées, pas que ces règles sont les bonnes : unité de somme_totale, remboursements et TVA restent à confirmer par la finance. staff_2fa_required_test.py active la règle « 2FA obligatoire pour admin et finance » le temps de la suite (désactivée ailleurs pour que les autres suites se connectent par mot de passe). antivirus_clamav_test.py fait tourner le vrai moteur ClamAV avec une signature de test (EICAR) : les signatures officielles ne sont pas téléchargeables dans l'environnement de test. En production, utiliser le démon clamd (clamdscan --fdpass) plutôt que clamscan, qui recharge toute la base à chaque fichier, et surveiller freshclam : sans signatures, tous les dépôts sont refusés.</a:t>
+              <a:t>Les tests prouvent que le code applique les règles figées, pas que ces règles sont les bonnes : unité de somme_totale, remboursements et TVA restent à confirmer par la finance. staff_2fa_required_test.py active la règle « 2FA obligatoire pour admin et finance » le temps de la suite (désactivée ailleurs pour que les autres suites se connectent par mot de passe). antivirus_clamav_test.py fait tourner le vrai moteur ClamAV avec sa propre signature de test (EICAR) : voir la diapositive Antivirus pour la raison et la configuration de production.</a:t>
             </a:r>
             <a:endParaRPr lang="en-US" dirty="0"/>
           </a:p>
@@ -3698,7 +3788,7 @@
                   <a:schemeClr val="tx1"/>
                 </a:solidFill>
               </a:rPr>
-              <a:t>Feuille de route proposée, par paliers</a:t>
+              <a:t>Antivirus des pièces : ce que les essais avec ClamAV ont appris</a:t>
             </a:r>
             <a:endParaRPr lang="en-US" sz="3000" dirty="0"/>
           </a:p>
@@ -3706,26 +3796,421 @@
       </p:sp>
       <p:sp>
         <p:nvSpPr>
-          <p:cNvPr id="3" name="ph0"/>
+          <p:cNvPr id="3" name="av1"/>
           <p:cNvSpPr/>
           <p:nvPr/>
         </p:nvSpPr>
         <p:spPr>
           <a:xfrm>
-            <a:off x="457200" y="1463040"/>
-            <a:ext cx="1481328" cy="3566160"/>
+            <a:off x="457200" y="1280160"/>
+            <a:ext cx="5486400" cy="2103120"/>
           </a:xfrm>
           <a:prstGeom prst="roundRect">
             <a:avLst>
-              <a:gd name="adj" fmla="val 4938"/>
+              <a:gd name="adj" fmla="val 3478"/>
             </a:avLst>
           </a:prstGeom>
           <a:solidFill>
-            <a:schemeClr val="accent6">
-              <a:alpha val="12000"/>
-            </a:schemeClr>
+            <a:schemeClr val="bg2"/>
           </a:solidFill>
           <a:ln w="9525">
+            <a:solidFill>
+              <a:schemeClr val="bg2"/>
+            </a:solidFill>
+            <a:prstDash val="solid"/>
+          </a:ln>
+        </p:spPr>
+      </p:sp>
+      <p:sp>
+        <p:nvSpPr>
+          <p:cNvPr id="4" name="av1-dot"/>
+          <p:cNvSpPr/>
+          <p:nvPr/>
+        </p:nvSpPr>
+        <p:spPr>
+          <a:xfrm>
+            <a:off x="658368" y="1499616"/>
+            <a:ext cx="274320" cy="274320"/>
+          </a:xfrm>
+          <a:prstGeom prst="ellipse">
+            <a:avLst/>
+          </a:prstGeom>
+          <a:solidFill>
+            <a:schemeClr val="accent4"/>
+          </a:solidFill>
+          <a:ln w="12700">
+            <a:solidFill>
+              <a:schemeClr val="accent4"/>
+            </a:solidFill>
+            <a:prstDash val="solid"/>
+          </a:ln>
+        </p:spPr>
+      </p:sp>
+      <p:sp>
+        <p:nvSpPr>
+          <p:cNvPr id="5" name="Text 3"/>
+          <p:cNvSpPr txBox="1"/>
+          <p:nvPr/>
+        </p:nvSpPr>
+        <p:spPr>
+          <a:xfrm>
+            <a:off x="1051560" y="1389888"/>
+            <a:ext cx="4754880" cy="457200"/>
+          </a:xfrm>
+          <a:prstGeom prst="rect">
+            <a:avLst/>
+          </a:prstGeom>
+          <a:noFill/>
+          <a:ln/>
+        </p:spPr>
+        <p:txBody>
+          <a:bodyPr wrap="square" lIns="1016" tIns="1016" rIns="1016" bIns="1016" rtlCol="0" anchor="ctr"/>
+          <a:lstStyle/>
+          <a:p>
+            <a:pPr algn="l" indent="0" marL="0">
+              <a:buNone/>
+            </a:pPr>
+            <a:r>
+              <a:rPr lang="en-US" sz="1600" b="1" dirty="0">
+                <a:solidFill>
+                  <a:schemeClr val="tx1"/>
+                </a:solidFill>
+              </a:rPr>
+              <a:t>Configuration recommandée</a:t>
+            </a:r>
+            <a:endParaRPr lang="en-US" sz="1600" dirty="0"/>
+          </a:p>
+        </p:txBody>
+      </p:sp>
+      <p:sp>
+        <p:nvSpPr>
+          <p:cNvPr id="6" name="Text 4"/>
+          <p:cNvSpPr txBox="1"/>
+          <p:nvPr/>
+        </p:nvSpPr>
+        <p:spPr>
+          <a:xfrm>
+            <a:off x="640080" y="1920240"/>
+            <a:ext cx="5166360" cy="1371600"/>
+          </a:xfrm>
+          <a:prstGeom prst="rect">
+            <a:avLst/>
+          </a:prstGeom>
+          <a:noFill/>
+          <a:ln/>
+        </p:spPr>
+        <p:txBody>
+          <a:bodyPr wrap="square" lIns="1016" tIns="1016" rIns="1016" bIns="1016" rtlCol="0" anchor="t"/>
+          <a:lstStyle/>
+          <a:p>
+            <a:pPr algn="l" indent="0" marL="0">
+              <a:buNone/>
+            </a:pPr>
+            <a:r>
+              <a:rPr lang="en-US" sz="1300" dirty="0">
+                <a:solidFill>
+                  <a:schemeClr val="tx1"/>
+                </a:solidFill>
+              </a:rPr>
+              <a:t>Démon clamd + clamdscan --fdpass --no-summary, antivirus rendu obligatoire. Codes de sortie : 0 sain, 1 infecté, autre = erreur, donc refus du dépôt (fail closed).</a:t>
+            </a:r>
+            <a:endParaRPr lang="en-US" sz="1300" dirty="0"/>
+          </a:p>
+        </p:txBody>
+      </p:sp>
+      <p:sp>
+        <p:nvSpPr>
+          <p:cNvPr id="7" name="av2"/>
+          <p:cNvSpPr/>
+          <p:nvPr/>
+        </p:nvSpPr>
+        <p:spPr>
+          <a:xfrm>
+            <a:off x="6217920" y="1280160"/>
+            <a:ext cx="5486400" cy="2103120"/>
+          </a:xfrm>
+          <a:prstGeom prst="roundRect">
+            <a:avLst>
+              <a:gd name="adj" fmla="val 3478"/>
+            </a:avLst>
+          </a:prstGeom>
+          <a:solidFill>
+            <a:schemeClr val="bg2"/>
+          </a:solidFill>
+          <a:ln w="9525">
+            <a:solidFill>
+              <a:schemeClr val="bg2"/>
+            </a:solidFill>
+            <a:prstDash val="solid"/>
+          </a:ln>
+        </p:spPr>
+      </p:sp>
+      <p:sp>
+        <p:nvSpPr>
+          <p:cNvPr id="8" name="av2-dot"/>
+          <p:cNvSpPr/>
+          <p:nvPr/>
+        </p:nvSpPr>
+        <p:spPr>
+          <a:xfrm>
+            <a:off x="6419088" y="1499616"/>
+            <a:ext cx="274320" cy="274320"/>
+          </a:xfrm>
+          <a:prstGeom prst="ellipse">
+            <a:avLst/>
+          </a:prstGeom>
+          <a:solidFill>
+            <a:schemeClr val="accent2"/>
+          </a:solidFill>
+          <a:ln w="12700">
+            <a:solidFill>
+              <a:schemeClr val="accent2"/>
+            </a:solidFill>
+            <a:prstDash val="solid"/>
+          </a:ln>
+        </p:spPr>
+      </p:sp>
+      <p:sp>
+        <p:nvSpPr>
+          <p:cNvPr id="9" name="Text 7"/>
+          <p:cNvSpPr txBox="1"/>
+          <p:nvPr/>
+        </p:nvSpPr>
+        <p:spPr>
+          <a:xfrm>
+            <a:off x="6812280" y="1389888"/>
+            <a:ext cx="4754880" cy="457200"/>
+          </a:xfrm>
+          <a:prstGeom prst="rect">
+            <a:avLst/>
+          </a:prstGeom>
+          <a:noFill/>
+          <a:ln/>
+        </p:spPr>
+        <p:txBody>
+          <a:bodyPr wrap="square" lIns="1016" tIns="1016" rIns="1016" bIns="1016" rtlCol="0" anchor="ctr"/>
+          <a:lstStyle/>
+          <a:p>
+            <a:pPr algn="l" indent="0" marL="0">
+              <a:buNone/>
+            </a:pPr>
+            <a:r>
+              <a:rPr lang="en-US" sz="1600" b="1" dirty="0">
+                <a:solidFill>
+                  <a:schemeClr val="tx1"/>
+                </a:solidFill>
+              </a:rPr>
+              <a:t>Temps mesurés (base officielle, 3,6 M signatures)</a:t>
+            </a:r>
+            <a:endParaRPr lang="en-US" sz="1600" dirty="0"/>
+          </a:p>
+        </p:txBody>
+      </p:sp>
+      <p:sp>
+        <p:nvSpPr>
+          <p:cNvPr id="10" name="Text 8"/>
+          <p:cNvSpPr txBox="1"/>
+          <p:nvPr/>
+        </p:nvSpPr>
+        <p:spPr>
+          <a:xfrm>
+            <a:off x="6400800" y="1920240"/>
+            <a:ext cx="5166360" cy="1371600"/>
+          </a:xfrm>
+          <a:prstGeom prst="rect">
+            <a:avLst/>
+          </a:prstGeom>
+          <a:noFill/>
+          <a:ln/>
+        </p:spPr>
+        <p:txBody>
+          <a:bodyPr wrap="square" lIns="1016" tIns="1016" rIns="1016" bIns="1016" rtlCol="0" anchor="t"/>
+          <a:lstStyle/>
+          <a:p>
+            <a:pPr algn="l" indent="0" marL="0">
+              <a:buNone/>
+            </a:pPr>
+            <a:r>
+              <a:rPr lang="en-US" sz="1300" dirty="0">
+                <a:solidFill>
+                  <a:schemeClr val="tx1"/>
+                </a:solidFill>
+              </a:rPr>
+              <a:t>clamscan : environ 20 s par fichier, la base est rechargée à chaque fois. clamd : moins de 0,1 s, la base est chargée une fois au démarrage.</a:t>
+            </a:r>
+            <a:endParaRPr lang="en-US" sz="1300" dirty="0"/>
+          </a:p>
+        </p:txBody>
+      </p:sp>
+      <p:sp>
+        <p:nvSpPr>
+          <p:cNvPr id="11" name="av3"/>
+          <p:cNvSpPr/>
+          <p:nvPr/>
+        </p:nvSpPr>
+        <p:spPr>
+          <a:xfrm>
+            <a:off x="457200" y="3611880"/>
+            <a:ext cx="5486400" cy="2286000"/>
+          </a:xfrm>
+          <a:prstGeom prst="roundRect">
+            <a:avLst>
+              <a:gd name="adj" fmla="val 3200"/>
+            </a:avLst>
+          </a:prstGeom>
+          <a:solidFill>
+            <a:schemeClr val="bg2"/>
+          </a:solidFill>
+          <a:ln w="9525">
+            <a:solidFill>
+              <a:schemeClr val="bg2"/>
+            </a:solidFill>
+            <a:prstDash val="solid"/>
+          </a:ln>
+        </p:spPr>
+      </p:sp>
+      <p:sp>
+        <p:nvSpPr>
+          <p:cNvPr id="12" name="av3-dot"/>
+          <p:cNvSpPr/>
+          <p:nvPr/>
+        </p:nvSpPr>
+        <p:spPr>
+          <a:xfrm>
+            <a:off x="658368" y="3831336"/>
+            <a:ext cx="274320" cy="274320"/>
+          </a:xfrm>
+          <a:prstGeom prst="ellipse">
+            <a:avLst/>
+          </a:prstGeom>
+          <a:solidFill>
+            <a:schemeClr val="accent5"/>
+          </a:solidFill>
+          <a:ln w="12700">
+            <a:solidFill>
+              <a:schemeClr val="accent5"/>
+            </a:solidFill>
+            <a:prstDash val="solid"/>
+          </a:ln>
+        </p:spPr>
+      </p:sp>
+      <p:sp>
+        <p:nvSpPr>
+          <p:cNvPr id="13" name="Text 11"/>
+          <p:cNvSpPr txBox="1"/>
+          <p:nvPr/>
+        </p:nvSpPr>
+        <p:spPr>
+          <a:xfrm>
+            <a:off x="1051560" y="3721608"/>
+            <a:ext cx="4754880" cy="457200"/>
+          </a:xfrm>
+          <a:prstGeom prst="rect">
+            <a:avLst/>
+          </a:prstGeom>
+          <a:noFill/>
+          <a:ln/>
+        </p:spPr>
+        <p:txBody>
+          <a:bodyPr wrap="square" lIns="1016" tIns="1016" rIns="1016" bIns="1016" rtlCol="0" anchor="ctr"/>
+          <a:lstStyle/>
+          <a:p>
+            <a:pPr algn="l" indent="0" marL="0">
+              <a:buNone/>
+            </a:pPr>
+            <a:r>
+              <a:rPr lang="en-US" sz="1600" b="1" dirty="0">
+                <a:solidFill>
+                  <a:schemeClr val="tx1"/>
+                </a:solidFill>
+              </a:rPr>
+              <a:t>Signatures</a:t>
+            </a:r>
+            <a:endParaRPr lang="en-US" sz="1600" dirty="0"/>
+          </a:p>
+        </p:txBody>
+      </p:sp>
+      <p:sp>
+        <p:nvSpPr>
+          <p:cNvPr id="14" name="Text 12"/>
+          <p:cNvSpPr txBox="1"/>
+          <p:nvPr/>
+        </p:nvSpPr>
+        <p:spPr>
+          <a:xfrm>
+            <a:off x="640080" y="4251960"/>
+            <a:ext cx="5166360" cy="1554480"/>
+          </a:xfrm>
+          <a:prstGeom prst="rect">
+            <a:avLst/>
+          </a:prstGeom>
+          <a:noFill/>
+          <a:ln/>
+        </p:spPr>
+        <p:txBody>
+          <a:bodyPr wrap="square" lIns="1016" tIns="1016" rIns="1016" bIns="1016" rtlCol="0" anchor="t"/>
+          <a:lstStyle/>
+          <a:p>
+            <a:pPr algn="l" indent="0" marL="0">
+              <a:buNone/>
+            </a:pPr>
+            <a:r>
+              <a:rPr lang="en-US" sz="1300" dirty="0">
+                <a:solidFill>
+                  <a:schemeClr val="tx1"/>
+                </a:solidFill>
+              </a:rPr>
+              <a:t>freshclam à superviser : sans signatures, tous les dépôts sont refusés (testé). Le serveur officiel a refusé l'environnement de test ; le miroir ClamAV de Microsoft (packages.microsoft.com/clamav) a servi, signatures vérifiées par sigtool.</a:t>
+            </a:r>
+            <a:endParaRPr lang="en-US" sz="1300" dirty="0"/>
+          </a:p>
+        </p:txBody>
+      </p:sp>
+      <p:sp>
+        <p:nvSpPr>
+          <p:cNvPr id="15" name="av4"/>
+          <p:cNvSpPr/>
+          <p:nvPr/>
+        </p:nvSpPr>
+        <p:spPr>
+          <a:xfrm>
+            <a:off x="6217920" y="3611880"/>
+            <a:ext cx="5486400" cy="2286000"/>
+          </a:xfrm>
+          <a:prstGeom prst="roundRect">
+            <a:avLst>
+              <a:gd name="adj" fmla="val 3200"/>
+            </a:avLst>
+          </a:prstGeom>
+          <a:solidFill>
+            <a:schemeClr val="bg2"/>
+          </a:solidFill>
+          <a:ln w="9525">
+            <a:solidFill>
+              <a:schemeClr val="bg2"/>
+            </a:solidFill>
+            <a:prstDash val="solid"/>
+          </a:ln>
+        </p:spPr>
+      </p:sp>
+      <p:sp>
+        <p:nvSpPr>
+          <p:cNvPr id="16" name="av4-dot"/>
+          <p:cNvSpPr/>
+          <p:nvPr/>
+        </p:nvSpPr>
+        <p:spPr>
+          <a:xfrm>
+            <a:off x="6419088" y="3831336"/>
+            <a:ext cx="274320" cy="274320"/>
+          </a:xfrm>
+          <a:prstGeom prst="ellipse">
+            <a:avLst/>
+          </a:prstGeom>
+          <a:solidFill>
+            <a:schemeClr val="accent6"/>
+          </a:solidFill>
+          <a:ln w="12700">
             <a:solidFill>
               <a:schemeClr val="accent6"/>
             </a:solidFill>
@@ -3735,473 +4220,14 @@
       </p:sp>
       <p:sp>
         <p:nvSpPr>
-          <p:cNvPr id="4" name="Text 2"/>
-          <p:cNvSpPr txBox="1"/>
-          <p:nvPr/>
-        </p:nvSpPr>
-        <p:spPr>
-          <a:xfrm>
-            <a:off x="548640" y="1554480"/>
-            <a:ext cx="1280160" cy="640080"/>
-          </a:xfrm>
-          <a:prstGeom prst="rect">
-            <a:avLst/>
-          </a:prstGeom>
-          <a:noFill/>
-          <a:ln/>
-        </p:spPr>
-        <p:txBody>
-          <a:bodyPr wrap="square" lIns="1016" tIns="1016" rIns="1016" bIns="1016" rtlCol="0" anchor="t"/>
-          <a:lstStyle/>
-          <a:p>
-            <a:pPr algn="l" indent="0" marL="0">
-              <a:buNone/>
-            </a:pPr>
-            <a:r>
-              <a:rPr lang="en-US" sz="3400" b="1" dirty="0">
-                <a:solidFill>
-                  <a:schemeClr val="accent6"/>
-                </a:solidFill>
-                <a:latin typeface="Cambria" pitchFamily="34" charset="0"/>
-                <a:ea typeface="Cambria" pitchFamily="34" charset="-122"/>
-                <a:cs typeface="Cambria" pitchFamily="34" charset="-120"/>
-              </a:rPr>
-              <a:t>0</a:t>
-            </a:r>
-            <a:endParaRPr lang="en-US" sz="3400" dirty="0"/>
-          </a:p>
-        </p:txBody>
-      </p:sp>
-      <p:sp>
-        <p:nvSpPr>
-          <p:cNvPr id="5" name="Text 3"/>
-          <p:cNvSpPr txBox="1"/>
-          <p:nvPr/>
-        </p:nvSpPr>
-        <p:spPr>
-          <a:xfrm>
-            <a:off x="548640" y="2240280"/>
-            <a:ext cx="1325880" cy="822960"/>
-          </a:xfrm>
-          <a:prstGeom prst="rect">
-            <a:avLst/>
-          </a:prstGeom>
-          <a:noFill/>
-          <a:ln/>
-        </p:spPr>
-        <p:txBody>
-          <a:bodyPr wrap="square" lIns="1016" tIns="1016" rIns="1016" bIns="1016" rtlCol="0" anchor="t"/>
-          <a:lstStyle/>
-          <a:p>
-            <a:pPr algn="l" indent="0" marL="0">
-              <a:buNone/>
-            </a:pPr>
-            <a:r>
-              <a:rPr lang="en-US" sz="1400" b="1" dirty="0">
-                <a:solidFill>
-                  <a:schemeClr val="tx1"/>
-                </a:solidFill>
-              </a:rPr>
-              <a:t>Décisions</a:t>
-            </a:r>
-            <a:endParaRPr lang="en-US" sz="1400" dirty="0"/>
-          </a:p>
-        </p:txBody>
-      </p:sp>
-      <p:sp>
-        <p:nvSpPr>
-          <p:cNvPr id="6" name="Text 4"/>
-          <p:cNvSpPr txBox="1"/>
-          <p:nvPr/>
-        </p:nvSpPr>
-        <p:spPr>
-          <a:xfrm>
-            <a:off x="548640" y="3063240"/>
-            <a:ext cx="1325880" cy="1874520"/>
-          </a:xfrm>
-          <a:prstGeom prst="rect">
-            <a:avLst/>
-          </a:prstGeom>
-          <a:noFill/>
-          <a:ln/>
-        </p:spPr>
-        <p:txBody>
-          <a:bodyPr wrap="square" lIns="1016" tIns="1016" rIns="1016" bIns="1016" rtlCol="0" anchor="t"/>
-          <a:lstStyle/>
-          <a:p>
-            <a:pPr algn="l" indent="0" marL="0">
-              <a:buNone/>
-            </a:pPr>
-            <a:r>
-              <a:rPr lang="en-US" sz="1200" dirty="0">
-                <a:solidFill>
-                  <a:schemeClr val="tx1"/>
-                </a:solidFill>
-              </a:rPr>
-              <a:t>Modèle A ou B · textes BoM · seuils KYC · texte des CGU</a:t>
-            </a:r>
-            <a:endParaRPr lang="en-US" sz="1200" dirty="0"/>
-          </a:p>
-        </p:txBody>
-      </p:sp>
-      <p:sp>
-        <p:nvSpPr>
-          <p:cNvPr id="7" name="ph1"/>
-          <p:cNvSpPr/>
-          <p:nvPr/>
-        </p:nvSpPr>
-        <p:spPr>
-          <a:xfrm>
-            <a:off x="2075688" y="1463040"/>
-            <a:ext cx="1481328" cy="3566160"/>
-          </a:xfrm>
-          <a:prstGeom prst="roundRect">
-            <a:avLst>
-              <a:gd name="adj" fmla="val 4938"/>
-            </a:avLst>
-          </a:prstGeom>
-          <a:solidFill>
-            <a:schemeClr val="accent2">
-              <a:alpha val="12000"/>
-            </a:schemeClr>
-          </a:solidFill>
-          <a:ln w="9525">
-            <a:solidFill>
-              <a:schemeClr val="accent2"/>
-            </a:solidFill>
-            <a:prstDash val="solid"/>
-          </a:ln>
-        </p:spPr>
-      </p:sp>
-      <p:sp>
-        <p:nvSpPr>
-          <p:cNvPr id="8" name="Text 6"/>
-          <p:cNvSpPr txBox="1"/>
-          <p:nvPr/>
-        </p:nvSpPr>
-        <p:spPr>
-          <a:xfrm>
-            <a:off x="2167128" y="1554480"/>
-            <a:ext cx="1280160" cy="640080"/>
-          </a:xfrm>
-          <a:prstGeom prst="rect">
-            <a:avLst/>
-          </a:prstGeom>
-          <a:noFill/>
-          <a:ln/>
-        </p:spPr>
-        <p:txBody>
-          <a:bodyPr wrap="square" lIns="1016" tIns="1016" rIns="1016" bIns="1016" rtlCol="0" anchor="t"/>
-          <a:lstStyle/>
-          <a:p>
-            <a:pPr algn="l" indent="0" marL="0">
-              <a:buNone/>
-            </a:pPr>
-            <a:r>
-              <a:rPr lang="en-US" sz="3400" b="1" dirty="0">
-                <a:solidFill>
-                  <a:schemeClr val="accent2"/>
-                </a:solidFill>
-                <a:latin typeface="Cambria" pitchFamily="34" charset="0"/>
-                <a:ea typeface="Cambria" pitchFamily="34" charset="-122"/>
-                <a:cs typeface="Cambria" pitchFamily="34" charset="-120"/>
-              </a:rPr>
-              <a:t>1</a:t>
-            </a:r>
-            <a:endParaRPr lang="en-US" sz="3400" dirty="0"/>
-          </a:p>
-        </p:txBody>
-      </p:sp>
-      <p:sp>
-        <p:nvSpPr>
-          <p:cNvPr id="9" name="Text 7"/>
-          <p:cNvSpPr txBox="1"/>
-          <p:nvPr/>
-        </p:nvSpPr>
-        <p:spPr>
-          <a:xfrm>
-            <a:off x="2167128" y="2240280"/>
-            <a:ext cx="1325880" cy="822960"/>
-          </a:xfrm>
-          <a:prstGeom prst="rect">
-            <a:avLst/>
-          </a:prstGeom>
-          <a:noFill/>
-          <a:ln/>
-        </p:spPr>
-        <p:txBody>
-          <a:bodyPr wrap="square" lIns="1016" tIns="1016" rIns="1016" bIns="1016" rtlCol="0" anchor="t"/>
-          <a:lstStyle/>
-          <a:p>
-            <a:pPr algn="l" indent="0" marL="0">
-              <a:buNone/>
-            </a:pPr>
-            <a:r>
-              <a:rPr lang="en-US" sz="1400" b="1" dirty="0">
-                <a:solidFill>
-                  <a:schemeClr val="tx1"/>
-                </a:solidFill>
-              </a:rPr>
-              <a:t>Socle</a:t>
-            </a:r>
-            <a:endParaRPr lang="en-US" sz="1400" dirty="0"/>
-          </a:p>
-        </p:txBody>
-      </p:sp>
-      <p:sp>
-        <p:nvSpPr>
-          <p:cNvPr id="10" name="Text 8"/>
-          <p:cNvSpPr txBox="1"/>
-          <p:nvPr/>
-        </p:nvSpPr>
-        <p:spPr>
-          <a:xfrm>
-            <a:off x="2167128" y="3063240"/>
-            <a:ext cx="1325880" cy="1874520"/>
-          </a:xfrm>
-          <a:prstGeom prst="rect">
-            <a:avLst/>
-          </a:prstGeom>
-          <a:noFill/>
-          <a:ln/>
-        </p:spPr>
-        <p:txBody>
-          <a:bodyPr wrap="square" lIns="1016" tIns="1016" rIns="1016" bIns="1016" rtlCol="0" anchor="t"/>
-          <a:lstStyle/>
-          <a:p>
-            <a:pPr algn="l" indent="0" marL="0">
-              <a:buNone/>
-            </a:pPr>
-            <a:r>
-              <a:rPr lang="en-US" sz="1200" dirty="0">
-                <a:solidFill>
-                  <a:schemeClr val="tx1"/>
-                </a:solidFill>
-              </a:rPr>
-              <a:t>Auth, 2FA, rôles, audit, sessions séparées</a:t>
-            </a:r>
-            <a:endParaRPr lang="en-US" sz="1200" dirty="0"/>
-          </a:p>
-        </p:txBody>
-      </p:sp>
-      <p:sp>
-        <p:nvSpPr>
-          <p:cNvPr id="11" name="ph2"/>
-          <p:cNvSpPr/>
-          <p:nvPr/>
-        </p:nvSpPr>
-        <p:spPr>
-          <a:xfrm>
-            <a:off x="3694176" y="1463040"/>
-            <a:ext cx="1481328" cy="3566160"/>
-          </a:xfrm>
-          <a:prstGeom prst="roundRect">
-            <a:avLst>
-              <a:gd name="adj" fmla="val 4938"/>
-            </a:avLst>
-          </a:prstGeom>
-          <a:solidFill>
-            <a:schemeClr val="accent2">
-              <a:alpha val="12000"/>
-            </a:schemeClr>
-          </a:solidFill>
-          <a:ln w="9525">
-            <a:solidFill>
-              <a:schemeClr val="accent2"/>
-            </a:solidFill>
-            <a:prstDash val="solid"/>
-          </a:ln>
-        </p:spPr>
-      </p:sp>
-      <p:sp>
-        <p:nvSpPr>
-          <p:cNvPr id="12" name="Text 10"/>
-          <p:cNvSpPr txBox="1"/>
-          <p:nvPr/>
-        </p:nvSpPr>
-        <p:spPr>
-          <a:xfrm>
-            <a:off x="3785616" y="1554480"/>
-            <a:ext cx="1280160" cy="640080"/>
-          </a:xfrm>
-          <a:prstGeom prst="rect">
-            <a:avLst/>
-          </a:prstGeom>
-          <a:noFill/>
-          <a:ln/>
-        </p:spPr>
-        <p:txBody>
-          <a:bodyPr wrap="square" lIns="1016" tIns="1016" rIns="1016" bIns="1016" rtlCol="0" anchor="t"/>
-          <a:lstStyle/>
-          <a:p>
-            <a:pPr algn="l" indent="0" marL="0">
-              <a:buNone/>
-            </a:pPr>
-            <a:r>
-              <a:rPr lang="en-US" sz="3400" b="1" dirty="0">
-                <a:solidFill>
-                  <a:schemeClr val="accent2"/>
-                </a:solidFill>
-                <a:latin typeface="Cambria" pitchFamily="34" charset="0"/>
-                <a:ea typeface="Cambria" pitchFamily="34" charset="-122"/>
-                <a:cs typeface="Cambria" pitchFamily="34" charset="-120"/>
-              </a:rPr>
-              <a:t>2</a:t>
-            </a:r>
-            <a:endParaRPr lang="en-US" sz="3400" dirty="0"/>
-          </a:p>
-        </p:txBody>
-      </p:sp>
-      <p:sp>
-        <p:nvSpPr>
-          <p:cNvPr id="13" name="Text 11"/>
-          <p:cNvSpPr txBox="1"/>
-          <p:nvPr/>
-        </p:nvSpPr>
-        <p:spPr>
-          <a:xfrm>
-            <a:off x="3785616" y="2240280"/>
-            <a:ext cx="1325880" cy="822960"/>
-          </a:xfrm>
-          <a:prstGeom prst="rect">
-            <a:avLst/>
-          </a:prstGeom>
-          <a:noFill/>
-          <a:ln/>
-        </p:spPr>
-        <p:txBody>
-          <a:bodyPr wrap="square" lIns="1016" tIns="1016" rIns="1016" bIns="1016" rtlCol="0" anchor="t"/>
-          <a:lstStyle/>
-          <a:p>
-            <a:pPr algn="l" indent="0" marL="0">
-              <a:buNone/>
-            </a:pPr>
-            <a:r>
-              <a:rPr lang="en-US" sz="1400" b="1" dirty="0">
-                <a:solidFill>
-                  <a:schemeClr val="tx1"/>
-                </a:solidFill>
-              </a:rPr>
-              <a:t>Reporting et facturation</a:t>
-            </a:r>
-            <a:endParaRPr lang="en-US" sz="1400" dirty="0"/>
-          </a:p>
-        </p:txBody>
-      </p:sp>
-      <p:sp>
-        <p:nvSpPr>
-          <p:cNvPr id="14" name="Text 12"/>
-          <p:cNvSpPr txBox="1"/>
-          <p:nvPr/>
-        </p:nvSpPr>
-        <p:spPr>
-          <a:xfrm>
-            <a:off x="3785616" y="3063240"/>
-            <a:ext cx="1325880" cy="1874520"/>
-          </a:xfrm>
-          <a:prstGeom prst="rect">
-            <a:avLst/>
-          </a:prstGeom>
-          <a:noFill/>
-          <a:ln/>
-        </p:spPr>
-        <p:txBody>
-          <a:bodyPr wrap="square" lIns="1016" tIns="1016" rIns="1016" bIns="1016" rtlCol="0" anchor="t"/>
-          <a:lstStyle/>
-          <a:p>
-            <a:pPr algn="l" indent="0" marL="0">
-              <a:buNone/>
-            </a:pPr>
-            <a:r>
-              <a:rPr lang="en-US" sz="1200" dirty="0">
-                <a:solidFill>
-                  <a:schemeClr val="tx1"/>
-                </a:solidFill>
-              </a:rPr>
-              <a:t>Import, rapport, Excel, BigQuery, factures</a:t>
-            </a:r>
-            <a:endParaRPr lang="en-US" sz="1200" dirty="0"/>
-          </a:p>
-        </p:txBody>
-      </p:sp>
-      <p:sp>
-        <p:nvSpPr>
-          <p:cNvPr id="15" name="ph3"/>
-          <p:cNvSpPr/>
-          <p:nvPr/>
-        </p:nvSpPr>
-        <p:spPr>
-          <a:xfrm>
-            <a:off x="5312664" y="1463040"/>
-            <a:ext cx="1481328" cy="3566160"/>
-          </a:xfrm>
-          <a:prstGeom prst="roundRect">
-            <a:avLst>
-              <a:gd name="adj" fmla="val 4938"/>
-            </a:avLst>
-          </a:prstGeom>
-          <a:solidFill>
-            <a:schemeClr val="accent1">
-              <a:alpha val="12000"/>
-            </a:schemeClr>
-          </a:solidFill>
-          <a:ln w="9525">
-            <a:solidFill>
-              <a:schemeClr val="accent1"/>
-            </a:solidFill>
-            <a:prstDash val="solid"/>
-          </a:ln>
-        </p:spPr>
-      </p:sp>
-      <p:sp>
-        <p:nvSpPr>
-          <p:cNvPr id="16" name="Text 14"/>
-          <p:cNvSpPr txBox="1"/>
-          <p:nvPr/>
-        </p:nvSpPr>
-        <p:spPr>
-          <a:xfrm>
-            <a:off x="5404104" y="1554480"/>
-            <a:ext cx="1280160" cy="640080"/>
-          </a:xfrm>
-          <a:prstGeom prst="rect">
-            <a:avLst/>
-          </a:prstGeom>
-          <a:noFill/>
-          <a:ln/>
-        </p:spPr>
-        <p:txBody>
-          <a:bodyPr wrap="square" lIns="1016" tIns="1016" rIns="1016" bIns="1016" rtlCol="0" anchor="t"/>
-          <a:lstStyle/>
-          <a:p>
-            <a:pPr algn="l" indent="0" marL="0">
-              <a:buNone/>
-            </a:pPr>
-            <a:r>
-              <a:rPr lang="en-US" sz="3400" b="1" dirty="0">
-                <a:solidFill>
-                  <a:schemeClr val="accent1"/>
-                </a:solidFill>
-                <a:latin typeface="Cambria" pitchFamily="34" charset="0"/>
-                <a:ea typeface="Cambria" pitchFamily="34" charset="-122"/>
-                <a:cs typeface="Cambria" pitchFamily="34" charset="-120"/>
-              </a:rPr>
-              <a:t>3</a:t>
-            </a:r>
-            <a:endParaRPr lang="en-US" sz="3400" dirty="0"/>
-          </a:p>
-        </p:txBody>
-      </p:sp>
-      <p:sp>
-        <p:nvSpPr>
           <p:cNvPr id="17" name="Text 15"/>
           <p:cNvSpPr txBox="1"/>
           <p:nvPr/>
         </p:nvSpPr>
         <p:spPr>
           <a:xfrm>
-            <a:off x="5404104" y="2240280"/>
-            <a:ext cx="1325880" cy="822960"/>
+            <a:off x="6812280" y="3721608"/>
+            <a:ext cx="4754880" cy="457200"/>
           </a:xfrm>
           <a:prstGeom prst="rect">
             <a:avLst/>
@@ -4210,21 +4236,21 @@
           <a:ln/>
         </p:spPr>
         <p:txBody>
-          <a:bodyPr wrap="square" lIns="1016" tIns="1016" rIns="1016" bIns="1016" rtlCol="0" anchor="t"/>
+          <a:bodyPr wrap="square" lIns="1016" tIns="1016" rIns="1016" bIns="1016" rtlCol="0" anchor="ctr"/>
           <a:lstStyle/>
           <a:p>
             <a:pPr algn="l" indent="0" marL="0">
               <a:buNone/>
             </a:pPr>
             <a:r>
-              <a:rPr lang="en-US" sz="1400" b="1" dirty="0">
+              <a:rPr lang="en-US" sz="1600" b="1" dirty="0">
                 <a:solidFill>
                   <a:schemeClr val="tx1"/>
                 </a:solidFill>
               </a:rPr>
-              <a:t>Marchands et KYC</a:t>
-            </a:r>
-            <a:endParaRPr lang="en-US" sz="1400" dirty="0"/>
+              <a:t>Piège pour les tests</a:t>
+            </a:r>
+            <a:endParaRPr lang="en-US" sz="1600" dirty="0"/>
           </a:p>
         </p:txBody>
       </p:sp>
@@ -4236,8 +4262,8 @@
         </p:nvSpPr>
         <p:spPr>
           <a:xfrm>
-            <a:off x="5404104" y="3063240"/>
-            <a:ext cx="1325880" cy="1874520"/>
+            <a:off x="6400800" y="4251960"/>
+            <a:ext cx="5166360" cy="1554480"/>
           </a:xfrm>
           <a:prstGeom prst="rect">
             <a:avLst/>
@@ -4253,470 +4279,14 @@
               <a:buNone/>
             </a:pPr>
             <a:r>
-              <a:rPr lang="en-US" sz="1200" dirty="0">
+              <a:rPr lang="en-US" sz="1300" dirty="0">
                 <a:solidFill>
                   <a:schemeClr val="tx1"/>
                 </a:solidFill>
               </a:rPr>
-              <a:t>Fiche marchand, dossier KYC, double regard, relances</a:t>
-            </a:r>
-            <a:endParaRPr lang="en-US" sz="1200" dirty="0"/>
-          </a:p>
-        </p:txBody>
-      </p:sp>
-      <p:sp>
-        <p:nvSpPr>
-          <p:cNvPr id="19" name="ph4"/>
-          <p:cNvSpPr/>
-          <p:nvPr/>
-        </p:nvSpPr>
-        <p:spPr>
-          <a:xfrm>
-            <a:off x="6931152" y="1463040"/>
-            <a:ext cx="1481328" cy="3566160"/>
-          </a:xfrm>
-          <a:prstGeom prst="roundRect">
-            <a:avLst>
-              <a:gd name="adj" fmla="val 4938"/>
-            </a:avLst>
-          </a:prstGeom>
-          <a:solidFill>
-            <a:schemeClr val="accent3">
-              <a:alpha val="12000"/>
-            </a:schemeClr>
-          </a:solidFill>
-          <a:ln w="9525">
-            <a:solidFill>
-              <a:schemeClr val="accent3"/>
-            </a:solidFill>
-            <a:prstDash val="solid"/>
-          </a:ln>
-        </p:spPr>
-      </p:sp>
-      <p:sp>
-        <p:nvSpPr>
-          <p:cNvPr id="20" name="Text 18"/>
-          <p:cNvSpPr txBox="1"/>
-          <p:nvPr/>
-        </p:nvSpPr>
-        <p:spPr>
-          <a:xfrm>
-            <a:off x="7022592" y="1554480"/>
-            <a:ext cx="1280160" cy="640080"/>
-          </a:xfrm>
-          <a:prstGeom prst="rect">
-            <a:avLst/>
-          </a:prstGeom>
-          <a:noFill/>
-          <a:ln/>
-        </p:spPr>
-        <p:txBody>
-          <a:bodyPr wrap="square" lIns="1016" tIns="1016" rIns="1016" bIns="1016" rtlCol="0" anchor="t"/>
-          <a:lstStyle/>
-          <a:p>
-            <a:pPr algn="l" indent="0" marL="0">
-              <a:buNone/>
-            </a:pPr>
-            <a:r>
-              <a:rPr lang="en-US" sz="3400" b="1" dirty="0">
-                <a:solidFill>
-                  <a:schemeClr val="accent3"/>
-                </a:solidFill>
-                <a:latin typeface="Cambria" pitchFamily="34" charset="0"/>
-                <a:ea typeface="Cambria" pitchFamily="34" charset="-122"/>
-                <a:cs typeface="Cambria" pitchFamily="34" charset="-120"/>
-              </a:rPr>
-              <a:t>4</a:t>
-            </a:r>
-            <a:endParaRPr lang="en-US" sz="3400" dirty="0"/>
-          </a:p>
-        </p:txBody>
-      </p:sp>
-      <p:sp>
-        <p:nvSpPr>
-          <p:cNvPr id="21" name="Text 19"/>
-          <p:cNvSpPr txBox="1"/>
-          <p:nvPr/>
-        </p:nvSpPr>
-        <p:spPr>
-          <a:xfrm>
-            <a:off x="7022592" y="2240280"/>
-            <a:ext cx="1325880" cy="822960"/>
-          </a:xfrm>
-          <a:prstGeom prst="rect">
-            <a:avLst/>
-          </a:prstGeom>
-          <a:noFill/>
-          <a:ln/>
-        </p:spPr>
-        <p:txBody>
-          <a:bodyPr wrap="square" lIns="1016" tIns="1016" rIns="1016" bIns="1016" rtlCol="0" anchor="t"/>
-          <a:lstStyle/>
-          <a:p>
-            <a:pPr algn="l" indent="0" marL="0">
-              <a:buNone/>
-            </a:pPr>
-            <a:r>
-              <a:rPr lang="en-US" sz="1400" b="1" dirty="0">
-                <a:solidFill>
-                  <a:schemeClr val="tx1"/>
-                </a:solidFill>
-              </a:rPr>
-              <a:t>Portail marchand</a:t>
-            </a:r>
-            <a:endParaRPr lang="en-US" sz="1400" dirty="0"/>
-          </a:p>
-        </p:txBody>
-      </p:sp>
-      <p:sp>
-        <p:nvSpPr>
-          <p:cNvPr id="22" name="Text 20"/>
-          <p:cNvSpPr txBox="1"/>
-          <p:nvPr/>
-        </p:nvSpPr>
-        <p:spPr>
-          <a:xfrm>
-            <a:off x="7022592" y="3063240"/>
-            <a:ext cx="1325880" cy="1874520"/>
-          </a:xfrm>
-          <a:prstGeom prst="rect">
-            <a:avLst/>
-          </a:prstGeom>
-          <a:noFill/>
-          <a:ln/>
-        </p:spPr>
-        <p:txBody>
-          <a:bodyPr wrap="square" lIns="1016" tIns="1016" rIns="1016" bIns="1016" rtlCol="0" anchor="t"/>
-          <a:lstStyle/>
-          <a:p>
-            <a:pPr algn="l" indent="0" marL="0">
-              <a:buNone/>
-            </a:pPr>
-            <a:r>
-              <a:rPr lang="en-US" sz="1200" dirty="0">
-                <a:solidFill>
-                  <a:schemeClr val="tx1"/>
-                </a:solidFill>
-              </a:rPr>
-              <a:t>Compte, CGU, préqualification, pièces, antivirus</a:t>
-            </a:r>
-            <a:endParaRPr lang="en-US" sz="1200" dirty="0"/>
-          </a:p>
-        </p:txBody>
-      </p:sp>
-      <p:sp>
-        <p:nvSpPr>
-          <p:cNvPr id="23" name="ph5"/>
-          <p:cNvSpPr/>
-          <p:nvPr/>
-        </p:nvSpPr>
-        <p:spPr>
-          <a:xfrm>
-            <a:off x="8549640" y="1463040"/>
-            <a:ext cx="1481328" cy="3566160"/>
-          </a:xfrm>
-          <a:prstGeom prst="roundRect">
-            <a:avLst>
-              <a:gd name="adj" fmla="val 4938"/>
-            </a:avLst>
-          </a:prstGeom>
-          <a:solidFill>
-            <a:schemeClr val="accent1">
-              <a:alpha val="12000"/>
-            </a:schemeClr>
-          </a:solidFill>
-          <a:ln w="9525">
-            <a:solidFill>
-              <a:schemeClr val="accent1"/>
-            </a:solidFill>
-            <a:prstDash val="solid"/>
-          </a:ln>
-        </p:spPr>
-      </p:sp>
-      <p:sp>
-        <p:nvSpPr>
-          <p:cNvPr id="24" name="Text 22"/>
-          <p:cNvSpPr txBox="1"/>
-          <p:nvPr/>
-        </p:nvSpPr>
-        <p:spPr>
-          <a:xfrm>
-            <a:off x="8641080" y="1554480"/>
-            <a:ext cx="1280160" cy="640080"/>
-          </a:xfrm>
-          <a:prstGeom prst="rect">
-            <a:avLst/>
-          </a:prstGeom>
-          <a:noFill/>
-          <a:ln/>
-        </p:spPr>
-        <p:txBody>
-          <a:bodyPr wrap="square" lIns="1016" tIns="1016" rIns="1016" bIns="1016" rtlCol="0" anchor="t"/>
-          <a:lstStyle/>
-          <a:p>
-            <a:pPr algn="l" indent="0" marL="0">
-              <a:buNone/>
-            </a:pPr>
-            <a:r>
-              <a:rPr lang="en-US" sz="3400" b="1" dirty="0">
-                <a:solidFill>
-                  <a:schemeClr val="accent1"/>
-                </a:solidFill>
-                <a:latin typeface="Cambria" pitchFamily="34" charset="0"/>
-                <a:ea typeface="Cambria" pitchFamily="34" charset="-122"/>
-                <a:cs typeface="Cambria" pitchFamily="34" charset="-120"/>
-              </a:rPr>
-              <a:t>5</a:t>
-            </a:r>
-            <a:endParaRPr lang="en-US" sz="3400" dirty="0"/>
-          </a:p>
-        </p:txBody>
-      </p:sp>
-      <p:sp>
-        <p:nvSpPr>
-          <p:cNvPr id="25" name="Text 23"/>
-          <p:cNvSpPr txBox="1"/>
-          <p:nvPr/>
-        </p:nvSpPr>
-        <p:spPr>
-          <a:xfrm>
-            <a:off x="8641080" y="2240280"/>
-            <a:ext cx="1325880" cy="822960"/>
-          </a:xfrm>
-          <a:prstGeom prst="rect">
-            <a:avLst/>
-          </a:prstGeom>
-          <a:noFill/>
-          <a:ln/>
-        </p:spPr>
-        <p:txBody>
-          <a:bodyPr wrap="square" lIns="1016" tIns="1016" rIns="1016" bIns="1016" rtlCol="0" anchor="t"/>
-          <a:lstStyle/>
-          <a:p>
-            <a:pPr algn="l" indent="0" marL="0">
-              <a:buNone/>
-            </a:pPr>
-            <a:r>
-              <a:rPr lang="en-US" sz="1400" b="1" dirty="0">
-                <a:solidFill>
-                  <a:schemeClr val="tx1"/>
-                </a:solidFill>
-              </a:rPr>
-              <a:t>Rapprochement MCB</a:t>
-            </a:r>
-            <a:endParaRPr lang="en-US" sz="1400" dirty="0"/>
-          </a:p>
-        </p:txBody>
-      </p:sp>
-      <p:sp>
-        <p:nvSpPr>
-          <p:cNvPr id="26" name="Text 24"/>
-          <p:cNvSpPr txBox="1"/>
-          <p:nvPr/>
-        </p:nvSpPr>
-        <p:spPr>
-          <a:xfrm>
-            <a:off x="8641080" y="3063240"/>
-            <a:ext cx="1325880" cy="1874520"/>
-          </a:xfrm>
-          <a:prstGeom prst="rect">
-            <a:avLst/>
-          </a:prstGeom>
-          <a:noFill/>
-          <a:ln/>
-        </p:spPr>
-        <p:txBody>
-          <a:bodyPr wrap="square" lIns="1016" tIns="1016" rIns="1016" bIns="1016" rtlCol="0" anchor="t"/>
-          <a:lstStyle/>
-          <a:p>
-            <a:pPr algn="l" indent="0" marL="0">
-              <a:buNone/>
-            </a:pPr>
-            <a:r>
-              <a:rPr lang="en-US" sz="1200" dirty="0">
-                <a:solidFill>
-                  <a:schemeClr val="tx1"/>
-                </a:solidFill>
-              </a:rPr>
-              <a:t>Validé sur un mois déjà réconcilié</a:t>
-            </a:r>
-            <a:endParaRPr lang="en-US" sz="1200" dirty="0"/>
-          </a:p>
-        </p:txBody>
-      </p:sp>
-      <p:sp>
-        <p:nvSpPr>
-          <p:cNvPr id="27" name="ph6"/>
-          <p:cNvSpPr/>
-          <p:nvPr/>
-        </p:nvSpPr>
-        <p:spPr>
-          <a:xfrm>
-            <a:off x="10168128" y="1463040"/>
-            <a:ext cx="1481328" cy="3566160"/>
-          </a:xfrm>
-          <a:prstGeom prst="roundRect">
-            <a:avLst>
-              <a:gd name="adj" fmla="val 4938"/>
-            </a:avLst>
-          </a:prstGeom>
-          <a:solidFill>
-            <a:schemeClr val="accent5">
-              <a:alpha val="12000"/>
-            </a:schemeClr>
-          </a:solidFill>
-          <a:ln w="9525">
-            <a:solidFill>
-              <a:schemeClr val="accent5"/>
-            </a:solidFill>
-            <a:prstDash val="solid"/>
-          </a:ln>
-        </p:spPr>
-      </p:sp>
-      <p:sp>
-        <p:nvSpPr>
-          <p:cNvPr id="28" name="Text 26"/>
-          <p:cNvSpPr txBox="1"/>
-          <p:nvPr/>
-        </p:nvSpPr>
-        <p:spPr>
-          <a:xfrm>
-            <a:off x="10259568" y="1554480"/>
-            <a:ext cx="1280160" cy="640080"/>
-          </a:xfrm>
-          <a:prstGeom prst="rect">
-            <a:avLst/>
-          </a:prstGeom>
-          <a:noFill/>
-          <a:ln/>
-        </p:spPr>
-        <p:txBody>
-          <a:bodyPr wrap="square" lIns="1016" tIns="1016" rIns="1016" bIns="1016" rtlCol="0" anchor="t"/>
-          <a:lstStyle/>
-          <a:p>
-            <a:pPr algn="l" indent="0" marL="0">
-              <a:buNone/>
-            </a:pPr>
-            <a:r>
-              <a:rPr lang="en-US" sz="3400" b="1" dirty="0">
-                <a:solidFill>
-                  <a:schemeClr val="accent5"/>
-                </a:solidFill>
-                <a:latin typeface="Cambria" pitchFamily="34" charset="0"/>
-                <a:ea typeface="Cambria" pitchFamily="34" charset="-122"/>
-                <a:cs typeface="Cambria" pitchFamily="34" charset="-120"/>
-              </a:rPr>
-              <a:t>6</a:t>
-            </a:r>
-            <a:endParaRPr lang="en-US" sz="3400" dirty="0"/>
-          </a:p>
-        </p:txBody>
-      </p:sp>
-      <p:sp>
-        <p:nvSpPr>
-          <p:cNvPr id="29" name="Text 27"/>
-          <p:cNvSpPr txBox="1"/>
-          <p:nvPr/>
-        </p:nvSpPr>
-        <p:spPr>
-          <a:xfrm>
-            <a:off x="10259568" y="2240280"/>
-            <a:ext cx="1325880" cy="822960"/>
-          </a:xfrm>
-          <a:prstGeom prst="rect">
-            <a:avLst/>
-          </a:prstGeom>
-          <a:noFill/>
-          <a:ln/>
-        </p:spPr>
-        <p:txBody>
-          <a:bodyPr wrap="square" lIns="1016" tIns="1016" rIns="1016" bIns="1016" rtlCol="0" anchor="t"/>
-          <a:lstStyle/>
-          <a:p>
-            <a:pPr algn="l" indent="0" marL="0">
-              <a:buNone/>
-            </a:pPr>
-            <a:r>
-              <a:rPr lang="en-US" sz="1400" b="1" dirty="0">
-                <a:solidFill>
-                  <a:schemeClr val="tx1"/>
-                </a:solidFill>
-              </a:rPr>
-              <a:t>Trust (si modèle B)</a:t>
-            </a:r>
-            <a:endParaRPr lang="en-US" sz="1400" dirty="0"/>
-          </a:p>
-        </p:txBody>
-      </p:sp>
-      <p:sp>
-        <p:nvSpPr>
-          <p:cNvPr id="30" name="Text 28"/>
-          <p:cNvSpPr txBox="1"/>
-          <p:nvPr/>
-        </p:nvSpPr>
-        <p:spPr>
-          <a:xfrm>
-            <a:off x="10259568" y="3063240"/>
-            <a:ext cx="1325880" cy="1874520"/>
-          </a:xfrm>
-          <a:prstGeom prst="rect">
-            <a:avLst/>
-          </a:prstGeom>
-          <a:noFill/>
-          <a:ln/>
-        </p:spPr>
-        <p:txBody>
-          <a:bodyPr wrap="square" lIns="1016" tIns="1016" rIns="1016" bIns="1016" rtlCol="0" anchor="t"/>
-          <a:lstStyle/>
-          <a:p>
-            <a:pPr algn="l" indent="0" marL="0">
-              <a:buNone/>
-            </a:pPr>
-            <a:r>
-              <a:rPr lang="en-US" sz="1200" dirty="0">
-                <a:solidFill>
-                  <a:schemeClr val="tx1"/>
-                </a:solidFill>
-              </a:rPr>
-              <a:t>Grand livre, rapprochement quotidien, reversements</a:t>
-            </a:r>
-            <a:endParaRPr lang="en-US" sz="1200" dirty="0"/>
-          </a:p>
-        </p:txBody>
-      </p:sp>
-      <p:sp>
-        <p:nvSpPr>
-          <p:cNvPr id="31" name="Text 29"/>
-          <p:cNvSpPr txBox="1"/>
-          <p:nvPr/>
-        </p:nvSpPr>
-        <p:spPr>
-          <a:xfrm>
-            <a:off x="457200" y="5303520"/>
-            <a:ext cx="11247120" cy="548640"/>
-          </a:xfrm>
-          <a:prstGeom prst="rect">
-            <a:avLst/>
-          </a:prstGeom>
-          <a:noFill/>
-          <a:ln/>
-        </p:spPr>
-        <p:txBody>
-          <a:bodyPr wrap="square" lIns="0" tIns="0" rIns="0" bIns="0" rtlCol="0" anchor="t"/>
-          <a:lstStyle/>
-          <a:p>
-            <a:pPr algn="l" indent="0" marL="0">
-              <a:buNone/>
-            </a:pPr>
-            <a:r>
-              <a:rPr lang="en-US" sz="1400" i="1" dirty="0">
-                <a:solidFill>
-                  <a:schemeClr val="tx2"/>
-                </a:solidFill>
-              </a:rPr>
-              <a:t>Chaque palier se termine quand ses tests de recette passent sur données réelles. Pas de dates tant que le palier 0 n'est pas tranché.</a:t>
-            </a:r>
-            <a:endParaRPr lang="en-US" sz="1400" dirty="0"/>
+              <a:t>La base officielle ne détecte pas la chaîne EICAR collée à un PDF (EICAR doit être en début de fichier), et un EICAR pur est refusé avant par le contrôle de format. D'où une signature de test dédiée dans la suite.</a:t>
+            </a:r>
+            <a:endParaRPr lang="en-US" sz="1300" dirty="0"/>
           </a:p>
         </p:txBody>
       </p:sp>
@@ -4822,7 +4392,7 @@
                   <a:schemeClr val="tx1"/>
                 </a:solidFill>
               </a:rPr>
-              <a:t>Définition de « terminé »</a:t>
+              <a:t>Feuille de route proposée, par paliers</a:t>
             </a:r>
             <a:endParaRPr lang="en-US" sz="3000" dirty="0"/>
           </a:p>
@@ -4830,26 +4400,28 @@
       </p:sp>
       <p:sp>
         <p:nvSpPr>
-          <p:cNvPr id="3" name="dod0"/>
+          <p:cNvPr id="3" name="ph0"/>
           <p:cNvSpPr/>
           <p:nvPr/>
         </p:nvSpPr>
         <p:spPr>
           <a:xfrm>
-            <a:off x="457200" y="1325880"/>
-            <a:ext cx="3566160" cy="2011680"/>
+            <a:off x="457200" y="1463040"/>
+            <a:ext cx="1481328" cy="3566160"/>
           </a:xfrm>
           <a:prstGeom prst="roundRect">
             <a:avLst>
-              <a:gd name="adj" fmla="val 3636"/>
+              <a:gd name="adj" fmla="val 4938"/>
             </a:avLst>
           </a:prstGeom>
           <a:solidFill>
-            <a:schemeClr val="bg2"/>
+            <a:schemeClr val="accent6">
+              <a:alpha val="12000"/>
+            </a:schemeClr>
           </a:solidFill>
           <a:ln w="9525">
             <a:solidFill>
-              <a:schemeClr val="bg2"/>
+              <a:schemeClr val="accent6"/>
             </a:solidFill>
             <a:prstDash val="solid"/>
           </a:ln>
@@ -4857,24 +4429,139 @@
       </p:sp>
       <p:sp>
         <p:nvSpPr>
-          <p:cNvPr id="4" name="dod0-dot"/>
+          <p:cNvPr id="4" name="Text 2"/>
+          <p:cNvSpPr txBox="1"/>
+          <p:nvPr/>
+        </p:nvSpPr>
+        <p:spPr>
+          <a:xfrm>
+            <a:off x="548640" y="1554480"/>
+            <a:ext cx="1280160" cy="640080"/>
+          </a:xfrm>
+          <a:prstGeom prst="rect">
+            <a:avLst/>
+          </a:prstGeom>
+          <a:noFill/>
+          <a:ln/>
+        </p:spPr>
+        <p:txBody>
+          <a:bodyPr wrap="square" lIns="1016" tIns="1016" rIns="1016" bIns="1016" rtlCol="0" anchor="t"/>
+          <a:lstStyle/>
+          <a:p>
+            <a:pPr algn="l" indent="0" marL="0">
+              <a:buNone/>
+            </a:pPr>
+            <a:r>
+              <a:rPr lang="en-US" sz="3400" b="1" dirty="0">
+                <a:solidFill>
+                  <a:schemeClr val="accent6"/>
+                </a:solidFill>
+                <a:latin typeface="Cambria" pitchFamily="34" charset="0"/>
+                <a:ea typeface="Cambria" pitchFamily="34" charset="-122"/>
+                <a:cs typeface="Cambria" pitchFamily="34" charset="-120"/>
+              </a:rPr>
+              <a:t>0</a:t>
+            </a:r>
+            <a:endParaRPr lang="en-US" sz="3400" dirty="0"/>
+          </a:p>
+        </p:txBody>
+      </p:sp>
+      <p:sp>
+        <p:nvSpPr>
+          <p:cNvPr id="5" name="Text 3"/>
+          <p:cNvSpPr txBox="1"/>
+          <p:nvPr/>
+        </p:nvSpPr>
+        <p:spPr>
+          <a:xfrm>
+            <a:off x="548640" y="2240280"/>
+            <a:ext cx="1325880" cy="822960"/>
+          </a:xfrm>
+          <a:prstGeom prst="rect">
+            <a:avLst/>
+          </a:prstGeom>
+          <a:noFill/>
+          <a:ln/>
+        </p:spPr>
+        <p:txBody>
+          <a:bodyPr wrap="square" lIns="1016" tIns="1016" rIns="1016" bIns="1016" rtlCol="0" anchor="t"/>
+          <a:lstStyle/>
+          <a:p>
+            <a:pPr algn="l" indent="0" marL="0">
+              <a:buNone/>
+            </a:pPr>
+            <a:r>
+              <a:rPr lang="en-US" sz="1400" b="1" dirty="0">
+                <a:solidFill>
+                  <a:schemeClr val="tx1"/>
+                </a:solidFill>
+              </a:rPr>
+              <a:t>Décisions</a:t>
+            </a:r>
+            <a:endParaRPr lang="en-US" sz="1400" dirty="0"/>
+          </a:p>
+        </p:txBody>
+      </p:sp>
+      <p:sp>
+        <p:nvSpPr>
+          <p:cNvPr id="6" name="Text 4"/>
+          <p:cNvSpPr txBox="1"/>
+          <p:nvPr/>
+        </p:nvSpPr>
+        <p:spPr>
+          <a:xfrm>
+            <a:off x="548640" y="3063240"/>
+            <a:ext cx="1325880" cy="1874520"/>
+          </a:xfrm>
+          <a:prstGeom prst="rect">
+            <a:avLst/>
+          </a:prstGeom>
+          <a:noFill/>
+          <a:ln/>
+        </p:spPr>
+        <p:txBody>
+          <a:bodyPr wrap="square" lIns="1016" tIns="1016" rIns="1016" bIns="1016" rtlCol="0" anchor="t"/>
+          <a:lstStyle/>
+          <a:p>
+            <a:pPr algn="l" indent="0" marL="0">
+              <a:buNone/>
+            </a:pPr>
+            <a:r>
+              <a:rPr lang="en-US" sz="1200" dirty="0">
+                <a:solidFill>
+                  <a:schemeClr val="tx1"/>
+                </a:solidFill>
+              </a:rPr>
+              <a:t>Modèle A ou B · textes BoM · seuils KYC · texte des CGU</a:t>
+            </a:r>
+            <a:endParaRPr lang="en-US" sz="1200" dirty="0"/>
+          </a:p>
+        </p:txBody>
+      </p:sp>
+      <p:sp>
+        <p:nvSpPr>
+          <p:cNvPr id="7" name="ph1"/>
           <p:cNvSpPr/>
           <p:nvPr/>
         </p:nvSpPr>
         <p:spPr>
           <a:xfrm>
-            <a:off x="658368" y="1545336"/>
-            <a:ext cx="274320" cy="274320"/>
-          </a:xfrm>
-          <a:prstGeom prst="ellipse">
-            <a:avLst/>
+            <a:off x="2075688" y="1463040"/>
+            <a:ext cx="1481328" cy="3566160"/>
+          </a:xfrm>
+          <a:prstGeom prst="roundRect">
+            <a:avLst>
+              <a:gd name="adj" fmla="val 4938"/>
+            </a:avLst>
           </a:prstGeom>
           <a:solidFill>
-            <a:schemeClr val="accent4"/>
+            <a:schemeClr val="accent2">
+              <a:alpha val="12000"/>
+            </a:schemeClr>
           </a:solidFill>
-          <a:ln w="12700">
+          <a:ln w="9525">
             <a:solidFill>
-              <a:schemeClr val="accent4"/>
+              <a:schemeClr val="accent2"/>
             </a:solidFill>
             <a:prstDash val="solid"/>
           </a:ln>
@@ -4882,14 +4569,14 @@
       </p:sp>
       <p:sp>
         <p:nvSpPr>
-          <p:cNvPr id="5" name="Text 3"/>
+          <p:cNvPr id="8" name="Text 6"/>
           <p:cNvSpPr txBox="1"/>
           <p:nvPr/>
         </p:nvSpPr>
         <p:spPr>
           <a:xfrm>
-            <a:off x="1051560" y="1435608"/>
-            <a:ext cx="2834640" cy="457200"/>
+            <a:off x="2167128" y="1554480"/>
+            <a:ext cx="1280160" cy="640080"/>
           </a:xfrm>
           <a:prstGeom prst="rect">
             <a:avLst/>
@@ -4898,34 +4585,73 @@
           <a:ln/>
         </p:spPr>
         <p:txBody>
-          <a:bodyPr wrap="square" lIns="1016" tIns="1016" rIns="1016" bIns="1016" rtlCol="0" anchor="ctr"/>
+          <a:bodyPr wrap="square" lIns="1016" tIns="1016" rIns="1016" bIns="1016" rtlCol="0" anchor="t"/>
           <a:lstStyle/>
           <a:p>
             <a:pPr algn="l" indent="0" marL="0">
               <a:buNone/>
             </a:pPr>
             <a:r>
-              <a:rPr lang="en-US" sz="1600" b="1" dirty="0">
+              <a:rPr lang="en-US" sz="3400" b="1" dirty="0">
+                <a:solidFill>
+                  <a:schemeClr val="accent2"/>
+                </a:solidFill>
+                <a:latin typeface="Cambria" pitchFamily="34" charset="0"/>
+                <a:ea typeface="Cambria" pitchFamily="34" charset="-122"/>
+                <a:cs typeface="Cambria" pitchFamily="34" charset="-120"/>
+              </a:rPr>
+              <a:t>1</a:t>
+            </a:r>
+            <a:endParaRPr lang="en-US" sz="3400" dirty="0"/>
+          </a:p>
+        </p:txBody>
+      </p:sp>
+      <p:sp>
+        <p:nvSpPr>
+          <p:cNvPr id="9" name="Text 7"/>
+          <p:cNvSpPr txBox="1"/>
+          <p:nvPr/>
+        </p:nvSpPr>
+        <p:spPr>
+          <a:xfrm>
+            <a:off x="2167128" y="2240280"/>
+            <a:ext cx="1325880" cy="822960"/>
+          </a:xfrm>
+          <a:prstGeom prst="rect">
+            <a:avLst/>
+          </a:prstGeom>
+          <a:noFill/>
+          <a:ln/>
+        </p:spPr>
+        <p:txBody>
+          <a:bodyPr wrap="square" lIns="1016" tIns="1016" rIns="1016" bIns="1016" rtlCol="0" anchor="t"/>
+          <a:lstStyle/>
+          <a:p>
+            <a:pPr algn="l" indent="0" marL="0">
+              <a:buNone/>
+            </a:pPr>
+            <a:r>
+              <a:rPr lang="en-US" sz="1400" b="1" dirty="0">
                 <a:solidFill>
                   <a:schemeClr val="tx1"/>
                 </a:solidFill>
               </a:rPr>
-              <a:t>Tests de recette</a:t>
-            </a:r>
-            <a:endParaRPr lang="en-US" sz="1600" dirty="0"/>
-          </a:p>
-        </p:txBody>
-      </p:sp>
-      <p:sp>
-        <p:nvSpPr>
-          <p:cNvPr id="6" name="Text 4"/>
+              <a:t>Socle</a:t>
+            </a:r>
+            <a:endParaRPr lang="en-US" sz="1400" dirty="0"/>
+          </a:p>
+        </p:txBody>
+      </p:sp>
+      <p:sp>
+        <p:nvSpPr>
+          <p:cNvPr id="10" name="Text 8"/>
           <p:cNvSpPr txBox="1"/>
           <p:nvPr/>
         </p:nvSpPr>
         <p:spPr>
           <a:xfrm>
-            <a:off x="640080" y="1965960"/>
-            <a:ext cx="3246120" cy="1280160"/>
+            <a:off x="2167128" y="3063240"/>
+            <a:ext cx="1325880" cy="1874520"/>
           </a:xfrm>
           <a:prstGeom prst="rect">
             <a:avLst/>
@@ -4941,39 +4667,41 @@
               <a:buNone/>
             </a:pPr>
             <a:r>
-              <a:rPr lang="en-US" sz="1300" dirty="0">
+              <a:rPr lang="en-US" sz="1200" dirty="0">
                 <a:solidFill>
                   <a:schemeClr val="tx1"/>
                 </a:solidFill>
               </a:rPr>
-              <a:t>Les tests de la spec et les scénarios des suites de référence passent, automatisés.</a:t>
-            </a:r>
-            <a:endParaRPr lang="en-US" sz="1300" dirty="0"/>
-          </a:p>
-        </p:txBody>
-      </p:sp>
-      <p:sp>
-        <p:nvSpPr>
-          <p:cNvPr id="7" name="dod1"/>
+              <a:t>Auth, 2FA, rôles, audit, sessions séparées</a:t>
+            </a:r>
+            <a:endParaRPr lang="en-US" sz="1200" dirty="0"/>
+          </a:p>
+        </p:txBody>
+      </p:sp>
+      <p:sp>
+        <p:nvSpPr>
+          <p:cNvPr id="11" name="ph2"/>
           <p:cNvSpPr/>
           <p:nvPr/>
         </p:nvSpPr>
         <p:spPr>
           <a:xfrm>
-            <a:off x="4251960" y="1325880"/>
-            <a:ext cx="3566160" cy="2011680"/>
+            <a:off x="3694176" y="1463040"/>
+            <a:ext cx="1481328" cy="3566160"/>
           </a:xfrm>
           <a:prstGeom prst="roundRect">
             <a:avLst>
-              <a:gd name="adj" fmla="val 3636"/>
+              <a:gd name="adj" fmla="val 4938"/>
             </a:avLst>
           </a:prstGeom>
           <a:solidFill>
-            <a:schemeClr val="bg2"/>
+            <a:schemeClr val="accent2">
+              <a:alpha val="12000"/>
+            </a:schemeClr>
           </a:solidFill>
           <a:ln w="9525">
             <a:solidFill>
-              <a:schemeClr val="bg2"/>
+              <a:schemeClr val="accent2"/>
             </a:solidFill>
             <a:prstDash val="solid"/>
           </a:ln>
@@ -4981,24 +4709,139 @@
       </p:sp>
       <p:sp>
         <p:nvSpPr>
-          <p:cNvPr id="8" name="dod1-dot"/>
+          <p:cNvPr id="12" name="Text 10"/>
+          <p:cNvSpPr txBox="1"/>
+          <p:nvPr/>
+        </p:nvSpPr>
+        <p:spPr>
+          <a:xfrm>
+            <a:off x="3785616" y="1554480"/>
+            <a:ext cx="1280160" cy="640080"/>
+          </a:xfrm>
+          <a:prstGeom prst="rect">
+            <a:avLst/>
+          </a:prstGeom>
+          <a:noFill/>
+          <a:ln/>
+        </p:spPr>
+        <p:txBody>
+          <a:bodyPr wrap="square" lIns="1016" tIns="1016" rIns="1016" bIns="1016" rtlCol="0" anchor="t"/>
+          <a:lstStyle/>
+          <a:p>
+            <a:pPr algn="l" indent="0" marL="0">
+              <a:buNone/>
+            </a:pPr>
+            <a:r>
+              <a:rPr lang="en-US" sz="3400" b="1" dirty="0">
+                <a:solidFill>
+                  <a:schemeClr val="accent2"/>
+                </a:solidFill>
+                <a:latin typeface="Cambria" pitchFamily="34" charset="0"/>
+                <a:ea typeface="Cambria" pitchFamily="34" charset="-122"/>
+                <a:cs typeface="Cambria" pitchFamily="34" charset="-120"/>
+              </a:rPr>
+              <a:t>2</a:t>
+            </a:r>
+            <a:endParaRPr lang="en-US" sz="3400" dirty="0"/>
+          </a:p>
+        </p:txBody>
+      </p:sp>
+      <p:sp>
+        <p:nvSpPr>
+          <p:cNvPr id="13" name="Text 11"/>
+          <p:cNvSpPr txBox="1"/>
+          <p:nvPr/>
+        </p:nvSpPr>
+        <p:spPr>
+          <a:xfrm>
+            <a:off x="3785616" y="2240280"/>
+            <a:ext cx="1325880" cy="822960"/>
+          </a:xfrm>
+          <a:prstGeom prst="rect">
+            <a:avLst/>
+          </a:prstGeom>
+          <a:noFill/>
+          <a:ln/>
+        </p:spPr>
+        <p:txBody>
+          <a:bodyPr wrap="square" lIns="1016" tIns="1016" rIns="1016" bIns="1016" rtlCol="0" anchor="t"/>
+          <a:lstStyle/>
+          <a:p>
+            <a:pPr algn="l" indent="0" marL="0">
+              <a:buNone/>
+            </a:pPr>
+            <a:r>
+              <a:rPr lang="en-US" sz="1400" b="1" dirty="0">
+                <a:solidFill>
+                  <a:schemeClr val="tx1"/>
+                </a:solidFill>
+              </a:rPr>
+              <a:t>Reporting et facturation</a:t>
+            </a:r>
+            <a:endParaRPr lang="en-US" sz="1400" dirty="0"/>
+          </a:p>
+        </p:txBody>
+      </p:sp>
+      <p:sp>
+        <p:nvSpPr>
+          <p:cNvPr id="14" name="Text 12"/>
+          <p:cNvSpPr txBox="1"/>
+          <p:nvPr/>
+        </p:nvSpPr>
+        <p:spPr>
+          <a:xfrm>
+            <a:off x="3785616" y="3063240"/>
+            <a:ext cx="1325880" cy="1874520"/>
+          </a:xfrm>
+          <a:prstGeom prst="rect">
+            <a:avLst/>
+          </a:prstGeom>
+          <a:noFill/>
+          <a:ln/>
+        </p:spPr>
+        <p:txBody>
+          <a:bodyPr wrap="square" lIns="1016" tIns="1016" rIns="1016" bIns="1016" rtlCol="0" anchor="t"/>
+          <a:lstStyle/>
+          <a:p>
+            <a:pPr algn="l" indent="0" marL="0">
+              <a:buNone/>
+            </a:pPr>
+            <a:r>
+              <a:rPr lang="en-US" sz="1200" dirty="0">
+                <a:solidFill>
+                  <a:schemeClr val="tx1"/>
+                </a:solidFill>
+              </a:rPr>
+              <a:t>Import, rapport, Excel, BigQuery, factures</a:t>
+            </a:r>
+            <a:endParaRPr lang="en-US" sz="1200" dirty="0"/>
+          </a:p>
+        </p:txBody>
+      </p:sp>
+      <p:sp>
+        <p:nvSpPr>
+          <p:cNvPr id="15" name="ph3"/>
           <p:cNvSpPr/>
           <p:nvPr/>
         </p:nvSpPr>
         <p:spPr>
           <a:xfrm>
-            <a:off x="4453128" y="1545336"/>
-            <a:ext cx="274320" cy="274320"/>
-          </a:xfrm>
-          <a:prstGeom prst="ellipse">
-            <a:avLst/>
+            <a:off x="5312664" y="1463040"/>
+            <a:ext cx="1481328" cy="3566160"/>
+          </a:xfrm>
+          <a:prstGeom prst="roundRect">
+            <a:avLst>
+              <a:gd name="adj" fmla="val 4938"/>
+            </a:avLst>
           </a:prstGeom>
           <a:solidFill>
-            <a:schemeClr val="accent4"/>
+            <a:schemeClr val="accent1">
+              <a:alpha val="12000"/>
+            </a:schemeClr>
           </a:solidFill>
-          <a:ln w="12700">
+          <a:ln w="9525">
             <a:solidFill>
-              <a:schemeClr val="accent4"/>
+              <a:schemeClr val="accent1"/>
             </a:solidFill>
             <a:prstDash val="solid"/>
           </a:ln>
@@ -5006,14 +4849,14 @@
       </p:sp>
       <p:sp>
         <p:nvSpPr>
-          <p:cNvPr id="9" name="Text 7"/>
+          <p:cNvPr id="16" name="Text 14"/>
           <p:cNvSpPr txBox="1"/>
           <p:nvPr/>
         </p:nvSpPr>
         <p:spPr>
           <a:xfrm>
-            <a:off x="4846320" y="1435608"/>
-            <a:ext cx="2834640" cy="457200"/>
+            <a:off x="5404104" y="1554480"/>
+            <a:ext cx="1280160" cy="640080"/>
           </a:xfrm>
           <a:prstGeom prst="rect">
             <a:avLst/>
@@ -5022,34 +4865,73 @@
           <a:ln/>
         </p:spPr>
         <p:txBody>
-          <a:bodyPr wrap="square" lIns="1016" tIns="1016" rIns="1016" bIns="1016" rtlCol="0" anchor="ctr"/>
+          <a:bodyPr wrap="square" lIns="1016" tIns="1016" rIns="1016" bIns="1016" rtlCol="0" anchor="t"/>
           <a:lstStyle/>
           <a:p>
             <a:pPr algn="l" indent="0" marL="0">
               <a:buNone/>
             </a:pPr>
             <a:r>
-              <a:rPr lang="en-US" sz="1600" b="1" dirty="0">
+              <a:rPr lang="en-US" sz="3400" b="1" dirty="0">
+                <a:solidFill>
+                  <a:schemeClr val="accent1"/>
+                </a:solidFill>
+                <a:latin typeface="Cambria" pitchFamily="34" charset="0"/>
+                <a:ea typeface="Cambria" pitchFamily="34" charset="-122"/>
+                <a:cs typeface="Cambria" pitchFamily="34" charset="-120"/>
+              </a:rPr>
+              <a:t>3</a:t>
+            </a:r>
+            <a:endParaRPr lang="en-US" sz="3400" dirty="0"/>
+          </a:p>
+        </p:txBody>
+      </p:sp>
+      <p:sp>
+        <p:nvSpPr>
+          <p:cNvPr id="17" name="Text 15"/>
+          <p:cNvSpPr txBox="1"/>
+          <p:nvPr/>
+        </p:nvSpPr>
+        <p:spPr>
+          <a:xfrm>
+            <a:off x="5404104" y="2240280"/>
+            <a:ext cx="1325880" cy="822960"/>
+          </a:xfrm>
+          <a:prstGeom prst="rect">
+            <a:avLst/>
+          </a:prstGeom>
+          <a:noFill/>
+          <a:ln/>
+        </p:spPr>
+        <p:txBody>
+          <a:bodyPr wrap="square" lIns="1016" tIns="1016" rIns="1016" bIns="1016" rtlCol="0" anchor="t"/>
+          <a:lstStyle/>
+          <a:p>
+            <a:pPr algn="l" indent="0" marL="0">
+              <a:buNone/>
+            </a:pPr>
+            <a:r>
+              <a:rPr lang="en-US" sz="1400" b="1" dirty="0">
                 <a:solidFill>
                   <a:schemeClr val="tx1"/>
                 </a:solidFill>
               </a:rPr>
-              <a:t>Données réelles</a:t>
-            </a:r>
-            <a:endParaRPr lang="en-US" sz="1600" dirty="0"/>
-          </a:p>
-        </p:txBody>
-      </p:sp>
-      <p:sp>
-        <p:nvSpPr>
-          <p:cNvPr id="10" name="Text 8"/>
+              <a:t>Marchands et KYC</a:t>
+            </a:r>
+            <a:endParaRPr lang="en-US" sz="1400" dirty="0"/>
+          </a:p>
+        </p:txBody>
+      </p:sp>
+      <p:sp>
+        <p:nvSpPr>
+          <p:cNvPr id="18" name="Text 16"/>
           <p:cNvSpPr txBox="1"/>
           <p:nvPr/>
         </p:nvSpPr>
         <p:spPr>
           <a:xfrm>
-            <a:off x="4434840" y="1965960"/>
-            <a:ext cx="3246120" cy="1280160"/>
+            <a:off x="5404104" y="3063240"/>
+            <a:ext cx="1325880" cy="1874520"/>
           </a:xfrm>
           <a:prstGeom prst="rect">
             <a:avLst/>
@@ -5065,39 +4947,41 @@
               <a:buNone/>
             </a:pPr>
             <a:r>
-              <a:rPr lang="en-US" sz="1300" dirty="0">
+              <a:rPr lang="en-US" sz="1200" dirty="0">
                 <a:solidFill>
                   <a:schemeClr val="tx1"/>
                 </a:solidFill>
               </a:rPr>
-              <a:t>Résultat comparé au processus actuel sur au moins un mois.</a:t>
-            </a:r>
-            <a:endParaRPr lang="en-US" sz="1300" dirty="0"/>
-          </a:p>
-        </p:txBody>
-      </p:sp>
-      <p:sp>
-        <p:nvSpPr>
-          <p:cNvPr id="11" name="dod2"/>
+              <a:t>Fiche marchand, dossier KYC, double regard, relances</a:t>
+            </a:r>
+            <a:endParaRPr lang="en-US" sz="1200" dirty="0"/>
+          </a:p>
+        </p:txBody>
+      </p:sp>
+      <p:sp>
+        <p:nvSpPr>
+          <p:cNvPr id="19" name="ph4"/>
           <p:cNvSpPr/>
           <p:nvPr/>
         </p:nvSpPr>
         <p:spPr>
           <a:xfrm>
-            <a:off x="8046720" y="1325880"/>
-            <a:ext cx="3566160" cy="2011680"/>
+            <a:off x="6931152" y="1463040"/>
+            <a:ext cx="1481328" cy="3566160"/>
           </a:xfrm>
           <a:prstGeom prst="roundRect">
             <a:avLst>
-              <a:gd name="adj" fmla="val 3636"/>
+              <a:gd name="adj" fmla="val 4938"/>
             </a:avLst>
           </a:prstGeom>
           <a:solidFill>
-            <a:schemeClr val="bg2"/>
+            <a:schemeClr val="accent3">
+              <a:alpha val="12000"/>
+            </a:schemeClr>
           </a:solidFill>
           <a:ln w="9525">
             <a:solidFill>
-              <a:schemeClr val="bg2"/>
+              <a:schemeClr val="accent3"/>
             </a:solidFill>
             <a:prstDash val="solid"/>
           </a:ln>
@@ -5105,24 +4989,139 @@
       </p:sp>
       <p:sp>
         <p:nvSpPr>
-          <p:cNvPr id="12" name="dod2-dot"/>
+          <p:cNvPr id="20" name="Text 18"/>
+          <p:cNvSpPr txBox="1"/>
+          <p:nvPr/>
+        </p:nvSpPr>
+        <p:spPr>
+          <a:xfrm>
+            <a:off x="7022592" y="1554480"/>
+            <a:ext cx="1280160" cy="640080"/>
+          </a:xfrm>
+          <a:prstGeom prst="rect">
+            <a:avLst/>
+          </a:prstGeom>
+          <a:noFill/>
+          <a:ln/>
+        </p:spPr>
+        <p:txBody>
+          <a:bodyPr wrap="square" lIns="1016" tIns="1016" rIns="1016" bIns="1016" rtlCol="0" anchor="t"/>
+          <a:lstStyle/>
+          <a:p>
+            <a:pPr algn="l" indent="0" marL="0">
+              <a:buNone/>
+            </a:pPr>
+            <a:r>
+              <a:rPr lang="en-US" sz="3400" b="1" dirty="0">
+                <a:solidFill>
+                  <a:schemeClr val="accent3"/>
+                </a:solidFill>
+                <a:latin typeface="Cambria" pitchFamily="34" charset="0"/>
+                <a:ea typeface="Cambria" pitchFamily="34" charset="-122"/>
+                <a:cs typeface="Cambria" pitchFamily="34" charset="-120"/>
+              </a:rPr>
+              <a:t>4</a:t>
+            </a:r>
+            <a:endParaRPr lang="en-US" sz="3400" dirty="0"/>
+          </a:p>
+        </p:txBody>
+      </p:sp>
+      <p:sp>
+        <p:nvSpPr>
+          <p:cNvPr id="21" name="Text 19"/>
+          <p:cNvSpPr txBox="1"/>
+          <p:nvPr/>
+        </p:nvSpPr>
+        <p:spPr>
+          <a:xfrm>
+            <a:off x="7022592" y="2240280"/>
+            <a:ext cx="1325880" cy="822960"/>
+          </a:xfrm>
+          <a:prstGeom prst="rect">
+            <a:avLst/>
+          </a:prstGeom>
+          <a:noFill/>
+          <a:ln/>
+        </p:spPr>
+        <p:txBody>
+          <a:bodyPr wrap="square" lIns="1016" tIns="1016" rIns="1016" bIns="1016" rtlCol="0" anchor="t"/>
+          <a:lstStyle/>
+          <a:p>
+            <a:pPr algn="l" indent="0" marL="0">
+              <a:buNone/>
+            </a:pPr>
+            <a:r>
+              <a:rPr lang="en-US" sz="1400" b="1" dirty="0">
+                <a:solidFill>
+                  <a:schemeClr val="tx1"/>
+                </a:solidFill>
+              </a:rPr>
+              <a:t>Portail marchand</a:t>
+            </a:r>
+            <a:endParaRPr lang="en-US" sz="1400" dirty="0"/>
+          </a:p>
+        </p:txBody>
+      </p:sp>
+      <p:sp>
+        <p:nvSpPr>
+          <p:cNvPr id="22" name="Text 20"/>
+          <p:cNvSpPr txBox="1"/>
+          <p:nvPr/>
+        </p:nvSpPr>
+        <p:spPr>
+          <a:xfrm>
+            <a:off x="7022592" y="3063240"/>
+            <a:ext cx="1325880" cy="1874520"/>
+          </a:xfrm>
+          <a:prstGeom prst="rect">
+            <a:avLst/>
+          </a:prstGeom>
+          <a:noFill/>
+          <a:ln/>
+        </p:spPr>
+        <p:txBody>
+          <a:bodyPr wrap="square" lIns="1016" tIns="1016" rIns="1016" bIns="1016" rtlCol="0" anchor="t"/>
+          <a:lstStyle/>
+          <a:p>
+            <a:pPr algn="l" indent="0" marL="0">
+              <a:buNone/>
+            </a:pPr>
+            <a:r>
+              <a:rPr lang="en-US" sz="1200" dirty="0">
+                <a:solidFill>
+                  <a:schemeClr val="tx1"/>
+                </a:solidFill>
+              </a:rPr>
+              <a:t>Compte, CGU, préqualification, pièces, antivirus</a:t>
+            </a:r>
+            <a:endParaRPr lang="en-US" sz="1200" dirty="0"/>
+          </a:p>
+        </p:txBody>
+      </p:sp>
+      <p:sp>
+        <p:nvSpPr>
+          <p:cNvPr id="23" name="ph5"/>
           <p:cNvSpPr/>
           <p:nvPr/>
         </p:nvSpPr>
         <p:spPr>
           <a:xfrm>
-            <a:off x="8247888" y="1545336"/>
-            <a:ext cx="274320" cy="274320"/>
-          </a:xfrm>
-          <a:prstGeom prst="ellipse">
-            <a:avLst/>
+            <a:off x="8549640" y="1463040"/>
+            <a:ext cx="1481328" cy="3566160"/>
+          </a:xfrm>
+          <a:prstGeom prst="roundRect">
+            <a:avLst>
+              <a:gd name="adj" fmla="val 4938"/>
+            </a:avLst>
           </a:prstGeom>
           <a:solidFill>
-            <a:schemeClr val="accent4"/>
+            <a:schemeClr val="accent1">
+              <a:alpha val="12000"/>
+            </a:schemeClr>
           </a:solidFill>
-          <a:ln w="12700">
+          <a:ln w="9525">
             <a:solidFill>
-              <a:schemeClr val="accent4"/>
+              <a:schemeClr val="accent1"/>
             </a:solidFill>
             <a:prstDash val="solid"/>
           </a:ln>
@@ -5130,14 +5129,14 @@
       </p:sp>
       <p:sp>
         <p:nvSpPr>
-          <p:cNvPr id="13" name="Text 11"/>
+          <p:cNvPr id="24" name="Text 22"/>
           <p:cNvSpPr txBox="1"/>
           <p:nvPr/>
         </p:nvSpPr>
         <p:spPr>
           <a:xfrm>
-            <a:off x="8641080" y="1435608"/>
-            <a:ext cx="2834640" cy="457200"/>
+            <a:off x="8641080" y="1554480"/>
+            <a:ext cx="1280160" cy="640080"/>
           </a:xfrm>
           <a:prstGeom prst="rect">
             <a:avLst/>
@@ -5146,34 +5145,73 @@
           <a:ln/>
         </p:spPr>
         <p:txBody>
-          <a:bodyPr wrap="square" lIns="1016" tIns="1016" rIns="1016" bIns="1016" rtlCol="0" anchor="ctr"/>
+          <a:bodyPr wrap="square" lIns="1016" tIns="1016" rIns="1016" bIns="1016" rtlCol="0" anchor="t"/>
           <a:lstStyle/>
           <a:p>
             <a:pPr algn="l" indent="0" marL="0">
               <a:buNone/>
             </a:pPr>
             <a:r>
-              <a:rPr lang="en-US" sz="1600" b="1" dirty="0">
+              <a:rPr lang="en-US" sz="3400" b="1" dirty="0">
+                <a:solidFill>
+                  <a:schemeClr val="accent1"/>
+                </a:solidFill>
+                <a:latin typeface="Cambria" pitchFamily="34" charset="0"/>
+                <a:ea typeface="Cambria" pitchFamily="34" charset="-122"/>
+                <a:cs typeface="Cambria" pitchFamily="34" charset="-120"/>
+              </a:rPr>
+              <a:t>5</a:t>
+            </a:r>
+            <a:endParaRPr lang="en-US" sz="3400" dirty="0"/>
+          </a:p>
+        </p:txBody>
+      </p:sp>
+      <p:sp>
+        <p:nvSpPr>
+          <p:cNvPr id="25" name="Text 23"/>
+          <p:cNvSpPr txBox="1"/>
+          <p:nvPr/>
+        </p:nvSpPr>
+        <p:spPr>
+          <a:xfrm>
+            <a:off x="8641080" y="2240280"/>
+            <a:ext cx="1325880" cy="822960"/>
+          </a:xfrm>
+          <a:prstGeom prst="rect">
+            <a:avLst/>
+          </a:prstGeom>
+          <a:noFill/>
+          <a:ln/>
+        </p:spPr>
+        <p:txBody>
+          <a:bodyPr wrap="square" lIns="1016" tIns="1016" rIns="1016" bIns="1016" rtlCol="0" anchor="t"/>
+          <a:lstStyle/>
+          <a:p>
+            <a:pPr algn="l" indent="0" marL="0">
+              <a:buNone/>
+            </a:pPr>
+            <a:r>
+              <a:rPr lang="en-US" sz="1400" b="1" dirty="0">
                 <a:solidFill>
                   <a:schemeClr val="tx1"/>
                 </a:solidFill>
               </a:rPr>
-              <a:t>Revue de sécurité</a:t>
-            </a:r>
-            <a:endParaRPr lang="en-US" sz="1600" dirty="0"/>
-          </a:p>
-        </p:txBody>
-      </p:sp>
-      <p:sp>
-        <p:nvSpPr>
-          <p:cNvPr id="14" name="Text 12"/>
+              <a:t>Rapprochement MCB</a:t>
+            </a:r>
+            <a:endParaRPr lang="en-US" sz="1400" dirty="0"/>
+          </a:p>
+        </p:txBody>
+      </p:sp>
+      <p:sp>
+        <p:nvSpPr>
+          <p:cNvPr id="26" name="Text 24"/>
           <p:cNvSpPr txBox="1"/>
           <p:nvPr/>
         </p:nvSpPr>
         <p:spPr>
           <a:xfrm>
-            <a:off x="8229600" y="1965960"/>
-            <a:ext cx="3246120" cy="1280160"/>
+            <a:off x="8641080" y="3063240"/>
+            <a:ext cx="1325880" cy="1874520"/>
           </a:xfrm>
           <a:prstGeom prst="rect">
             <a:avLst/>
@@ -5189,39 +5227,41 @@
               <a:buNone/>
             </a:pPr>
             <a:r>
-              <a:rPr lang="en-US" sz="1300" dirty="0">
+              <a:rPr lang="en-US" sz="1200" dirty="0">
                 <a:solidFill>
                   <a:schemeClr val="tx1"/>
                 </a:solidFill>
               </a:rPr>
-              <a:t>Accès, double regard, données sensibles, fichiers : vérifiés par un pair.</a:t>
-            </a:r>
-            <a:endParaRPr lang="en-US" sz="1300" dirty="0"/>
-          </a:p>
-        </p:txBody>
-      </p:sp>
-      <p:sp>
-        <p:nvSpPr>
-          <p:cNvPr id="15" name="dod3"/>
+              <a:t>Validé sur un mois déjà réconcilié</a:t>
+            </a:r>
+            <a:endParaRPr lang="en-US" sz="1200" dirty="0"/>
+          </a:p>
+        </p:txBody>
+      </p:sp>
+      <p:sp>
+        <p:nvSpPr>
+          <p:cNvPr id="27" name="ph6"/>
           <p:cNvSpPr/>
           <p:nvPr/>
         </p:nvSpPr>
         <p:spPr>
           <a:xfrm>
-            <a:off x="457200" y="3566160"/>
-            <a:ext cx="3566160" cy="2011680"/>
+            <a:off x="10168128" y="1463040"/>
+            <a:ext cx="1481328" cy="3566160"/>
           </a:xfrm>
           <a:prstGeom prst="roundRect">
             <a:avLst>
-              <a:gd name="adj" fmla="val 3636"/>
+              <a:gd name="adj" fmla="val 4938"/>
             </a:avLst>
           </a:prstGeom>
           <a:solidFill>
-            <a:schemeClr val="bg2"/>
+            <a:schemeClr val="accent5">
+              <a:alpha val="12000"/>
+            </a:schemeClr>
           </a:solidFill>
           <a:ln w="9525">
             <a:solidFill>
-              <a:schemeClr val="bg2"/>
+              <a:schemeClr val="accent5"/>
             </a:solidFill>
             <a:prstDash val="solid"/>
           </a:ln>
@@ -5229,39 +5269,14 @@
       </p:sp>
       <p:sp>
         <p:nvSpPr>
-          <p:cNvPr id="16" name="dod3-dot"/>
-          <p:cNvSpPr/>
-          <p:nvPr/>
-        </p:nvSpPr>
-        <p:spPr>
-          <a:xfrm>
-            <a:off x="658368" y="3785616"/>
-            <a:ext cx="274320" cy="274320"/>
-          </a:xfrm>
-          <a:prstGeom prst="ellipse">
-            <a:avLst/>
-          </a:prstGeom>
-          <a:solidFill>
-            <a:schemeClr val="accent4"/>
-          </a:solidFill>
-          <a:ln w="12700">
-            <a:solidFill>
-              <a:schemeClr val="accent4"/>
-            </a:solidFill>
-            <a:prstDash val="solid"/>
-          </a:ln>
-        </p:spPr>
-      </p:sp>
-      <p:sp>
-        <p:nvSpPr>
-          <p:cNvPr id="17" name="Text 15"/>
+          <p:cNvPr id="28" name="Text 26"/>
           <p:cNvSpPr txBox="1"/>
           <p:nvPr/>
         </p:nvSpPr>
         <p:spPr>
           <a:xfrm>
-            <a:off x="1051560" y="3675888"/>
-            <a:ext cx="2834640" cy="457200"/>
+            <a:off x="10259568" y="1554480"/>
+            <a:ext cx="1280160" cy="640080"/>
           </a:xfrm>
           <a:prstGeom prst="rect">
             <a:avLst/>
@@ -5270,34 +5285,73 @@
           <a:ln/>
         </p:spPr>
         <p:txBody>
-          <a:bodyPr wrap="square" lIns="1016" tIns="1016" rIns="1016" bIns="1016" rtlCol="0" anchor="ctr"/>
+          <a:bodyPr wrap="square" lIns="1016" tIns="1016" rIns="1016" bIns="1016" rtlCol="0" anchor="t"/>
           <a:lstStyle/>
           <a:p>
             <a:pPr algn="l" indent="0" marL="0">
               <a:buNone/>
             </a:pPr>
             <a:r>
-              <a:rPr lang="en-US" sz="1600" b="1" dirty="0">
+              <a:rPr lang="en-US" sz="3400" b="1" dirty="0">
+                <a:solidFill>
+                  <a:schemeClr val="accent5"/>
+                </a:solidFill>
+                <a:latin typeface="Cambria" pitchFamily="34" charset="0"/>
+                <a:ea typeface="Cambria" pitchFamily="34" charset="-122"/>
+                <a:cs typeface="Cambria" pitchFamily="34" charset="-120"/>
+              </a:rPr>
+              <a:t>6</a:t>
+            </a:r>
+            <a:endParaRPr lang="en-US" sz="3400" dirty="0"/>
+          </a:p>
+        </p:txBody>
+      </p:sp>
+      <p:sp>
+        <p:nvSpPr>
+          <p:cNvPr id="29" name="Text 27"/>
+          <p:cNvSpPr txBox="1"/>
+          <p:nvPr/>
+        </p:nvSpPr>
+        <p:spPr>
+          <a:xfrm>
+            <a:off x="10259568" y="2240280"/>
+            <a:ext cx="1325880" cy="822960"/>
+          </a:xfrm>
+          <a:prstGeom prst="rect">
+            <a:avLst/>
+          </a:prstGeom>
+          <a:noFill/>
+          <a:ln/>
+        </p:spPr>
+        <p:txBody>
+          <a:bodyPr wrap="square" lIns="1016" tIns="1016" rIns="1016" bIns="1016" rtlCol="0" anchor="t"/>
+          <a:lstStyle/>
+          <a:p>
+            <a:pPr algn="l" indent="0" marL="0">
+              <a:buNone/>
+            </a:pPr>
+            <a:r>
+              <a:rPr lang="en-US" sz="1400" b="1" dirty="0">
                 <a:solidFill>
                   <a:schemeClr val="tx1"/>
                 </a:solidFill>
               </a:rPr>
-              <a:t>Configuration validée</a:t>
-            </a:r>
-            <a:endParaRPr lang="en-US" sz="1600" dirty="0"/>
-          </a:p>
-        </p:txBody>
-      </p:sp>
-      <p:sp>
-        <p:nvSpPr>
-          <p:cNvPr id="18" name="Text 16"/>
+              <a:t>Trust (si modèle B)</a:t>
+            </a:r>
+            <a:endParaRPr lang="en-US" sz="1400" dirty="0"/>
+          </a:p>
+        </p:txBody>
+      </p:sp>
+      <p:sp>
+        <p:nvSpPr>
+          <p:cNvPr id="30" name="Text 28"/>
           <p:cNvSpPr txBox="1"/>
           <p:nvPr/>
         </p:nvSpPr>
         <p:spPr>
           <a:xfrm>
-            <a:off x="640080" y="4206240"/>
-            <a:ext cx="3246120" cy="1280160"/>
+            <a:off x="10259568" y="3063240"/>
+            <a:ext cx="1325880" cy="1874520"/>
           </a:xfrm>
           <a:prstGeom prst="rect">
             <a:avLst/>
@@ -5313,79 +5367,27 @@
               <a:buNone/>
             </a:pPr>
             <a:r>
-              <a:rPr lang="en-US" sz="1300" dirty="0">
+              <a:rPr lang="en-US" sz="1200" dirty="0">
                 <a:solidFill>
                   <a:schemeClr val="tx1"/>
                 </a:solidFill>
               </a:rPr>
-              <a:t>Seuils et listes signés par la conformité ou la finance.</a:t>
-            </a:r>
-            <a:endParaRPr lang="en-US" sz="1300" dirty="0"/>
-          </a:p>
-        </p:txBody>
-      </p:sp>
-      <p:sp>
-        <p:nvSpPr>
-          <p:cNvPr id="19" name="dod4"/>
-          <p:cNvSpPr/>
-          <p:nvPr/>
-        </p:nvSpPr>
-        <p:spPr>
-          <a:xfrm>
-            <a:off x="4251960" y="3566160"/>
-            <a:ext cx="3566160" cy="2011680"/>
-          </a:xfrm>
-          <a:prstGeom prst="roundRect">
-            <a:avLst>
-              <a:gd name="adj" fmla="val 3636"/>
-            </a:avLst>
-          </a:prstGeom>
-          <a:solidFill>
-            <a:schemeClr val="bg2"/>
-          </a:solidFill>
-          <a:ln w="9525">
-            <a:solidFill>
-              <a:schemeClr val="bg2"/>
-            </a:solidFill>
-            <a:prstDash val="solid"/>
-          </a:ln>
-        </p:spPr>
-      </p:sp>
-      <p:sp>
-        <p:nvSpPr>
-          <p:cNvPr id="20" name="dod4-dot"/>
-          <p:cNvSpPr/>
-          <p:nvPr/>
-        </p:nvSpPr>
-        <p:spPr>
-          <a:xfrm>
-            <a:off x="4453128" y="3785616"/>
-            <a:ext cx="274320" cy="274320"/>
-          </a:xfrm>
-          <a:prstGeom prst="ellipse">
-            <a:avLst/>
-          </a:prstGeom>
-          <a:solidFill>
-            <a:schemeClr val="accent4"/>
-          </a:solidFill>
-          <a:ln w="12700">
-            <a:solidFill>
-              <a:schemeClr val="accent4"/>
-            </a:solidFill>
-            <a:prstDash val="solid"/>
-          </a:ln>
-        </p:spPr>
-      </p:sp>
-      <p:sp>
-        <p:nvSpPr>
-          <p:cNvPr id="21" name="Text 19"/>
+              <a:t>Grand livre, rapprochement quotidien, reversements</a:t>
+            </a:r>
+            <a:endParaRPr lang="en-US" sz="1200" dirty="0"/>
+          </a:p>
+        </p:txBody>
+      </p:sp>
+      <p:sp>
+        <p:nvSpPr>
+          <p:cNvPr id="31" name="Text 29"/>
           <p:cNvSpPr txBox="1"/>
           <p:nvPr/>
         </p:nvSpPr>
         <p:spPr>
           <a:xfrm>
-            <a:off x="4846320" y="3675888"/>
-            <a:ext cx="2834640" cy="457200"/>
+            <a:off x="457200" y="5303520"/>
+            <a:ext cx="11247120" cy="548640"/>
           </a:xfrm>
           <a:prstGeom prst="rect">
             <a:avLst/>
@@ -5394,181 +5396,21 @@
           <a:ln/>
         </p:spPr>
         <p:txBody>
-          <a:bodyPr wrap="square" lIns="1016" tIns="1016" rIns="1016" bIns="1016" rtlCol="0" anchor="ctr"/>
+          <a:bodyPr wrap="square" lIns="0" tIns="0" rIns="0" bIns="0" rtlCol="0" anchor="t"/>
           <a:lstStyle/>
           <a:p>
             <a:pPr algn="l" indent="0" marL="0">
               <a:buNone/>
             </a:pPr>
             <a:r>
-              <a:rPr lang="en-US" sz="1600" b="1" dirty="0">
-                <a:solidFill>
-                  <a:schemeClr val="tx1"/>
-                </a:solidFill>
-              </a:rPr>
-              <a:t>Journal complet</a:t>
-            </a:r>
-            <a:endParaRPr lang="en-US" sz="1600" dirty="0"/>
-          </a:p>
-        </p:txBody>
-      </p:sp>
-      <p:sp>
-        <p:nvSpPr>
-          <p:cNvPr id="22" name="Text 20"/>
-          <p:cNvSpPr txBox="1"/>
-          <p:nvPr/>
-        </p:nvSpPr>
-        <p:spPr>
-          <a:xfrm>
-            <a:off x="4434840" y="4206240"/>
-            <a:ext cx="3246120" cy="1280160"/>
-          </a:xfrm>
-          <a:prstGeom prst="rect">
-            <a:avLst/>
-          </a:prstGeom>
-          <a:noFill/>
-          <a:ln/>
-        </p:spPr>
-        <p:txBody>
-          <a:bodyPr wrap="square" lIns="1016" tIns="1016" rIns="1016" bIns="1016" rtlCol="0" anchor="t"/>
-          <a:lstStyle/>
-          <a:p>
-            <a:pPr algn="l" indent="0" marL="0">
-              <a:buNone/>
-            </a:pPr>
-            <a:r>
-              <a:rPr lang="en-US" sz="1300" dirty="0">
-                <a:solidFill>
-                  <a:schemeClr val="tx1"/>
-                </a:solidFill>
-              </a:rPr>
-              <a:t>Chaque action du module apparaît dans le journal d'audit.</a:t>
-            </a:r>
-            <a:endParaRPr lang="en-US" sz="1300" dirty="0"/>
-          </a:p>
-        </p:txBody>
-      </p:sp>
-      <p:sp>
-        <p:nvSpPr>
-          <p:cNvPr id="23" name="dod5"/>
-          <p:cNvSpPr/>
-          <p:nvPr/>
-        </p:nvSpPr>
-        <p:spPr>
-          <a:xfrm>
-            <a:off x="8046720" y="3566160"/>
-            <a:ext cx="3566160" cy="2011680"/>
-          </a:xfrm>
-          <a:prstGeom prst="roundRect">
-            <a:avLst>
-              <a:gd name="adj" fmla="val 3636"/>
-            </a:avLst>
-          </a:prstGeom>
-          <a:solidFill>
-            <a:schemeClr val="bg2"/>
-          </a:solidFill>
-          <a:ln w="9525">
-            <a:solidFill>
-              <a:schemeClr val="bg2"/>
-            </a:solidFill>
-            <a:prstDash val="solid"/>
-          </a:ln>
-        </p:spPr>
-      </p:sp>
-      <p:sp>
-        <p:nvSpPr>
-          <p:cNvPr id="24" name="dod5-dot"/>
-          <p:cNvSpPr/>
-          <p:nvPr/>
-        </p:nvSpPr>
-        <p:spPr>
-          <a:xfrm>
-            <a:off x="8247888" y="3785616"/>
-            <a:ext cx="274320" cy="274320"/>
-          </a:xfrm>
-          <a:prstGeom prst="ellipse">
-            <a:avLst/>
-          </a:prstGeom>
-          <a:solidFill>
-            <a:schemeClr val="accent4"/>
-          </a:solidFill>
-          <a:ln w="12700">
-            <a:solidFill>
-              <a:schemeClr val="accent4"/>
-            </a:solidFill>
-            <a:prstDash val="solid"/>
-          </a:ln>
-        </p:spPr>
-      </p:sp>
-      <p:sp>
-        <p:nvSpPr>
-          <p:cNvPr id="25" name="Text 23"/>
-          <p:cNvSpPr txBox="1"/>
-          <p:nvPr/>
-        </p:nvSpPr>
-        <p:spPr>
-          <a:xfrm>
-            <a:off x="8641080" y="3675888"/>
-            <a:ext cx="2834640" cy="457200"/>
-          </a:xfrm>
-          <a:prstGeom prst="rect">
-            <a:avLst/>
-          </a:prstGeom>
-          <a:noFill/>
-          <a:ln/>
-        </p:spPr>
-        <p:txBody>
-          <a:bodyPr wrap="square" lIns="1016" tIns="1016" rIns="1016" bIns="1016" rtlCol="0" anchor="ctr"/>
-          <a:lstStyle/>
-          <a:p>
-            <a:pPr algn="l" indent="0" marL="0">
-              <a:buNone/>
-            </a:pPr>
-            <a:r>
-              <a:rPr lang="en-US" sz="1600" b="1" dirty="0">
-                <a:solidFill>
-                  <a:schemeClr val="tx1"/>
-                </a:solidFill>
-              </a:rPr>
-              <a:t>Documentation</a:t>
-            </a:r>
-            <a:endParaRPr lang="en-US" sz="1600" dirty="0"/>
-          </a:p>
-        </p:txBody>
-      </p:sp>
-      <p:sp>
-        <p:nvSpPr>
-          <p:cNvPr id="26" name="Text 24"/>
-          <p:cNvSpPr txBox="1"/>
-          <p:nvPr/>
-        </p:nvSpPr>
-        <p:spPr>
-          <a:xfrm>
-            <a:off x="8229600" y="4206240"/>
-            <a:ext cx="3246120" cy="1280160"/>
-          </a:xfrm>
-          <a:prstGeom prst="rect">
-            <a:avLst/>
-          </a:prstGeom>
-          <a:noFill/>
-          <a:ln/>
-        </p:spPr>
-        <p:txBody>
-          <a:bodyPr wrap="square" lIns="1016" tIns="1016" rIns="1016" bIns="1016" rtlCol="0" anchor="t"/>
-          <a:lstStyle/>
-          <a:p>
-            <a:pPr algn="l" indent="0" marL="0">
-              <a:buNone/>
-            </a:pPr>
-            <a:r>
-              <a:rPr lang="en-US" sz="1300" dirty="0">
-                <a:solidFill>
-                  <a:schemeClr val="tx1"/>
-                </a:solidFill>
-              </a:rPr>
-              <a:t>Spec à jour, paramètres décrits, procédure d'exploitation.</a:t>
-            </a:r>
-            <a:endParaRPr lang="en-US" sz="1300" dirty="0"/>
+              <a:rPr lang="en-US" sz="1400" i="1" dirty="0">
+                <a:solidFill>
+                  <a:schemeClr val="tx2"/>
+                </a:solidFill>
+              </a:rPr>
+              <a:t>Chaque palier se termine quand ses tests de recette passent sur données réelles. Pas de dates tant que le palier 0 n'est pas tranché.</a:t>
+            </a:r>
+            <a:endParaRPr lang="en-US" sz="1400" dirty="0"/>
           </a:p>
         </p:txBody>
       </p:sp>
@@ -5674,6 +5516,858 @@
                   <a:schemeClr val="tx1"/>
                 </a:solidFill>
               </a:rPr>
+              <a:t>Définition de « terminé »</a:t>
+            </a:r>
+            <a:endParaRPr lang="en-US" sz="3000" dirty="0"/>
+          </a:p>
+        </p:txBody>
+      </p:sp>
+      <p:sp>
+        <p:nvSpPr>
+          <p:cNvPr id="3" name="dod0"/>
+          <p:cNvSpPr/>
+          <p:nvPr/>
+        </p:nvSpPr>
+        <p:spPr>
+          <a:xfrm>
+            <a:off x="457200" y="1325880"/>
+            <a:ext cx="3566160" cy="2011680"/>
+          </a:xfrm>
+          <a:prstGeom prst="roundRect">
+            <a:avLst>
+              <a:gd name="adj" fmla="val 3636"/>
+            </a:avLst>
+          </a:prstGeom>
+          <a:solidFill>
+            <a:schemeClr val="bg2"/>
+          </a:solidFill>
+          <a:ln w="9525">
+            <a:solidFill>
+              <a:schemeClr val="bg2"/>
+            </a:solidFill>
+            <a:prstDash val="solid"/>
+          </a:ln>
+        </p:spPr>
+      </p:sp>
+      <p:sp>
+        <p:nvSpPr>
+          <p:cNvPr id="4" name="dod0-dot"/>
+          <p:cNvSpPr/>
+          <p:nvPr/>
+        </p:nvSpPr>
+        <p:spPr>
+          <a:xfrm>
+            <a:off x="658368" y="1545336"/>
+            <a:ext cx="274320" cy="274320"/>
+          </a:xfrm>
+          <a:prstGeom prst="ellipse">
+            <a:avLst/>
+          </a:prstGeom>
+          <a:solidFill>
+            <a:schemeClr val="accent4"/>
+          </a:solidFill>
+          <a:ln w="12700">
+            <a:solidFill>
+              <a:schemeClr val="accent4"/>
+            </a:solidFill>
+            <a:prstDash val="solid"/>
+          </a:ln>
+        </p:spPr>
+      </p:sp>
+      <p:sp>
+        <p:nvSpPr>
+          <p:cNvPr id="5" name="Text 3"/>
+          <p:cNvSpPr txBox="1"/>
+          <p:nvPr/>
+        </p:nvSpPr>
+        <p:spPr>
+          <a:xfrm>
+            <a:off x="1051560" y="1435608"/>
+            <a:ext cx="2834640" cy="457200"/>
+          </a:xfrm>
+          <a:prstGeom prst="rect">
+            <a:avLst/>
+          </a:prstGeom>
+          <a:noFill/>
+          <a:ln/>
+        </p:spPr>
+        <p:txBody>
+          <a:bodyPr wrap="square" lIns="1016" tIns="1016" rIns="1016" bIns="1016" rtlCol="0" anchor="ctr"/>
+          <a:lstStyle/>
+          <a:p>
+            <a:pPr algn="l" indent="0" marL="0">
+              <a:buNone/>
+            </a:pPr>
+            <a:r>
+              <a:rPr lang="en-US" sz="1600" b="1" dirty="0">
+                <a:solidFill>
+                  <a:schemeClr val="tx1"/>
+                </a:solidFill>
+              </a:rPr>
+              <a:t>Tests de recette</a:t>
+            </a:r>
+            <a:endParaRPr lang="en-US" sz="1600" dirty="0"/>
+          </a:p>
+        </p:txBody>
+      </p:sp>
+      <p:sp>
+        <p:nvSpPr>
+          <p:cNvPr id="6" name="Text 4"/>
+          <p:cNvSpPr txBox="1"/>
+          <p:nvPr/>
+        </p:nvSpPr>
+        <p:spPr>
+          <a:xfrm>
+            <a:off x="640080" y="1965960"/>
+            <a:ext cx="3246120" cy="1280160"/>
+          </a:xfrm>
+          <a:prstGeom prst="rect">
+            <a:avLst/>
+          </a:prstGeom>
+          <a:noFill/>
+          <a:ln/>
+        </p:spPr>
+        <p:txBody>
+          <a:bodyPr wrap="square" lIns="1016" tIns="1016" rIns="1016" bIns="1016" rtlCol="0" anchor="t"/>
+          <a:lstStyle/>
+          <a:p>
+            <a:pPr algn="l" indent="0" marL="0">
+              <a:buNone/>
+            </a:pPr>
+            <a:r>
+              <a:rPr lang="en-US" sz="1300" dirty="0">
+                <a:solidFill>
+                  <a:schemeClr val="tx1"/>
+                </a:solidFill>
+              </a:rPr>
+              <a:t>Les tests de la spec et les scénarios des suites de référence passent, automatisés.</a:t>
+            </a:r>
+            <a:endParaRPr lang="en-US" sz="1300" dirty="0"/>
+          </a:p>
+        </p:txBody>
+      </p:sp>
+      <p:sp>
+        <p:nvSpPr>
+          <p:cNvPr id="7" name="dod1"/>
+          <p:cNvSpPr/>
+          <p:nvPr/>
+        </p:nvSpPr>
+        <p:spPr>
+          <a:xfrm>
+            <a:off x="4251960" y="1325880"/>
+            <a:ext cx="3566160" cy="2011680"/>
+          </a:xfrm>
+          <a:prstGeom prst="roundRect">
+            <a:avLst>
+              <a:gd name="adj" fmla="val 3636"/>
+            </a:avLst>
+          </a:prstGeom>
+          <a:solidFill>
+            <a:schemeClr val="bg2"/>
+          </a:solidFill>
+          <a:ln w="9525">
+            <a:solidFill>
+              <a:schemeClr val="bg2"/>
+            </a:solidFill>
+            <a:prstDash val="solid"/>
+          </a:ln>
+        </p:spPr>
+      </p:sp>
+      <p:sp>
+        <p:nvSpPr>
+          <p:cNvPr id="8" name="dod1-dot"/>
+          <p:cNvSpPr/>
+          <p:nvPr/>
+        </p:nvSpPr>
+        <p:spPr>
+          <a:xfrm>
+            <a:off x="4453128" y="1545336"/>
+            <a:ext cx="274320" cy="274320"/>
+          </a:xfrm>
+          <a:prstGeom prst="ellipse">
+            <a:avLst/>
+          </a:prstGeom>
+          <a:solidFill>
+            <a:schemeClr val="accent4"/>
+          </a:solidFill>
+          <a:ln w="12700">
+            <a:solidFill>
+              <a:schemeClr val="accent4"/>
+            </a:solidFill>
+            <a:prstDash val="solid"/>
+          </a:ln>
+        </p:spPr>
+      </p:sp>
+      <p:sp>
+        <p:nvSpPr>
+          <p:cNvPr id="9" name="Text 7"/>
+          <p:cNvSpPr txBox="1"/>
+          <p:nvPr/>
+        </p:nvSpPr>
+        <p:spPr>
+          <a:xfrm>
+            <a:off x="4846320" y="1435608"/>
+            <a:ext cx="2834640" cy="457200"/>
+          </a:xfrm>
+          <a:prstGeom prst="rect">
+            <a:avLst/>
+          </a:prstGeom>
+          <a:noFill/>
+          <a:ln/>
+        </p:spPr>
+        <p:txBody>
+          <a:bodyPr wrap="square" lIns="1016" tIns="1016" rIns="1016" bIns="1016" rtlCol="0" anchor="ctr"/>
+          <a:lstStyle/>
+          <a:p>
+            <a:pPr algn="l" indent="0" marL="0">
+              <a:buNone/>
+            </a:pPr>
+            <a:r>
+              <a:rPr lang="en-US" sz="1600" b="1" dirty="0">
+                <a:solidFill>
+                  <a:schemeClr val="tx1"/>
+                </a:solidFill>
+              </a:rPr>
+              <a:t>Données réelles</a:t>
+            </a:r>
+            <a:endParaRPr lang="en-US" sz="1600" dirty="0"/>
+          </a:p>
+        </p:txBody>
+      </p:sp>
+      <p:sp>
+        <p:nvSpPr>
+          <p:cNvPr id="10" name="Text 8"/>
+          <p:cNvSpPr txBox="1"/>
+          <p:nvPr/>
+        </p:nvSpPr>
+        <p:spPr>
+          <a:xfrm>
+            <a:off x="4434840" y="1965960"/>
+            <a:ext cx="3246120" cy="1280160"/>
+          </a:xfrm>
+          <a:prstGeom prst="rect">
+            <a:avLst/>
+          </a:prstGeom>
+          <a:noFill/>
+          <a:ln/>
+        </p:spPr>
+        <p:txBody>
+          <a:bodyPr wrap="square" lIns="1016" tIns="1016" rIns="1016" bIns="1016" rtlCol="0" anchor="t"/>
+          <a:lstStyle/>
+          <a:p>
+            <a:pPr algn="l" indent="0" marL="0">
+              <a:buNone/>
+            </a:pPr>
+            <a:r>
+              <a:rPr lang="en-US" sz="1300" dirty="0">
+                <a:solidFill>
+                  <a:schemeClr val="tx1"/>
+                </a:solidFill>
+              </a:rPr>
+              <a:t>Résultat comparé au processus actuel sur au moins un mois.</a:t>
+            </a:r>
+            <a:endParaRPr lang="en-US" sz="1300" dirty="0"/>
+          </a:p>
+        </p:txBody>
+      </p:sp>
+      <p:sp>
+        <p:nvSpPr>
+          <p:cNvPr id="11" name="dod2"/>
+          <p:cNvSpPr/>
+          <p:nvPr/>
+        </p:nvSpPr>
+        <p:spPr>
+          <a:xfrm>
+            <a:off x="8046720" y="1325880"/>
+            <a:ext cx="3566160" cy="2011680"/>
+          </a:xfrm>
+          <a:prstGeom prst="roundRect">
+            <a:avLst>
+              <a:gd name="adj" fmla="val 3636"/>
+            </a:avLst>
+          </a:prstGeom>
+          <a:solidFill>
+            <a:schemeClr val="bg2"/>
+          </a:solidFill>
+          <a:ln w="9525">
+            <a:solidFill>
+              <a:schemeClr val="bg2"/>
+            </a:solidFill>
+            <a:prstDash val="solid"/>
+          </a:ln>
+        </p:spPr>
+      </p:sp>
+      <p:sp>
+        <p:nvSpPr>
+          <p:cNvPr id="12" name="dod2-dot"/>
+          <p:cNvSpPr/>
+          <p:nvPr/>
+        </p:nvSpPr>
+        <p:spPr>
+          <a:xfrm>
+            <a:off x="8247888" y="1545336"/>
+            <a:ext cx="274320" cy="274320"/>
+          </a:xfrm>
+          <a:prstGeom prst="ellipse">
+            <a:avLst/>
+          </a:prstGeom>
+          <a:solidFill>
+            <a:schemeClr val="accent4"/>
+          </a:solidFill>
+          <a:ln w="12700">
+            <a:solidFill>
+              <a:schemeClr val="accent4"/>
+            </a:solidFill>
+            <a:prstDash val="solid"/>
+          </a:ln>
+        </p:spPr>
+      </p:sp>
+      <p:sp>
+        <p:nvSpPr>
+          <p:cNvPr id="13" name="Text 11"/>
+          <p:cNvSpPr txBox="1"/>
+          <p:nvPr/>
+        </p:nvSpPr>
+        <p:spPr>
+          <a:xfrm>
+            <a:off x="8641080" y="1435608"/>
+            <a:ext cx="2834640" cy="457200"/>
+          </a:xfrm>
+          <a:prstGeom prst="rect">
+            <a:avLst/>
+          </a:prstGeom>
+          <a:noFill/>
+          <a:ln/>
+        </p:spPr>
+        <p:txBody>
+          <a:bodyPr wrap="square" lIns="1016" tIns="1016" rIns="1016" bIns="1016" rtlCol="0" anchor="ctr"/>
+          <a:lstStyle/>
+          <a:p>
+            <a:pPr algn="l" indent="0" marL="0">
+              <a:buNone/>
+            </a:pPr>
+            <a:r>
+              <a:rPr lang="en-US" sz="1600" b="1" dirty="0">
+                <a:solidFill>
+                  <a:schemeClr val="tx1"/>
+                </a:solidFill>
+              </a:rPr>
+              <a:t>Revue de sécurité</a:t>
+            </a:r>
+            <a:endParaRPr lang="en-US" sz="1600" dirty="0"/>
+          </a:p>
+        </p:txBody>
+      </p:sp>
+      <p:sp>
+        <p:nvSpPr>
+          <p:cNvPr id="14" name="Text 12"/>
+          <p:cNvSpPr txBox="1"/>
+          <p:nvPr/>
+        </p:nvSpPr>
+        <p:spPr>
+          <a:xfrm>
+            <a:off x="8229600" y="1965960"/>
+            <a:ext cx="3246120" cy="1280160"/>
+          </a:xfrm>
+          <a:prstGeom prst="rect">
+            <a:avLst/>
+          </a:prstGeom>
+          <a:noFill/>
+          <a:ln/>
+        </p:spPr>
+        <p:txBody>
+          <a:bodyPr wrap="square" lIns="1016" tIns="1016" rIns="1016" bIns="1016" rtlCol="0" anchor="t"/>
+          <a:lstStyle/>
+          <a:p>
+            <a:pPr algn="l" indent="0" marL="0">
+              <a:buNone/>
+            </a:pPr>
+            <a:r>
+              <a:rPr lang="en-US" sz="1300" dirty="0">
+                <a:solidFill>
+                  <a:schemeClr val="tx1"/>
+                </a:solidFill>
+              </a:rPr>
+              <a:t>Accès, double regard, données sensibles, fichiers : vérifiés par un pair.</a:t>
+            </a:r>
+            <a:endParaRPr lang="en-US" sz="1300" dirty="0"/>
+          </a:p>
+        </p:txBody>
+      </p:sp>
+      <p:sp>
+        <p:nvSpPr>
+          <p:cNvPr id="15" name="dod3"/>
+          <p:cNvSpPr/>
+          <p:nvPr/>
+        </p:nvSpPr>
+        <p:spPr>
+          <a:xfrm>
+            <a:off x="457200" y="3566160"/>
+            <a:ext cx="3566160" cy="2011680"/>
+          </a:xfrm>
+          <a:prstGeom prst="roundRect">
+            <a:avLst>
+              <a:gd name="adj" fmla="val 3636"/>
+            </a:avLst>
+          </a:prstGeom>
+          <a:solidFill>
+            <a:schemeClr val="bg2"/>
+          </a:solidFill>
+          <a:ln w="9525">
+            <a:solidFill>
+              <a:schemeClr val="bg2"/>
+            </a:solidFill>
+            <a:prstDash val="solid"/>
+          </a:ln>
+        </p:spPr>
+      </p:sp>
+      <p:sp>
+        <p:nvSpPr>
+          <p:cNvPr id="16" name="dod3-dot"/>
+          <p:cNvSpPr/>
+          <p:nvPr/>
+        </p:nvSpPr>
+        <p:spPr>
+          <a:xfrm>
+            <a:off x="658368" y="3785616"/>
+            <a:ext cx="274320" cy="274320"/>
+          </a:xfrm>
+          <a:prstGeom prst="ellipse">
+            <a:avLst/>
+          </a:prstGeom>
+          <a:solidFill>
+            <a:schemeClr val="accent4"/>
+          </a:solidFill>
+          <a:ln w="12700">
+            <a:solidFill>
+              <a:schemeClr val="accent4"/>
+            </a:solidFill>
+            <a:prstDash val="solid"/>
+          </a:ln>
+        </p:spPr>
+      </p:sp>
+      <p:sp>
+        <p:nvSpPr>
+          <p:cNvPr id="17" name="Text 15"/>
+          <p:cNvSpPr txBox="1"/>
+          <p:nvPr/>
+        </p:nvSpPr>
+        <p:spPr>
+          <a:xfrm>
+            <a:off x="1051560" y="3675888"/>
+            <a:ext cx="2834640" cy="457200"/>
+          </a:xfrm>
+          <a:prstGeom prst="rect">
+            <a:avLst/>
+          </a:prstGeom>
+          <a:noFill/>
+          <a:ln/>
+        </p:spPr>
+        <p:txBody>
+          <a:bodyPr wrap="square" lIns="1016" tIns="1016" rIns="1016" bIns="1016" rtlCol="0" anchor="ctr"/>
+          <a:lstStyle/>
+          <a:p>
+            <a:pPr algn="l" indent="0" marL="0">
+              <a:buNone/>
+            </a:pPr>
+            <a:r>
+              <a:rPr lang="en-US" sz="1600" b="1" dirty="0">
+                <a:solidFill>
+                  <a:schemeClr val="tx1"/>
+                </a:solidFill>
+              </a:rPr>
+              <a:t>Configuration validée</a:t>
+            </a:r>
+            <a:endParaRPr lang="en-US" sz="1600" dirty="0"/>
+          </a:p>
+        </p:txBody>
+      </p:sp>
+      <p:sp>
+        <p:nvSpPr>
+          <p:cNvPr id="18" name="Text 16"/>
+          <p:cNvSpPr txBox="1"/>
+          <p:nvPr/>
+        </p:nvSpPr>
+        <p:spPr>
+          <a:xfrm>
+            <a:off x="640080" y="4206240"/>
+            <a:ext cx="3246120" cy="1280160"/>
+          </a:xfrm>
+          <a:prstGeom prst="rect">
+            <a:avLst/>
+          </a:prstGeom>
+          <a:noFill/>
+          <a:ln/>
+        </p:spPr>
+        <p:txBody>
+          <a:bodyPr wrap="square" lIns="1016" tIns="1016" rIns="1016" bIns="1016" rtlCol="0" anchor="t"/>
+          <a:lstStyle/>
+          <a:p>
+            <a:pPr algn="l" indent="0" marL="0">
+              <a:buNone/>
+            </a:pPr>
+            <a:r>
+              <a:rPr lang="en-US" sz="1300" dirty="0">
+                <a:solidFill>
+                  <a:schemeClr val="tx1"/>
+                </a:solidFill>
+              </a:rPr>
+              <a:t>Seuils et listes signés par la conformité ou la finance.</a:t>
+            </a:r>
+            <a:endParaRPr lang="en-US" sz="1300" dirty="0"/>
+          </a:p>
+        </p:txBody>
+      </p:sp>
+      <p:sp>
+        <p:nvSpPr>
+          <p:cNvPr id="19" name="dod4"/>
+          <p:cNvSpPr/>
+          <p:nvPr/>
+        </p:nvSpPr>
+        <p:spPr>
+          <a:xfrm>
+            <a:off x="4251960" y="3566160"/>
+            <a:ext cx="3566160" cy="2011680"/>
+          </a:xfrm>
+          <a:prstGeom prst="roundRect">
+            <a:avLst>
+              <a:gd name="adj" fmla="val 3636"/>
+            </a:avLst>
+          </a:prstGeom>
+          <a:solidFill>
+            <a:schemeClr val="bg2"/>
+          </a:solidFill>
+          <a:ln w="9525">
+            <a:solidFill>
+              <a:schemeClr val="bg2"/>
+            </a:solidFill>
+            <a:prstDash val="solid"/>
+          </a:ln>
+        </p:spPr>
+      </p:sp>
+      <p:sp>
+        <p:nvSpPr>
+          <p:cNvPr id="20" name="dod4-dot"/>
+          <p:cNvSpPr/>
+          <p:nvPr/>
+        </p:nvSpPr>
+        <p:spPr>
+          <a:xfrm>
+            <a:off x="4453128" y="3785616"/>
+            <a:ext cx="274320" cy="274320"/>
+          </a:xfrm>
+          <a:prstGeom prst="ellipse">
+            <a:avLst/>
+          </a:prstGeom>
+          <a:solidFill>
+            <a:schemeClr val="accent4"/>
+          </a:solidFill>
+          <a:ln w="12700">
+            <a:solidFill>
+              <a:schemeClr val="accent4"/>
+            </a:solidFill>
+            <a:prstDash val="solid"/>
+          </a:ln>
+        </p:spPr>
+      </p:sp>
+      <p:sp>
+        <p:nvSpPr>
+          <p:cNvPr id="21" name="Text 19"/>
+          <p:cNvSpPr txBox="1"/>
+          <p:nvPr/>
+        </p:nvSpPr>
+        <p:spPr>
+          <a:xfrm>
+            <a:off x="4846320" y="3675888"/>
+            <a:ext cx="2834640" cy="457200"/>
+          </a:xfrm>
+          <a:prstGeom prst="rect">
+            <a:avLst/>
+          </a:prstGeom>
+          <a:noFill/>
+          <a:ln/>
+        </p:spPr>
+        <p:txBody>
+          <a:bodyPr wrap="square" lIns="1016" tIns="1016" rIns="1016" bIns="1016" rtlCol="0" anchor="ctr"/>
+          <a:lstStyle/>
+          <a:p>
+            <a:pPr algn="l" indent="0" marL="0">
+              <a:buNone/>
+            </a:pPr>
+            <a:r>
+              <a:rPr lang="en-US" sz="1600" b="1" dirty="0">
+                <a:solidFill>
+                  <a:schemeClr val="tx1"/>
+                </a:solidFill>
+              </a:rPr>
+              <a:t>Journal complet</a:t>
+            </a:r>
+            <a:endParaRPr lang="en-US" sz="1600" dirty="0"/>
+          </a:p>
+        </p:txBody>
+      </p:sp>
+      <p:sp>
+        <p:nvSpPr>
+          <p:cNvPr id="22" name="Text 20"/>
+          <p:cNvSpPr txBox="1"/>
+          <p:nvPr/>
+        </p:nvSpPr>
+        <p:spPr>
+          <a:xfrm>
+            <a:off x="4434840" y="4206240"/>
+            <a:ext cx="3246120" cy="1280160"/>
+          </a:xfrm>
+          <a:prstGeom prst="rect">
+            <a:avLst/>
+          </a:prstGeom>
+          <a:noFill/>
+          <a:ln/>
+        </p:spPr>
+        <p:txBody>
+          <a:bodyPr wrap="square" lIns="1016" tIns="1016" rIns="1016" bIns="1016" rtlCol="0" anchor="t"/>
+          <a:lstStyle/>
+          <a:p>
+            <a:pPr algn="l" indent="0" marL="0">
+              <a:buNone/>
+            </a:pPr>
+            <a:r>
+              <a:rPr lang="en-US" sz="1300" dirty="0">
+                <a:solidFill>
+                  <a:schemeClr val="tx1"/>
+                </a:solidFill>
+              </a:rPr>
+              <a:t>Chaque action du module apparaît dans le journal d'audit.</a:t>
+            </a:r>
+            <a:endParaRPr lang="en-US" sz="1300" dirty="0"/>
+          </a:p>
+        </p:txBody>
+      </p:sp>
+      <p:sp>
+        <p:nvSpPr>
+          <p:cNvPr id="23" name="dod5"/>
+          <p:cNvSpPr/>
+          <p:nvPr/>
+        </p:nvSpPr>
+        <p:spPr>
+          <a:xfrm>
+            <a:off x="8046720" y="3566160"/>
+            <a:ext cx="3566160" cy="2011680"/>
+          </a:xfrm>
+          <a:prstGeom prst="roundRect">
+            <a:avLst>
+              <a:gd name="adj" fmla="val 3636"/>
+            </a:avLst>
+          </a:prstGeom>
+          <a:solidFill>
+            <a:schemeClr val="bg2"/>
+          </a:solidFill>
+          <a:ln w="9525">
+            <a:solidFill>
+              <a:schemeClr val="bg2"/>
+            </a:solidFill>
+            <a:prstDash val="solid"/>
+          </a:ln>
+        </p:spPr>
+      </p:sp>
+      <p:sp>
+        <p:nvSpPr>
+          <p:cNvPr id="24" name="dod5-dot"/>
+          <p:cNvSpPr/>
+          <p:nvPr/>
+        </p:nvSpPr>
+        <p:spPr>
+          <a:xfrm>
+            <a:off x="8247888" y="3785616"/>
+            <a:ext cx="274320" cy="274320"/>
+          </a:xfrm>
+          <a:prstGeom prst="ellipse">
+            <a:avLst/>
+          </a:prstGeom>
+          <a:solidFill>
+            <a:schemeClr val="accent4"/>
+          </a:solidFill>
+          <a:ln w="12700">
+            <a:solidFill>
+              <a:schemeClr val="accent4"/>
+            </a:solidFill>
+            <a:prstDash val="solid"/>
+          </a:ln>
+        </p:spPr>
+      </p:sp>
+      <p:sp>
+        <p:nvSpPr>
+          <p:cNvPr id="25" name="Text 23"/>
+          <p:cNvSpPr txBox="1"/>
+          <p:nvPr/>
+        </p:nvSpPr>
+        <p:spPr>
+          <a:xfrm>
+            <a:off x="8641080" y="3675888"/>
+            <a:ext cx="2834640" cy="457200"/>
+          </a:xfrm>
+          <a:prstGeom prst="rect">
+            <a:avLst/>
+          </a:prstGeom>
+          <a:noFill/>
+          <a:ln/>
+        </p:spPr>
+        <p:txBody>
+          <a:bodyPr wrap="square" lIns="1016" tIns="1016" rIns="1016" bIns="1016" rtlCol="0" anchor="ctr"/>
+          <a:lstStyle/>
+          <a:p>
+            <a:pPr algn="l" indent="0" marL="0">
+              <a:buNone/>
+            </a:pPr>
+            <a:r>
+              <a:rPr lang="en-US" sz="1600" b="1" dirty="0">
+                <a:solidFill>
+                  <a:schemeClr val="tx1"/>
+                </a:solidFill>
+              </a:rPr>
+              <a:t>Documentation</a:t>
+            </a:r>
+            <a:endParaRPr lang="en-US" sz="1600" dirty="0"/>
+          </a:p>
+        </p:txBody>
+      </p:sp>
+      <p:sp>
+        <p:nvSpPr>
+          <p:cNvPr id="26" name="Text 24"/>
+          <p:cNvSpPr txBox="1"/>
+          <p:nvPr/>
+        </p:nvSpPr>
+        <p:spPr>
+          <a:xfrm>
+            <a:off x="8229600" y="4206240"/>
+            <a:ext cx="3246120" cy="1280160"/>
+          </a:xfrm>
+          <a:prstGeom prst="rect">
+            <a:avLst/>
+          </a:prstGeom>
+          <a:noFill/>
+          <a:ln/>
+        </p:spPr>
+        <p:txBody>
+          <a:bodyPr wrap="square" lIns="1016" tIns="1016" rIns="1016" bIns="1016" rtlCol="0" anchor="t"/>
+          <a:lstStyle/>
+          <a:p>
+            <a:pPr algn="l" indent="0" marL="0">
+              <a:buNone/>
+            </a:pPr>
+            <a:r>
+              <a:rPr lang="en-US" sz="1300" dirty="0">
+                <a:solidFill>
+                  <a:schemeClr val="tx1"/>
+                </a:solidFill>
+              </a:rPr>
+              <a:t>Spec à jour, paramètres décrits, procédure d'exploitation.</a:t>
+            </a:r>
+            <a:endParaRPr lang="en-US" sz="1300" dirty="0"/>
+          </a:p>
+        </p:txBody>
+      </p:sp>
+      <p:sp>
+        <p:nvSpPr>
+          <p:cNvPr id="25" name="Slide Number Placeholder 0"/>
+          <p:cNvSpPr>
+            <a:spLocks noGrp="1"/>
+          </p:cNvSpPr>
+          <p:nvPr>
+            <p:ph type="sldNum" sz="quarter" idx="4294967295"/>
+          </p:nvPr>
+        </p:nvSpPr>
+        <p:spPr>
+          <a:xfrm>
+            <a:off x="11247120" y="6400800"/>
+            <a:ext cx="457200" cy="274320"/>
+          </a:xfrm>
+          <a:prstGeom prst="rect">
+            <a:avLst/>
+          </a:prstGeom>
+          <a:extLst>
+            <a:ext uri="{C572A759-6A51-4108-AA02-DFA0A04FC94B}">
+              <ma14:wrappingTextBoxFlag xmlns:ma14="http://schemas.microsoft.com/office/mac/drawingml/2011/main" val="0"/>
+            </a:ext>
+          </a:extLst>
+        </p:spPr>
+        <p:txBody>
+          <a:bodyPr/>
+          <a:lstStyle>
+            <a:lvl1pPr>
+              <a:defRPr sz="1000">
+                <a:solidFill>
+                  <a:schemeClr val="tx2"/>
+                </a:solidFill>
+              </a:defRPr>
+            </a:lvl1pPr>
+          </a:lstStyle>
+          <a:p>
+            <a:pPr algn="r"/>
+            <a:fld id="{F7021451-1387-4CA6-816F-3879F97B5CBC}" type="slidenum">
+              <a:rPr b="0" lang="en-US"/>
+              <a:t>14</a:t>
+            </a:fld>
+            <a:endParaRPr lang="en-US"/>
+          </a:p>
+        </p:txBody>
+      </p:sp>
+    </p:spTree>
+  </p:cSld>
+  <p:clrMapOvr>
+    <a:masterClrMapping/>
+  </p:clrMapOvr>
+</p:sld>
+</file>
+
+<file path=ppt/slides/slide15.xml><?xml version="1.0" encoding="utf-8"?>
+<p:sld xmlns:a="http://schemas.openxmlformats.org/drawingml/2006/main" xmlns:r="http://schemas.openxmlformats.org/officeDocument/2006/relationships" xmlns:p="http://schemas.openxmlformats.org/presentationml/2006/main">
+  <p:cSld name="Slide 15">
+    <p:spTree>
+      <p:nvGrpSpPr>
+        <p:cNvPr id="1" name=""/>
+        <p:cNvGrpSpPr/>
+        <p:nvPr/>
+      </p:nvGrpSpPr>
+      <p:grpSpPr>
+        <a:xfrm>
+          <a:off x="0" y="0"/>
+          <a:ext cx="0" cy="0"/>
+          <a:chOff x="0" y="0"/>
+          <a:chExt cx="0" cy="0"/>
+        </a:xfrm>
+      </p:grpSpPr>
+      <p:sp>
+        <p:nvSpPr>
+          <p:cNvPr id="2" name="Text 0"/>
+          <p:cNvSpPr/>
+          <p:nvPr>
+            <p:ph idx="100" type="title" hasCustomPrompt="1"/>
+          </p:nvPr>
+        </p:nvSpPr>
+        <p:spPr>
+          <a:xfrm>
+            <a:off x="457200" y="320040"/>
+            <a:ext cx="11247120" cy="731520"/>
+          </a:xfrm>
+          <a:prstGeom prst="rect">
+            <a:avLst/>
+          </a:prstGeom>
+          <a:noFill/>
+          <a:ln/>
+        </p:spPr>
+        <p:txBody>
+          <a:bodyPr wrap="square" lIns="0" tIns="0" rIns="0" bIns="0" rtlCol="0" anchor="ctr"/>
+          <a:lstStyle/>
+          <a:p>
+            <a:pPr algn="l" indent="0" marL="0">
+              <a:buNone/>
+            </a:pPr>
+            <a:r>
+              <a:rPr lang="en-US" sz="3000" b="1" dirty="0">
+                <a:solidFill>
+                  <a:schemeClr val="tx1"/>
+                </a:solidFill>
+              </a:rPr>
               <a:t>Ce dont l'équipe dépend</a:t>
             </a:r>
             <a:endParaRPr lang="en-US" sz="3000" dirty="0"/>
@@ -6664,7 +7358,7 @@
             <a:pPr algn="r"/>
             <a:fld id="{F7021451-1387-4CA6-816F-3879F97B5CBC}" type="slidenum">
               <a:rPr b="0" lang="en-US"/>
-              <a:t>14</a:t>
+              <a:t>15</a:t>
             </a:fld>
             <a:endParaRPr lang="en-US"/>
           </a:p>

</xml_diff>